<commit_message>
fix(investor): slide 4 spacing, accent edges, real table on slide 7
- Slide 4: move captions above the phone frames, shrink frames so
  nothing runs off the slide and the chrome row stays clear.
- Replace the separate accent-bar shapes with an add_card_with_left_edge
  helper that draws the accent as a rounded rect behind a slightly inset
  card so the corners share the same radius and the accent reads as part
  of the card itself, not a floating bar.
- Slide 7: rebuild the competition matrix using a real PowerPoint table
  (shapes.add_table) instead of a grid of rectangles + text boxes, so
  it's editable as a table downstream.
</commit_message>
<xml_diff>
--- a/docs/investor/Harpa-Pro-Deck-v2.pptx
+++ b/docs/investor/Harpa-Pro-Deck-v2.pptx
@@ -6659,14 +6659,104 @@
       </p:sp>
       <p:sp>
         <p:nvSpPr>
-          <p:cNvPr id="6" name="Rounded Rectangle 5"/>
+          <p:cNvPr id="6" name="TextBox 5"/>
+          <p:cNvSpPr txBox="1"/>
+          <p:nvPr/>
+        </p:nvSpPr>
+        <p:spPr>
+          <a:xfrm>
+            <a:off x="1798167" y="1828800"/>
+            <a:ext cx="2560320" cy="274320"/>
+          </a:xfrm>
+          <a:prstGeom prst="rect">
+            <a:avLst/>
+          </a:prstGeom>
+          <a:noFill/>
+        </p:spPr>
+        <p:txBody>
+          <a:bodyPr wrap="square" anchor="t" lIns="0" rIns="0" tIns="0" bIns="0">
+            <a:spAutoFit/>
+          </a:bodyPr>
+          <a:lstStyle/>
+          <a:p>
+            <a:pPr algn="l"/>
+            <a:r>
+              <a:rPr sz="1000" b="1" spc="160">
+                <a:solidFill>
+                  <a:srgbClr val="EA580C"/>
+                </a:solidFill>
+                <a:latin typeface="Helvetica Neue"/>
+              </a:rPr>
+              <a:t>NEW REPORT</a:t>
+            </a:r>
+          </a:p>
+        </p:txBody>
+      </p:sp>
+      <p:sp>
+        <p:nvSpPr>
+          <p:cNvPr id="7" name="TextBox 6"/>
+          <p:cNvSpPr txBox="1"/>
+          <p:nvPr/>
+        </p:nvSpPr>
+        <p:spPr>
+          <a:xfrm>
+            <a:off x="1798167" y="2103120"/>
+            <a:ext cx="2560320" cy="640080"/>
+          </a:xfrm>
+          <a:prstGeom prst="rect">
+            <a:avLst/>
+          </a:prstGeom>
+          <a:noFill/>
+        </p:spPr>
+        <p:txBody>
+          <a:bodyPr wrap="square" anchor="t" lIns="0" rIns="0" tIns="0" bIns="0">
+            <a:spAutoFit/>
+          </a:bodyPr>
+          <a:lstStyle/>
+          <a:p>
+            <a:pPr algn="l">
+              <a:lnSpc>
+                <a:spcPct val="130000"/>
+              </a:lnSpc>
+            </a:pPr>
+            <a:r>
+              <a:rPr sz="1200" b="0">
+                <a:solidFill>
+                  <a:srgbClr val="5F5B66"/>
+                </a:solidFill>
+                <a:latin typeface="Helvetica Neue"/>
+              </a:rPr>
+              <a:t>Voice-note list, timestamps,</a:t>
+            </a:r>
+          </a:p>
+          <a:p>
+            <a:pPr algn="l">
+              <a:lnSpc>
+                <a:spcPct val="130000"/>
+              </a:lnSpc>
+            </a:pPr>
+            <a:r>
+              <a:rPr sz="1200" b="0">
+                <a:solidFill>
+                  <a:srgbClr val="5F5B66"/>
+                </a:solidFill>
+                <a:latin typeface="Helvetica Neue"/>
+              </a:rPr>
+              <a:t>Generate-report button</a:t>
+            </a:r>
+          </a:p>
+        </p:txBody>
+      </p:sp>
+      <p:sp>
+        <p:nvSpPr>
+          <p:cNvPr id="8" name="Rounded Rectangle 7"/>
           <p:cNvSpPr/>
           <p:nvPr/>
         </p:nvSpPr>
         <p:spPr>
           <a:xfrm>
-            <a:off x="1798167" y="1828800"/>
-            <a:ext cx="2560320" cy="4160520"/>
+            <a:off x="1798167" y="2788920"/>
+            <a:ext cx="2560320" cy="3383280"/>
           </a:xfrm>
           <a:prstGeom prst="roundRect">
             <a:avLst>
@@ -6707,13 +6797,13 @@
       </p:sp>
       <p:sp>
         <p:nvSpPr>
-          <p:cNvPr id="7" name="Rounded Rectangle 6"/>
+          <p:cNvPr id="9" name="Rounded Rectangle 8"/>
           <p:cNvSpPr/>
           <p:nvPr/>
         </p:nvSpPr>
         <p:spPr>
           <a:xfrm>
-            <a:off x="2026767" y="2057400"/>
+            <a:off x="2026767" y="3017520"/>
             <a:ext cx="2103120" cy="274320"/>
           </a:xfrm>
           <a:prstGeom prst="roundRect">
@@ -6753,13 +6843,13 @@
       </p:sp>
       <p:sp>
         <p:nvSpPr>
-          <p:cNvPr id="8" name="Rounded Rectangle 7"/>
+          <p:cNvPr id="10" name="Rounded Rectangle 9"/>
           <p:cNvSpPr/>
           <p:nvPr/>
         </p:nvSpPr>
         <p:spPr>
           <a:xfrm>
-            <a:off x="2072487" y="2560320"/>
+            <a:off x="2072487" y="3520440"/>
             <a:ext cx="2011680" cy="320040"/>
           </a:xfrm>
           <a:prstGeom prst="roundRect">
@@ -6799,13 +6889,13 @@
       </p:sp>
       <p:sp>
         <p:nvSpPr>
-          <p:cNvPr id="9" name="Rounded Rectangle 8"/>
+          <p:cNvPr id="11" name="Rounded Rectangle 10"/>
           <p:cNvSpPr/>
           <p:nvPr/>
         </p:nvSpPr>
         <p:spPr>
           <a:xfrm>
-            <a:off x="2072487" y="3063240"/>
+            <a:off x="2072487" y="4023360"/>
             <a:ext cx="2011680" cy="320040"/>
           </a:xfrm>
           <a:prstGeom prst="roundRect">
@@ -6845,13 +6935,13 @@
       </p:sp>
       <p:sp>
         <p:nvSpPr>
-          <p:cNvPr id="10" name="Rounded Rectangle 9"/>
+          <p:cNvPr id="12" name="Rounded Rectangle 11"/>
           <p:cNvSpPr/>
           <p:nvPr/>
         </p:nvSpPr>
         <p:spPr>
           <a:xfrm>
-            <a:off x="2072487" y="3566160"/>
+            <a:off x="2072487" y="4526280"/>
             <a:ext cx="2011680" cy="320040"/>
           </a:xfrm>
           <a:prstGeom prst="roundRect">
@@ -6891,13 +6981,13 @@
       </p:sp>
       <p:sp>
         <p:nvSpPr>
-          <p:cNvPr id="11" name="Rounded Rectangle 10"/>
+          <p:cNvPr id="13" name="Rounded Rectangle 12"/>
           <p:cNvSpPr/>
           <p:nvPr/>
         </p:nvSpPr>
         <p:spPr>
           <a:xfrm>
-            <a:off x="2072487" y="4069080"/>
+            <a:off x="2072487" y="5029200"/>
             <a:ext cx="2011680" cy="320040"/>
           </a:xfrm>
           <a:prstGeom prst="roundRect">
@@ -6937,59 +7027,13 @@
       </p:sp>
       <p:sp>
         <p:nvSpPr>
-          <p:cNvPr id="12" name="Rounded Rectangle 11"/>
-          <p:cNvSpPr/>
-          <p:nvPr/>
-        </p:nvSpPr>
-        <p:spPr>
-          <a:xfrm>
-            <a:off x="2072487" y="4572000"/>
-            <a:ext cx="2011680" cy="320040"/>
-          </a:xfrm>
-          <a:prstGeom prst="roundRect">
-            <a:avLst>
-              <a:gd name="adj" fmla="val 20000"/>
-            </a:avLst>
-          </a:prstGeom>
-          <a:solidFill>
-            <a:srgbClr val="F1EEE6"/>
-          </a:solidFill>
-          <a:ln>
-            <a:noFill/>
-          </a:ln>
-          <a:effectLst/>
-        </p:spPr>
-        <p:style>
-          <a:lnRef idx="1">
-            <a:schemeClr val="accent1"/>
-          </a:lnRef>
-          <a:fillRef idx="3">
-            <a:schemeClr val="accent1"/>
-          </a:fillRef>
-          <a:effectRef idx="2">
-            <a:schemeClr val="accent1"/>
-          </a:effectRef>
-          <a:fontRef idx="minor">
-            <a:schemeClr val="lt1"/>
-          </a:fontRef>
-        </p:style>
-        <p:txBody>
-          <a:bodyPr rtlCol="0" anchor="ctr"/>
-          <a:lstStyle/>
-          <a:p>
-            <a:pPr algn="ctr"/>
-          </a:p>
-        </p:txBody>
-      </p:sp>
-      <p:sp>
-        <p:nvSpPr>
-          <p:cNvPr id="13" name="TextBox 12"/>
+          <p:cNvPr id="14" name="TextBox 13"/>
           <p:cNvSpPr txBox="1"/>
           <p:nvPr/>
         </p:nvSpPr>
         <p:spPr>
           <a:xfrm>
-            <a:off x="2026767" y="6172200"/>
+            <a:off x="4815687" y="1828800"/>
             <a:ext cx="2560320" cy="274320"/>
           </a:xfrm>
           <a:prstGeom prst="rect">
@@ -7011,21 +7055,21 @@
                 </a:solidFill>
                 <a:latin typeface="Helvetica Neue"/>
               </a:rPr>
-              <a:t>NEW REPORT</a:t>
-            </a:r>
-          </a:p>
-        </p:txBody>
-      </p:sp>
-      <p:sp>
-        <p:nvSpPr>
-          <p:cNvPr id="14" name="TextBox 13"/>
+              <a:t>DAILY PROGRESS REPORT</a:t>
+            </a:r>
+          </a:p>
+        </p:txBody>
+      </p:sp>
+      <p:sp>
+        <p:nvSpPr>
+          <p:cNvPr id="15" name="TextBox 14"/>
           <p:cNvSpPr txBox="1"/>
           <p:nvPr/>
         </p:nvSpPr>
         <p:spPr>
           <a:xfrm>
-            <a:off x="2026767" y="6492240"/>
-            <a:ext cx="2560320" cy="822960"/>
+            <a:off x="4815687" y="2103120"/>
+            <a:ext cx="2560320" cy="640080"/>
           </a:xfrm>
           <a:prstGeom prst="rect">
             <a:avLst/>
@@ -7050,7 +7094,7 @@
                 </a:solidFill>
                 <a:latin typeface="Helvetica Neue"/>
               </a:rPr>
-              <a:t>Voice-note list, timestamps,</a:t>
+              <a:t>Structured: weather, headcount,</a:t>
             </a:r>
           </a:p>
           <a:p>
@@ -7066,21 +7110,21 @@
                 </a:solidFill>
                 <a:latin typeface="Helvetica Neue"/>
               </a:rPr>
-              <a:t>Generate-report button</a:t>
-            </a:r>
-          </a:p>
-        </p:txBody>
-      </p:sp>
-      <p:sp>
-        <p:nvSpPr>
-          <p:cNvPr id="15" name="Rounded Rectangle 14"/>
+              <a:t>materials, flagged issues</a:t>
+            </a:r>
+          </a:p>
+        </p:txBody>
+      </p:sp>
+      <p:sp>
+        <p:nvSpPr>
+          <p:cNvPr id="16" name="Rounded Rectangle 15"/>
           <p:cNvSpPr/>
           <p:nvPr/>
         </p:nvSpPr>
         <p:spPr>
           <a:xfrm>
-            <a:off x="4815687" y="1828800"/>
-            <a:ext cx="2560320" cy="4160520"/>
+            <a:off x="4815687" y="2788920"/>
+            <a:ext cx="2560320" cy="3383280"/>
           </a:xfrm>
           <a:prstGeom prst="roundRect">
             <a:avLst>
@@ -7121,13 +7165,13 @@
       </p:sp>
       <p:sp>
         <p:nvSpPr>
-          <p:cNvPr id="16" name="Rounded Rectangle 15"/>
+          <p:cNvPr id="17" name="Rounded Rectangle 16"/>
           <p:cNvSpPr/>
           <p:nvPr/>
         </p:nvSpPr>
         <p:spPr>
           <a:xfrm>
-            <a:off x="5044287" y="2057400"/>
+            <a:off x="5044287" y="3017520"/>
             <a:ext cx="2103120" cy="274320"/>
           </a:xfrm>
           <a:prstGeom prst="roundRect">
@@ -7167,13 +7211,13 @@
       </p:sp>
       <p:sp>
         <p:nvSpPr>
-          <p:cNvPr id="17" name="Rounded Rectangle 16"/>
+          <p:cNvPr id="18" name="Rounded Rectangle 17"/>
           <p:cNvSpPr/>
           <p:nvPr/>
         </p:nvSpPr>
         <p:spPr>
           <a:xfrm>
-            <a:off x="5090007" y="2560320"/>
+            <a:off x="5090007" y="3520440"/>
             <a:ext cx="2011680" cy="320040"/>
           </a:xfrm>
           <a:prstGeom prst="roundRect">
@@ -7213,13 +7257,13 @@
       </p:sp>
       <p:sp>
         <p:nvSpPr>
-          <p:cNvPr id="18" name="Rounded Rectangle 17"/>
+          <p:cNvPr id="19" name="Rounded Rectangle 18"/>
           <p:cNvSpPr/>
           <p:nvPr/>
         </p:nvSpPr>
         <p:spPr>
           <a:xfrm>
-            <a:off x="5090007" y="3063240"/>
+            <a:off x="5090007" y="4023360"/>
             <a:ext cx="2011680" cy="320040"/>
           </a:xfrm>
           <a:prstGeom prst="roundRect">
@@ -7259,13 +7303,13 @@
       </p:sp>
       <p:sp>
         <p:nvSpPr>
-          <p:cNvPr id="19" name="Rounded Rectangle 18"/>
+          <p:cNvPr id="20" name="Rounded Rectangle 19"/>
           <p:cNvSpPr/>
           <p:nvPr/>
         </p:nvSpPr>
         <p:spPr>
           <a:xfrm>
-            <a:off x="5090007" y="3566160"/>
+            <a:off x="5090007" y="4526280"/>
             <a:ext cx="2011680" cy="320040"/>
           </a:xfrm>
           <a:prstGeom prst="roundRect">
@@ -7305,13 +7349,13 @@
       </p:sp>
       <p:sp>
         <p:nvSpPr>
-          <p:cNvPr id="20" name="Rounded Rectangle 19"/>
+          <p:cNvPr id="21" name="Rounded Rectangle 20"/>
           <p:cNvSpPr/>
           <p:nvPr/>
         </p:nvSpPr>
         <p:spPr>
           <a:xfrm>
-            <a:off x="5090007" y="4069080"/>
+            <a:off x="5090007" y="5029200"/>
             <a:ext cx="2011680" cy="320040"/>
           </a:xfrm>
           <a:prstGeom prst="roundRect">
@@ -7351,59 +7395,13 @@
       </p:sp>
       <p:sp>
         <p:nvSpPr>
-          <p:cNvPr id="21" name="Rounded Rectangle 20"/>
-          <p:cNvSpPr/>
-          <p:nvPr/>
-        </p:nvSpPr>
-        <p:spPr>
-          <a:xfrm>
-            <a:off x="5090007" y="4572000"/>
-            <a:ext cx="2011680" cy="320040"/>
-          </a:xfrm>
-          <a:prstGeom prst="roundRect">
-            <a:avLst>
-              <a:gd name="adj" fmla="val 20000"/>
-            </a:avLst>
-          </a:prstGeom>
-          <a:solidFill>
-            <a:srgbClr val="F1EEE6"/>
-          </a:solidFill>
-          <a:ln>
-            <a:noFill/>
-          </a:ln>
-          <a:effectLst/>
-        </p:spPr>
-        <p:style>
-          <a:lnRef idx="1">
-            <a:schemeClr val="accent1"/>
-          </a:lnRef>
-          <a:fillRef idx="3">
-            <a:schemeClr val="accent1"/>
-          </a:fillRef>
-          <a:effectRef idx="2">
-            <a:schemeClr val="accent1"/>
-          </a:effectRef>
-          <a:fontRef idx="minor">
-            <a:schemeClr val="lt1"/>
-          </a:fontRef>
-        </p:style>
-        <p:txBody>
-          <a:bodyPr rtlCol="0" anchor="ctr"/>
-          <a:lstStyle/>
-          <a:p>
-            <a:pPr algn="ctr"/>
-          </a:p>
-        </p:txBody>
-      </p:sp>
-      <p:sp>
-        <p:nvSpPr>
           <p:cNvPr id="22" name="TextBox 21"/>
           <p:cNvSpPr txBox="1"/>
           <p:nvPr/>
         </p:nvSpPr>
         <p:spPr>
           <a:xfrm>
-            <a:off x="5044287" y="6172200"/>
+            <a:off x="7833207" y="1828800"/>
             <a:ext cx="2560320" cy="274320"/>
           </a:xfrm>
           <a:prstGeom prst="rect">
@@ -7425,7 +7423,7 @@
                 </a:solidFill>
                 <a:latin typeface="Helvetica Neue"/>
               </a:rPr>
-              <a:t>DAILY PROGRESS REPORT</a:t>
+              <a:t>REPORTS</a:t>
             </a:r>
           </a:p>
         </p:txBody>
@@ -7438,8 +7436,8 @@
         </p:nvSpPr>
         <p:spPr>
           <a:xfrm>
-            <a:off x="5044287" y="6492240"/>
-            <a:ext cx="2560320" cy="822960"/>
+            <a:off x="7833207" y="2103120"/>
+            <a:ext cx="2560320" cy="640080"/>
           </a:xfrm>
           <a:prstGeom prst="rect">
             <a:avLst/>
@@ -7464,7 +7462,7 @@
                 </a:solidFill>
                 <a:latin typeface="Helvetica Neue"/>
               </a:rPr>
-              <a:t>Structured: weather, headcount,</a:t>
+              <a:t>History with DRAFT, Incident,</a:t>
             </a:r>
           </a:p>
           <a:p>
@@ -7480,7 +7478,7 @@
                 </a:solidFill>
                 <a:latin typeface="Helvetica Neue"/>
               </a:rPr>
-              <a:t>materials, flagged issues</a:t>
+              <a:t>Safety status tags</a:t>
             </a:r>
           </a:p>
         </p:txBody>
@@ -7493,8 +7491,8 @@
         </p:nvSpPr>
         <p:spPr>
           <a:xfrm>
-            <a:off x="7833207" y="1828800"/>
-            <a:ext cx="2560320" cy="4160520"/>
+            <a:off x="7833207" y="2788920"/>
+            <a:ext cx="2560320" cy="3383280"/>
           </a:xfrm>
           <a:prstGeom prst="roundRect">
             <a:avLst>
@@ -7541,7 +7539,7 @@
         </p:nvSpPr>
         <p:spPr>
           <a:xfrm>
-            <a:off x="8061807" y="2057400"/>
+            <a:off x="8061807" y="3017520"/>
             <a:ext cx="2103120" cy="274320"/>
           </a:xfrm>
           <a:prstGeom prst="roundRect">
@@ -7587,7 +7585,7 @@
         </p:nvSpPr>
         <p:spPr>
           <a:xfrm>
-            <a:off x="8107527" y="2560320"/>
+            <a:off x="8107527" y="3520440"/>
             <a:ext cx="2011680" cy="320040"/>
           </a:xfrm>
           <a:prstGeom prst="roundRect">
@@ -7633,7 +7631,7 @@
         </p:nvSpPr>
         <p:spPr>
           <a:xfrm>
-            <a:off x="8107527" y="3063240"/>
+            <a:off x="8107527" y="4023360"/>
             <a:ext cx="2011680" cy="320040"/>
           </a:xfrm>
           <a:prstGeom prst="roundRect">
@@ -7679,7 +7677,7 @@
         </p:nvSpPr>
         <p:spPr>
           <a:xfrm>
-            <a:off x="8107527" y="3566160"/>
+            <a:off x="8107527" y="4526280"/>
             <a:ext cx="2011680" cy="320040"/>
           </a:xfrm>
           <a:prstGeom prst="roundRect">
@@ -7725,7 +7723,7 @@
         </p:nvSpPr>
         <p:spPr>
           <a:xfrm>
-            <a:off x="8107527" y="4069080"/>
+            <a:off x="8107527" y="5029200"/>
             <a:ext cx="2011680" cy="320040"/>
           </a:xfrm>
           <a:prstGeom prst="roundRect">
@@ -7765,60 +7763,14 @@
       </p:sp>
       <p:sp>
         <p:nvSpPr>
-          <p:cNvPr id="30" name="Rounded Rectangle 29"/>
-          <p:cNvSpPr/>
-          <p:nvPr/>
-        </p:nvSpPr>
-        <p:spPr>
-          <a:xfrm>
-            <a:off x="8107527" y="4572000"/>
-            <a:ext cx="2011680" cy="320040"/>
-          </a:xfrm>
-          <a:prstGeom prst="roundRect">
-            <a:avLst>
-              <a:gd name="adj" fmla="val 20000"/>
-            </a:avLst>
-          </a:prstGeom>
-          <a:solidFill>
-            <a:srgbClr val="F1EEE6"/>
-          </a:solidFill>
-          <a:ln>
-            <a:noFill/>
-          </a:ln>
-          <a:effectLst/>
-        </p:spPr>
-        <p:style>
-          <a:lnRef idx="1">
-            <a:schemeClr val="accent1"/>
-          </a:lnRef>
-          <a:fillRef idx="3">
-            <a:schemeClr val="accent1"/>
-          </a:fillRef>
-          <a:effectRef idx="2">
-            <a:schemeClr val="accent1"/>
-          </a:effectRef>
-          <a:fontRef idx="minor">
-            <a:schemeClr val="lt1"/>
-          </a:fontRef>
-        </p:style>
-        <p:txBody>
-          <a:bodyPr rtlCol="0" anchor="ctr"/>
-          <a:lstStyle/>
-          <a:p>
-            <a:pPr algn="ctr"/>
-          </a:p>
-        </p:txBody>
-      </p:sp>
-      <p:sp>
-        <p:nvSpPr>
-          <p:cNvPr id="31" name="TextBox 30"/>
+          <p:cNvPr id="30" name="TextBox 29"/>
           <p:cNvSpPr txBox="1"/>
           <p:nvPr/>
         </p:nvSpPr>
         <p:spPr>
           <a:xfrm>
-            <a:off x="8061807" y="6172200"/>
-            <a:ext cx="2560320" cy="274320"/>
+            <a:off x="868680" y="6217920"/>
+            <a:ext cx="10469880" cy="182880"/>
           </a:xfrm>
           <a:prstGeom prst="rect">
             <a:avLst/>
@@ -7831,112 +7783,22 @@
           </a:bodyPr>
           <a:lstStyle/>
           <a:p>
-            <a:pPr algn="l"/>
-            <a:r>
-              <a:rPr sz="1000" b="1" spc="160">
-                <a:solidFill>
-                  <a:srgbClr val="EA580C"/>
-                </a:solidFill>
-                <a:latin typeface="Helvetica Neue"/>
-              </a:rPr>
-              <a:t>REPORTS</a:t>
-            </a:r>
-          </a:p>
-        </p:txBody>
-      </p:sp>
-      <p:sp>
-        <p:nvSpPr>
-          <p:cNvPr id="32" name="TextBox 31"/>
-          <p:cNvSpPr txBox="1"/>
-          <p:nvPr/>
-        </p:nvSpPr>
-        <p:spPr>
-          <a:xfrm>
-            <a:off x="8061807" y="6492240"/>
-            <a:ext cx="2560320" cy="822960"/>
-          </a:xfrm>
-          <a:prstGeom prst="rect">
-            <a:avLst/>
-          </a:prstGeom>
-          <a:noFill/>
-        </p:spPr>
-        <p:txBody>
-          <a:bodyPr wrap="square" anchor="t" lIns="0" rIns="0" tIns="0" bIns="0">
-            <a:spAutoFit/>
-          </a:bodyPr>
-          <a:lstStyle/>
-          <a:p>
-            <a:pPr algn="l">
-              <a:lnSpc>
-                <a:spcPct val="130000"/>
-              </a:lnSpc>
-            </a:pPr>
-            <a:r>
-              <a:rPr sz="1200" b="0">
-                <a:solidFill>
-                  <a:srgbClr val="5F5B66"/>
-                </a:solidFill>
-                <a:latin typeface="Helvetica Neue"/>
-              </a:rPr>
-              <a:t>History with DRAFT, Incident,</a:t>
-            </a:r>
-          </a:p>
-          <a:p>
-            <a:pPr algn="l">
-              <a:lnSpc>
-                <a:spcPct val="130000"/>
-              </a:lnSpc>
-            </a:pPr>
-            <a:r>
-              <a:rPr sz="1200" b="0">
-                <a:solidFill>
-                  <a:srgbClr val="5F5B66"/>
-                </a:solidFill>
-                <a:latin typeface="Helvetica Neue"/>
-              </a:rPr>
-              <a:t>Safety status tags</a:t>
-            </a:r>
-          </a:p>
-        </p:txBody>
-      </p:sp>
-      <p:sp>
-        <p:nvSpPr>
-          <p:cNvPr id="33" name="TextBox 32"/>
-          <p:cNvSpPr txBox="1"/>
-          <p:nvPr/>
-        </p:nvSpPr>
-        <p:spPr>
-          <a:xfrm>
-            <a:off x="868680" y="6263640"/>
-            <a:ext cx="10469880" cy="274320"/>
-          </a:xfrm>
-          <a:prstGeom prst="rect">
-            <a:avLst/>
-          </a:prstGeom>
-          <a:noFill/>
-        </p:spPr>
-        <p:txBody>
-          <a:bodyPr wrap="square" anchor="t" lIns="0" rIns="0" tIns="0" bIns="0">
-            <a:spAutoFit/>
-          </a:bodyPr>
-          <a:lstStyle/>
-          <a:p>
-            <a:pPr algn="l"/>
-            <a:r>
-              <a:rPr sz="1100" b="0">
+            <a:pPr algn="ctr"/>
+            <a:r>
+              <a:rPr sz="900" b="0">
                 <a:solidFill>
                   <a:srgbClr val="8A8693"/>
                 </a:solidFill>
                 <a:latin typeface="Menlo"/>
               </a:rPr>
-              <a:t>[INSERT 3 REAL SCREENSHOTS]   ·   real screenshots already exist on slide 15 of the original deck.</a:t>
-            </a:r>
-          </a:p>
-        </p:txBody>
-      </p:sp>
-      <p:sp>
-        <p:nvSpPr>
-          <p:cNvPr id="34" name="Rounded Rectangle 33"/>
+              <a:t>Mock frames — replace with real screenshots before sending.</a:t>
+            </a:r>
+          </a:p>
+        </p:txBody>
+      </p:sp>
+      <p:sp>
+        <p:nvSpPr>
+          <p:cNvPr id="31" name="Rounded Rectangle 30"/>
           <p:cNvSpPr/>
           <p:nvPr/>
         </p:nvSpPr>
@@ -7982,7 +7844,7 @@
       </p:sp>
       <p:sp>
         <p:nvSpPr>
-          <p:cNvPr id="35" name="TextBox 34"/>
+          <p:cNvPr id="32" name="TextBox 31"/>
           <p:cNvSpPr txBox="1"/>
           <p:nvPr/>
         </p:nvSpPr>
@@ -8017,7 +7879,7 @@
       </p:sp>
       <p:sp>
         <p:nvSpPr>
-          <p:cNvPr id="36" name="TextBox 35"/>
+          <p:cNvPr id="33" name="TextBox 32"/>
           <p:cNvSpPr txBox="1"/>
           <p:nvPr/>
         </p:nvSpPr>
@@ -8052,7 +7914,7 @@
       </p:sp>
       <p:sp>
         <p:nvSpPr>
-          <p:cNvPr id="37" name="TextBox 36"/>
+          <p:cNvPr id="34" name="TextBox 33"/>
           <p:cNvSpPr txBox="1"/>
           <p:nvPr/>
         </p:nvSpPr>
@@ -8278,52 +8140,6 @@
             </a:avLst>
           </a:prstGeom>
           <a:solidFill>
-            <a:srgbClr val="FFFFFF"/>
-          </a:solidFill>
-          <a:ln w="9525">
-            <a:solidFill>
-              <a:srgbClr val="B9B4A8"/>
-            </a:solidFill>
-          </a:ln>
-          <a:effectLst/>
-        </p:spPr>
-        <p:style>
-          <a:lnRef idx="1">
-            <a:schemeClr val="accent1"/>
-          </a:lnRef>
-          <a:fillRef idx="3">
-            <a:schemeClr val="accent1"/>
-          </a:fillRef>
-          <a:effectRef idx="2">
-            <a:schemeClr val="accent1"/>
-          </a:effectRef>
-          <a:fontRef idx="minor">
-            <a:schemeClr val="lt1"/>
-          </a:fontRef>
-        </p:style>
-        <p:txBody>
-          <a:bodyPr rtlCol="0" anchor="ctr"/>
-          <a:lstStyle/>
-          <a:p>
-            <a:pPr algn="ctr"/>
-          </a:p>
-        </p:txBody>
-      </p:sp>
-      <p:sp>
-        <p:nvSpPr>
-          <p:cNvPr id="7" name="Rectangle 6"/>
-          <p:cNvSpPr/>
-          <p:nvPr/>
-        </p:nvSpPr>
-        <p:spPr>
-          <a:xfrm>
-            <a:off x="495147" y="1828800"/>
-            <a:ext cx="73152" cy="1554480"/>
-          </a:xfrm>
-          <a:prstGeom prst="rect">
-            <a:avLst/>
-          </a:prstGeom>
-          <a:solidFill>
             <a:srgbClr val="EA580C"/>
           </a:solidFill>
           <a:ln>
@@ -8355,84 +8171,14 @@
       </p:sp>
       <p:sp>
         <p:nvSpPr>
-          <p:cNvPr id="8" name="TextBox 7"/>
-          <p:cNvSpPr txBox="1"/>
-          <p:nvPr/>
-        </p:nvSpPr>
-        <p:spPr>
-          <a:xfrm>
-            <a:off x="495147" y="2103120"/>
-            <a:ext cx="3611880" cy="822960"/>
-          </a:xfrm>
-          <a:prstGeom prst="rect">
-            <a:avLst/>
-          </a:prstGeom>
-          <a:noFill/>
-        </p:spPr>
-        <p:txBody>
-          <a:bodyPr wrap="square" anchor="ctr" lIns="0" rIns="0" tIns="0" bIns="0">
-            <a:spAutoFit/>
-          </a:bodyPr>
-          <a:lstStyle/>
-          <a:p>
-            <a:pPr algn="ctr"/>
-            <a:r>
-              <a:rPr sz="4400" b="1">
-                <a:solidFill>
-                  <a:srgbClr val="2D3A5A"/>
-                </a:solidFill>
-                <a:latin typeface="Helvetica Neue"/>
-              </a:rPr>
-              <a:t>90%</a:t>
-            </a:r>
-          </a:p>
-        </p:txBody>
-      </p:sp>
-      <p:sp>
-        <p:nvSpPr>
-          <p:cNvPr id="9" name="TextBox 8"/>
-          <p:cNvSpPr txBox="1"/>
-          <p:nvPr/>
-        </p:nvSpPr>
-        <p:spPr>
-          <a:xfrm>
-            <a:off x="495147" y="2971800"/>
-            <a:ext cx="3611880" cy="274320"/>
-          </a:xfrm>
-          <a:prstGeom prst="rect">
-            <a:avLst/>
-          </a:prstGeom>
-          <a:noFill/>
-        </p:spPr>
-        <p:txBody>
-          <a:bodyPr wrap="square" anchor="t" lIns="0" rIns="0" tIns="0" bIns="0">
-            <a:spAutoFit/>
-          </a:bodyPr>
-          <a:lstStyle/>
-          <a:p>
-            <a:pPr algn="l"/>
-            <a:r>
-              <a:rPr sz="1000" b="1" spc="160">
-                <a:solidFill>
-                  <a:srgbClr val="5F5B66"/>
-                </a:solidFill>
-                <a:latin typeface="Helvetica Neue"/>
-              </a:rPr>
-              <a:t>PROTOTYPE COMPLETE</a:t>
-            </a:r>
-          </a:p>
-        </p:txBody>
-      </p:sp>
-      <p:sp>
-        <p:nvSpPr>
-          <p:cNvPr id="10" name="Rounded Rectangle 9"/>
+          <p:cNvPr id="7" name="Rounded Rectangle 6"/>
           <p:cNvSpPr/>
           <p:nvPr/>
         </p:nvSpPr>
         <p:spPr>
           <a:xfrm>
-            <a:off x="4289907" y="1828800"/>
-            <a:ext cx="3611880" cy="1554480"/>
+            <a:off x="586587" y="1828800"/>
+            <a:ext cx="3520440" cy="1554480"/>
           </a:xfrm>
           <a:prstGeom prst="roundRect">
             <a:avLst>
@@ -8473,13 +8219,13 @@
       </p:sp>
       <p:sp>
         <p:nvSpPr>
-          <p:cNvPr id="11" name="TextBox 10"/>
+          <p:cNvPr id="8" name="TextBox 7"/>
           <p:cNvSpPr txBox="1"/>
           <p:nvPr/>
         </p:nvSpPr>
         <p:spPr>
           <a:xfrm>
-            <a:off x="4289907" y="2103120"/>
+            <a:off x="495147" y="2103120"/>
             <a:ext cx="3611880" cy="822960"/>
           </a:xfrm>
           <a:prstGeom prst="rect">
@@ -8501,20 +8247,20 @@
                 </a:solidFill>
                 <a:latin typeface="Helvetica Neue"/>
               </a:rPr>
-              <a:t>[N]</a:t>
-            </a:r>
-          </a:p>
-        </p:txBody>
-      </p:sp>
-      <p:sp>
-        <p:nvSpPr>
-          <p:cNvPr id="12" name="TextBox 11"/>
+              <a:t>90%</a:t>
+            </a:r>
+          </a:p>
+        </p:txBody>
+      </p:sp>
+      <p:sp>
+        <p:nvSpPr>
+          <p:cNvPr id="9" name="TextBox 8"/>
           <p:cNvSpPr txBox="1"/>
           <p:nvPr/>
         </p:nvSpPr>
         <p:spPr>
           <a:xfrm>
-            <a:off x="4289907" y="2971800"/>
+            <a:off x="495147" y="2971800"/>
             <a:ext cx="3611880" cy="274320"/>
           </a:xfrm>
           <a:prstGeom prst="rect">
@@ -8536,20 +8282,20 @@
                 </a:solidFill>
                 <a:latin typeface="Helvetica Neue"/>
               </a:rPr>
-              <a:t>CUSTOMER INTERVIEWS</a:t>
-            </a:r>
-          </a:p>
-        </p:txBody>
-      </p:sp>
-      <p:sp>
-        <p:nvSpPr>
-          <p:cNvPr id="13" name="Rounded Rectangle 12"/>
+              <a:t>PROTOTYPE COMPLETE</a:t>
+            </a:r>
+          </a:p>
+        </p:txBody>
+      </p:sp>
+      <p:sp>
+        <p:nvSpPr>
+          <p:cNvPr id="10" name="Rounded Rectangle 9"/>
           <p:cNvSpPr/>
           <p:nvPr/>
         </p:nvSpPr>
         <p:spPr>
           <a:xfrm>
-            <a:off x="8084667" y="1828800"/>
+            <a:off x="4289907" y="1828800"/>
             <a:ext cx="3611880" cy="1554480"/>
           </a:xfrm>
           <a:prstGeom prst="roundRect">
@@ -8591,6 +8337,124 @@
       </p:sp>
       <p:sp>
         <p:nvSpPr>
+          <p:cNvPr id="11" name="TextBox 10"/>
+          <p:cNvSpPr txBox="1"/>
+          <p:nvPr/>
+        </p:nvSpPr>
+        <p:spPr>
+          <a:xfrm>
+            <a:off x="4289907" y="2103120"/>
+            <a:ext cx="3611880" cy="822960"/>
+          </a:xfrm>
+          <a:prstGeom prst="rect">
+            <a:avLst/>
+          </a:prstGeom>
+          <a:noFill/>
+        </p:spPr>
+        <p:txBody>
+          <a:bodyPr wrap="square" anchor="ctr" lIns="0" rIns="0" tIns="0" bIns="0">
+            <a:spAutoFit/>
+          </a:bodyPr>
+          <a:lstStyle/>
+          <a:p>
+            <a:pPr algn="ctr"/>
+            <a:r>
+              <a:rPr sz="4400" b="1">
+                <a:solidFill>
+                  <a:srgbClr val="2D3A5A"/>
+                </a:solidFill>
+                <a:latin typeface="Helvetica Neue"/>
+              </a:rPr>
+              <a:t>[N]</a:t>
+            </a:r>
+          </a:p>
+        </p:txBody>
+      </p:sp>
+      <p:sp>
+        <p:nvSpPr>
+          <p:cNvPr id="12" name="TextBox 11"/>
+          <p:cNvSpPr txBox="1"/>
+          <p:nvPr/>
+        </p:nvSpPr>
+        <p:spPr>
+          <a:xfrm>
+            <a:off x="4289907" y="2971800"/>
+            <a:ext cx="3611880" cy="274320"/>
+          </a:xfrm>
+          <a:prstGeom prst="rect">
+            <a:avLst/>
+          </a:prstGeom>
+          <a:noFill/>
+        </p:spPr>
+        <p:txBody>
+          <a:bodyPr wrap="square" anchor="t" lIns="0" rIns="0" tIns="0" bIns="0">
+            <a:spAutoFit/>
+          </a:bodyPr>
+          <a:lstStyle/>
+          <a:p>
+            <a:pPr algn="l"/>
+            <a:r>
+              <a:rPr sz="1000" b="1" spc="160">
+                <a:solidFill>
+                  <a:srgbClr val="5F5B66"/>
+                </a:solidFill>
+                <a:latin typeface="Helvetica Neue"/>
+              </a:rPr>
+              <a:t>CUSTOMER INTERVIEWS</a:t>
+            </a:r>
+          </a:p>
+        </p:txBody>
+      </p:sp>
+      <p:sp>
+        <p:nvSpPr>
+          <p:cNvPr id="13" name="Rounded Rectangle 12"/>
+          <p:cNvSpPr/>
+          <p:nvPr/>
+        </p:nvSpPr>
+        <p:spPr>
+          <a:xfrm>
+            <a:off x="8084667" y="1828800"/>
+            <a:ext cx="3611880" cy="1554480"/>
+          </a:xfrm>
+          <a:prstGeom prst="roundRect">
+            <a:avLst>
+              <a:gd name="adj" fmla="val 5000"/>
+            </a:avLst>
+          </a:prstGeom>
+          <a:solidFill>
+            <a:srgbClr val="FFFFFF"/>
+          </a:solidFill>
+          <a:ln w="9525">
+            <a:solidFill>
+              <a:srgbClr val="B9B4A8"/>
+            </a:solidFill>
+          </a:ln>
+          <a:effectLst/>
+        </p:spPr>
+        <p:style>
+          <a:lnRef idx="1">
+            <a:schemeClr val="accent1"/>
+          </a:lnRef>
+          <a:fillRef idx="3">
+            <a:schemeClr val="accent1"/>
+          </a:fillRef>
+          <a:effectRef idx="2">
+            <a:schemeClr val="accent1"/>
+          </a:effectRef>
+          <a:fontRef idx="minor">
+            <a:schemeClr val="lt1"/>
+          </a:fontRef>
+        </p:style>
+        <p:txBody>
+          <a:bodyPr rtlCol="0" anchor="ctr"/>
+          <a:lstStyle/>
+          <a:p>
+            <a:pPr algn="ctr"/>
+          </a:p>
+        </p:txBody>
+      </p:sp>
+      <p:sp>
+        <p:nvSpPr>
           <p:cNvPr id="14" name="TextBox 13"/>
           <p:cNvSpPr txBox="1"/>
           <p:nvPr/>
@@ -8669,6 +8533,52 @@
           <a:xfrm>
             <a:off x="868680" y="3840480"/>
             <a:ext cx="10469880" cy="2011680"/>
+          </a:xfrm>
+          <a:prstGeom prst="roundRect">
+            <a:avLst>
+              <a:gd name="adj" fmla="val 5000"/>
+            </a:avLst>
+          </a:prstGeom>
+          <a:solidFill>
+            <a:srgbClr val="EA580C"/>
+          </a:solidFill>
+          <a:ln>
+            <a:noFill/>
+          </a:ln>
+          <a:effectLst/>
+        </p:spPr>
+        <p:style>
+          <a:lnRef idx="1">
+            <a:schemeClr val="accent1"/>
+          </a:lnRef>
+          <a:fillRef idx="3">
+            <a:schemeClr val="accent1"/>
+          </a:fillRef>
+          <a:effectRef idx="2">
+            <a:schemeClr val="accent1"/>
+          </a:effectRef>
+          <a:fontRef idx="minor">
+            <a:schemeClr val="lt1"/>
+          </a:fontRef>
+        </p:style>
+        <p:txBody>
+          <a:bodyPr rtlCol="0" anchor="ctr"/>
+          <a:lstStyle/>
+          <a:p>
+            <a:pPr algn="ctr"/>
+          </a:p>
+        </p:txBody>
+      </p:sp>
+      <p:sp>
+        <p:nvSpPr>
+          <p:cNvPr id="17" name="Rounded Rectangle 16"/>
+          <p:cNvSpPr/>
+          <p:nvPr/>
+        </p:nvSpPr>
+        <p:spPr>
+          <a:xfrm>
+            <a:off x="960120" y="3840480"/>
+            <a:ext cx="10378440" cy="2011680"/>
           </a:xfrm>
           <a:prstGeom prst="roundRect">
             <a:avLst>
@@ -8682,50 +8592,6 @@
             <a:solidFill>
               <a:srgbClr val="B9B4A8"/>
             </a:solidFill>
-          </a:ln>
-          <a:effectLst/>
-        </p:spPr>
-        <p:style>
-          <a:lnRef idx="1">
-            <a:schemeClr val="accent1"/>
-          </a:lnRef>
-          <a:fillRef idx="3">
-            <a:schemeClr val="accent1"/>
-          </a:fillRef>
-          <a:effectRef idx="2">
-            <a:schemeClr val="accent1"/>
-          </a:effectRef>
-          <a:fontRef idx="minor">
-            <a:schemeClr val="lt1"/>
-          </a:fontRef>
-        </p:style>
-        <p:txBody>
-          <a:bodyPr rtlCol="0" anchor="ctr"/>
-          <a:lstStyle/>
-          <a:p>
-            <a:pPr algn="ctr"/>
-          </a:p>
-        </p:txBody>
-      </p:sp>
-      <p:sp>
-        <p:nvSpPr>
-          <p:cNvPr id="17" name="Rectangle 16"/>
-          <p:cNvSpPr/>
-          <p:nvPr/>
-        </p:nvSpPr>
-        <p:spPr>
-          <a:xfrm>
-            <a:off x="868680" y="3840480"/>
-            <a:ext cx="73152" cy="2011680"/>
-          </a:xfrm>
-          <a:prstGeom prst="rect">
-            <a:avLst/>
-          </a:prstGeom>
-          <a:solidFill>
-            <a:srgbClr val="EA580C"/>
-          </a:solidFill>
-          <a:ln>
-            <a:noFill/>
           </a:ln>
           <a:effectLst/>
         </p:spPr>
@@ -9274,56 +9140,58 @@
             </a:avLst>
           </a:prstGeom>
           <a:solidFill>
+            <a:srgbClr val="EA580C"/>
+          </a:solidFill>
+          <a:ln>
+            <a:noFill/>
+          </a:ln>
+          <a:effectLst/>
+        </p:spPr>
+        <p:style>
+          <a:lnRef idx="1">
+            <a:schemeClr val="accent1"/>
+          </a:lnRef>
+          <a:fillRef idx="3">
+            <a:schemeClr val="accent1"/>
+          </a:fillRef>
+          <a:effectRef idx="2">
+            <a:schemeClr val="accent1"/>
+          </a:effectRef>
+          <a:fontRef idx="minor">
+            <a:schemeClr val="lt1"/>
+          </a:fontRef>
+        </p:style>
+        <p:txBody>
+          <a:bodyPr rtlCol="0" anchor="ctr"/>
+          <a:lstStyle/>
+          <a:p>
+            <a:pPr algn="ctr"/>
+          </a:p>
+        </p:txBody>
+      </p:sp>
+      <p:sp>
+        <p:nvSpPr>
+          <p:cNvPr id="7" name="Rounded Rectangle 6"/>
+          <p:cNvSpPr/>
+          <p:nvPr/>
+        </p:nvSpPr>
+        <p:spPr>
+          <a:xfrm>
+            <a:off x="960120" y="1828800"/>
+            <a:ext cx="10378440" cy="1280160"/>
+          </a:xfrm>
+          <a:prstGeom prst="roundRect">
+            <a:avLst>
+              <a:gd name="adj" fmla="val 5000"/>
+            </a:avLst>
+          </a:prstGeom>
+          <a:solidFill>
             <a:srgbClr val="FFFDF8"/>
           </a:solidFill>
           <a:ln w="9525">
             <a:solidFill>
               <a:srgbClr val="B9B4A8"/>
             </a:solidFill>
-          </a:ln>
-          <a:effectLst/>
-        </p:spPr>
-        <p:style>
-          <a:lnRef idx="1">
-            <a:schemeClr val="accent1"/>
-          </a:lnRef>
-          <a:fillRef idx="3">
-            <a:schemeClr val="accent1"/>
-          </a:fillRef>
-          <a:effectRef idx="2">
-            <a:schemeClr val="accent1"/>
-          </a:effectRef>
-          <a:fontRef idx="minor">
-            <a:schemeClr val="lt1"/>
-          </a:fontRef>
-        </p:style>
-        <p:txBody>
-          <a:bodyPr rtlCol="0" anchor="ctr"/>
-          <a:lstStyle/>
-          <a:p>
-            <a:pPr algn="ctr"/>
-          </a:p>
-        </p:txBody>
-      </p:sp>
-      <p:sp>
-        <p:nvSpPr>
-          <p:cNvPr id="7" name="Rectangle 6"/>
-          <p:cNvSpPr/>
-          <p:nvPr/>
-        </p:nvSpPr>
-        <p:spPr>
-          <a:xfrm>
-            <a:off x="868680" y="1828800"/>
-            <a:ext cx="73152" cy="1280160"/>
-          </a:xfrm>
-          <a:prstGeom prst="rect">
-            <a:avLst/>
-          </a:prstGeom>
-          <a:solidFill>
-            <a:srgbClr val="EA580C"/>
-          </a:solidFill>
-          <a:ln>
-            <a:noFill/>
           </a:ln>
           <a:effectLst/>
         </p:spPr>
@@ -10122,356 +9990,634 @@
           </a:p>
         </p:txBody>
       </p:sp>
-      <p:sp>
-        <p:nvSpPr>
-          <p:cNvPr id="6" name="Rounded Rectangle 5"/>
+      <p:graphicFrame>
+        <p:nvGraphicFramePr>
+          <p:cNvPr id="6" name="Table 5"/>
+          <p:cNvGraphicFramePr>
+            <a:graphicFrameLocks noGrp="1"/>
+          </p:cNvGraphicFramePr>
+          <p:nvPr/>
+        </p:nvGraphicFramePr>
+        <p:xfrm>
+          <a:off x="868680" y="1828800"/>
+          <a:ext cx="10469880" cy="2257544512080"/>
+        </p:xfrm>
+        <a:graphic>
+          <a:graphicData uri="http://schemas.openxmlformats.org/drawingml/2006/table">
+            <a:tbl>
+              <a:tblPr firstRow="1" bandRow="1">
+                <a:tableStyleId>{5C22544A-7EE6-4342-B048-85BDC9FD1C3A}</a:tableStyleId>
+              </a:tblPr>
+              <a:tblGrid>
+                <a:gridCol w="1554480"/>
+                <a:gridCol w="2103120"/>
+                <a:gridCol w="2468880"/>
+                <a:gridCol w="2103120"/>
+                <a:gridCol w="2240280"/>
+              </a:tblGrid>
+              <a:tr h="640080">
+                <a:tc>
+                  <a:txBody>
+                    <a:bodyPr wrap="square"/>
+                    <a:lstStyle/>
+                    <a:p>
+                      <a:pPr algn="ctr"/>
+                      <a:r>
+                        <a:rPr sz="1200" b="1" spc="80">
+                          <a:solidFill>
+                            <a:srgbClr val="FFFFFF"/>
+                          </a:solidFill>
+                          <a:latin typeface="Helvetica Neue"/>
+                        </a:rPr>
+                        <a:t/>
+                      </a:r>
+                    </a:p>
+                  </a:txBody>
+                  <a:tcPr marL="137160" marR="137160" marT="45720" marB="45720" anchor="ctr">
+                    <a:solidFill>
+                      <a:srgbClr val="2D3A5A"/>
+                    </a:solidFill>
+                  </a:tcPr>
+                </a:tc>
+                <a:tc>
+                  <a:txBody>
+                    <a:bodyPr wrap="square"/>
+                    <a:lstStyle/>
+                    <a:p>
+                      <a:pPr algn="ctr"/>
+                      <a:r>
+                        <a:rPr sz="1200" b="1" spc="80">
+                          <a:solidFill>
+                            <a:srgbClr val="FFFFFF"/>
+                          </a:solidFill>
+                          <a:latin typeface="Helvetica Neue"/>
+                        </a:rPr>
+                        <a:t>Procore</a:t>
+                      </a:r>
+                    </a:p>
+                  </a:txBody>
+                  <a:tcPr marL="137160" marR="137160" marT="45720" marB="45720" anchor="ctr">
+                    <a:solidFill>
+                      <a:srgbClr val="2D3A5A"/>
+                    </a:solidFill>
+                  </a:tcPr>
+                </a:tc>
+                <a:tc>
+                  <a:txBody>
+                    <a:bodyPr wrap="square"/>
+                    <a:lstStyle/>
+                    <a:p>
+                      <a:pPr algn="ctr"/>
+                      <a:r>
+                        <a:rPr sz="1200" b="1" spc="80">
+                          <a:solidFill>
+                            <a:srgbClr val="FFFFFF"/>
+                          </a:solidFill>
+                          <a:latin typeface="Helvetica Neue"/>
+                        </a:rPr>
+                        <a:t>Buildots / OpenSpace</a:t>
+                      </a:r>
+                    </a:p>
+                  </a:txBody>
+                  <a:tcPr marL="137160" marR="137160" marT="45720" marB="45720" anchor="ctr">
+                    <a:solidFill>
+                      <a:srgbClr val="2D3A5A"/>
+                    </a:solidFill>
+                  </a:tcPr>
+                </a:tc>
+                <a:tc>
+                  <a:txBody>
+                    <a:bodyPr wrap="square"/>
+                    <a:lstStyle/>
+                    <a:p>
+                      <a:pPr algn="ctr"/>
+                      <a:r>
+                        <a:rPr sz="1200" b="1" spc="80">
+                          <a:solidFill>
+                            <a:srgbClr val="FFFFFF"/>
+                          </a:solidFill>
+                          <a:latin typeface="Helvetica Neue"/>
+                        </a:rPr>
+                        <a:t>Fieldwire</a:t>
+                      </a:r>
+                    </a:p>
+                  </a:txBody>
+                  <a:tcPr marL="137160" marR="137160" marT="45720" marB="45720" anchor="ctr">
+                    <a:solidFill>
+                      <a:srgbClr val="2D3A5A"/>
+                    </a:solidFill>
+                  </a:tcPr>
+                </a:tc>
+                <a:tc>
+                  <a:txBody>
+                    <a:bodyPr wrap="square"/>
+                    <a:lstStyle/>
+                    <a:p>
+                      <a:pPr algn="ctr"/>
+                      <a:r>
+                        <a:rPr sz="1200" b="1" spc="80">
+                          <a:solidFill>
+                            <a:srgbClr val="FFFFFF"/>
+                          </a:solidFill>
+                          <a:latin typeface="Helvetica Neue"/>
+                        </a:rPr>
+                        <a:t>Harpa Pro</a:t>
+                      </a:r>
+                    </a:p>
+                  </a:txBody>
+                  <a:tcPr marL="137160" marR="137160" marT="45720" marB="45720" anchor="ctr">
+                    <a:solidFill>
+                      <a:srgbClr val="EA580C"/>
+                    </a:solidFill>
+                  </a:tcPr>
+                </a:tc>
+              </a:tr>
+              <a:tr h="564385968000">
+                <a:tc>
+                  <a:txBody>
+                    <a:bodyPr wrap="square"/>
+                    <a:lstStyle/>
+                    <a:p>
+                      <a:pPr algn="ctr"/>
+                      <a:r>
+                        <a:rPr sz="1300" b="1">
+                          <a:solidFill>
+                            <a:srgbClr val="2D3A5A"/>
+                          </a:solidFill>
+                          <a:latin typeface="Helvetica Neue"/>
+                        </a:rPr>
+                        <a:t>Buyer</a:t>
+                      </a:r>
+                    </a:p>
+                  </a:txBody>
+                  <a:tcPr marL="137160" marR="137160" marT="45720" marB="45720" anchor="ctr">
+                    <a:solidFill>
+                      <a:srgbClr val="F1EEE6"/>
+                    </a:solidFill>
+                  </a:tcPr>
+                </a:tc>
+                <a:tc>
+                  <a:txBody>
+                    <a:bodyPr wrap="square"/>
+                    <a:lstStyle/>
+                    <a:p>
+                      <a:pPr algn="ctr"/>
+                      <a:r>
+                        <a:rPr sz="1300" b="0">
+                          <a:solidFill>
+                            <a:srgbClr val="5F5B66"/>
+                          </a:solidFill>
+                          <a:latin typeface="Helvetica Neue"/>
+                        </a:rPr>
+                        <a:t>Enterprise GC</a:t>
+                      </a:r>
+                    </a:p>
+                  </a:txBody>
+                  <a:tcPr marL="137160" marR="137160" marT="45720" marB="45720" anchor="ctr">
+                    <a:solidFill>
+                      <a:srgbClr val="FFFFFF"/>
+                    </a:solidFill>
+                  </a:tcPr>
+                </a:tc>
+                <a:tc>
+                  <a:txBody>
+                    <a:bodyPr wrap="square"/>
+                    <a:lstStyle/>
+                    <a:p>
+                      <a:pPr algn="ctr"/>
+                      <a:r>
+                        <a:rPr sz="1300" b="0">
+                          <a:solidFill>
+                            <a:srgbClr val="5F5B66"/>
+                          </a:solidFill>
+                          <a:latin typeface="Helvetica Neue"/>
+                        </a:rPr>
+                        <a:t>Enterprise GC</a:t>
+                      </a:r>
+                    </a:p>
+                  </a:txBody>
+                  <a:tcPr marL="137160" marR="137160" marT="45720" marB="45720" anchor="ctr">
+                    <a:solidFill>
+                      <a:srgbClr val="FFFFFF"/>
+                    </a:solidFill>
+                  </a:tcPr>
+                </a:tc>
+                <a:tc>
+                  <a:txBody>
+                    <a:bodyPr wrap="square"/>
+                    <a:lstStyle/>
+                    <a:p>
+                      <a:pPr algn="ctr"/>
+                      <a:r>
+                        <a:rPr sz="1300" b="0">
+                          <a:solidFill>
+                            <a:srgbClr val="5F5B66"/>
+                          </a:solidFill>
+                          <a:latin typeface="Helvetica Neue"/>
+                        </a:rPr>
+                        <a:t>Mid-market</a:t>
+                      </a:r>
+                    </a:p>
+                  </a:txBody>
+                  <a:tcPr marL="137160" marR="137160" marT="45720" marB="45720" anchor="ctr">
+                    <a:solidFill>
+                      <a:srgbClr val="FFFFFF"/>
+                    </a:solidFill>
+                  </a:tcPr>
+                </a:tc>
+                <a:tc>
+                  <a:txBody>
+                    <a:bodyPr wrap="square"/>
+                    <a:lstStyle/>
+                    <a:p>
+                      <a:pPr algn="ctr"/>
+                      <a:r>
+                        <a:rPr sz="1300" b="1">
+                          <a:solidFill>
+                            <a:srgbClr val="2D3A5A"/>
+                          </a:solidFill>
+                          <a:latin typeface="Helvetica Neue"/>
+                        </a:rPr>
+                        <a:t>Site supervisor</a:t>
+                      </a:r>
+                    </a:p>
+                  </a:txBody>
+                  <a:tcPr marL="137160" marR="137160" marT="45720" marB="45720" anchor="ctr">
+                    <a:solidFill>
+                      <a:srgbClr val="FFFDF8"/>
+                    </a:solidFill>
+                  </a:tcPr>
+                </a:tc>
+              </a:tr>
+              <a:tr h="564385968000">
+                <a:tc>
+                  <a:txBody>
+                    <a:bodyPr wrap="square"/>
+                    <a:lstStyle/>
+                    <a:p>
+                      <a:pPr algn="ctr"/>
+                      <a:r>
+                        <a:rPr sz="1300" b="1">
+                          <a:solidFill>
+                            <a:srgbClr val="2D3A5A"/>
+                          </a:solidFill>
+                          <a:latin typeface="Helvetica Neue"/>
+                        </a:rPr>
+                        <a:t>Input</a:t>
+                      </a:r>
+                    </a:p>
+                  </a:txBody>
+                  <a:tcPr marL="137160" marR="137160" marT="45720" marB="45720" anchor="ctr">
+                    <a:solidFill>
+                      <a:srgbClr val="F1EEE6"/>
+                    </a:solidFill>
+                  </a:tcPr>
+                </a:tc>
+                <a:tc>
+                  <a:txBody>
+                    <a:bodyPr wrap="square"/>
+                    <a:lstStyle/>
+                    <a:p>
+                      <a:pPr algn="ctr"/>
+                      <a:r>
+                        <a:rPr sz="1300" b="0">
+                          <a:solidFill>
+                            <a:srgbClr val="5F5B66"/>
+                          </a:solidFill>
+                          <a:latin typeface="Helvetica Neue"/>
+                        </a:rPr>
+                        <a:t>Manual forms</a:t>
+                      </a:r>
+                    </a:p>
+                  </a:txBody>
+                  <a:tcPr marL="137160" marR="137160" marT="45720" marB="45720" anchor="ctr">
+                    <a:solidFill>
+                      <a:srgbClr val="F1EEE6"/>
+                    </a:solidFill>
+                  </a:tcPr>
+                </a:tc>
+                <a:tc>
+                  <a:txBody>
+                    <a:bodyPr wrap="square"/>
+                    <a:lstStyle/>
+                    <a:p>
+                      <a:pPr algn="ctr"/>
+                      <a:r>
+                        <a:rPr sz="1300" b="0">
+                          <a:solidFill>
+                            <a:srgbClr val="5F5B66"/>
+                          </a:solidFill>
+                          <a:latin typeface="Helvetica Neue"/>
+                        </a:rPr>
+                        <a:t>360° camera</a:t>
+                      </a:r>
+                    </a:p>
+                  </a:txBody>
+                  <a:tcPr marL="137160" marR="137160" marT="45720" marB="45720" anchor="ctr">
+                    <a:solidFill>
+                      <a:srgbClr val="F1EEE6"/>
+                    </a:solidFill>
+                  </a:tcPr>
+                </a:tc>
+                <a:tc>
+                  <a:txBody>
+                    <a:bodyPr wrap="square"/>
+                    <a:lstStyle/>
+                    <a:p>
+                      <a:pPr algn="ctr"/>
+                      <a:r>
+                        <a:rPr sz="1300" b="0">
+                          <a:solidFill>
+                            <a:srgbClr val="5F5B66"/>
+                          </a:solidFill>
+                          <a:latin typeface="Helvetica Neue"/>
+                        </a:rPr>
+                        <a:t>Manual forms</a:t>
+                      </a:r>
+                    </a:p>
+                  </a:txBody>
+                  <a:tcPr marL="137160" marR="137160" marT="45720" marB="45720" anchor="ctr">
+                    <a:solidFill>
+                      <a:srgbClr val="F1EEE6"/>
+                    </a:solidFill>
+                  </a:tcPr>
+                </a:tc>
+                <a:tc>
+                  <a:txBody>
+                    <a:bodyPr wrap="square"/>
+                    <a:lstStyle/>
+                    <a:p>
+                      <a:pPr algn="ctr"/>
+                      <a:r>
+                        <a:rPr sz="1300" b="1">
+                          <a:solidFill>
+                            <a:srgbClr val="2D3A5A"/>
+                          </a:solidFill>
+                          <a:latin typeface="Helvetica Neue"/>
+                        </a:rPr>
+                        <a:t>Voice</a:t>
+                      </a:r>
+                    </a:p>
+                  </a:txBody>
+                  <a:tcPr marL="137160" marR="137160" marT="45720" marB="45720" anchor="ctr">
+                    <a:solidFill>
+                      <a:srgbClr val="FFFDF8"/>
+                    </a:solidFill>
+                  </a:tcPr>
+                </a:tc>
+              </a:tr>
+              <a:tr h="564385968000">
+                <a:tc>
+                  <a:txBody>
+                    <a:bodyPr wrap="square"/>
+                    <a:lstStyle/>
+                    <a:p>
+                      <a:pPr algn="ctr"/>
+                      <a:r>
+                        <a:rPr sz="1300" b="1">
+                          <a:solidFill>
+                            <a:srgbClr val="2D3A5A"/>
+                          </a:solidFill>
+                          <a:latin typeface="Helvetica Neue"/>
+                        </a:rPr>
+                        <a:t>Onboarding</a:t>
+                      </a:r>
+                    </a:p>
+                  </a:txBody>
+                  <a:tcPr marL="137160" marR="137160" marT="45720" marB="45720" anchor="ctr">
+                    <a:solidFill>
+                      <a:srgbClr val="F1EEE6"/>
+                    </a:solidFill>
+                  </a:tcPr>
+                </a:tc>
+                <a:tc>
+                  <a:txBody>
+                    <a:bodyPr wrap="square"/>
+                    <a:lstStyle/>
+                    <a:p>
+                      <a:pPr algn="ctr"/>
+                      <a:r>
+                        <a:rPr sz="1300" b="0">
+                          <a:solidFill>
+                            <a:srgbClr val="5F5B66"/>
+                          </a:solidFill>
+                          <a:latin typeface="Helvetica Neue"/>
+                        </a:rPr>
+                        <a:t>Weeks</a:t>
+                      </a:r>
+                    </a:p>
+                  </a:txBody>
+                  <a:tcPr marL="137160" marR="137160" marT="45720" marB="45720" anchor="ctr">
+                    <a:solidFill>
+                      <a:srgbClr val="FFFFFF"/>
+                    </a:solidFill>
+                  </a:tcPr>
+                </a:tc>
+                <a:tc>
+                  <a:txBody>
+                    <a:bodyPr wrap="square"/>
+                    <a:lstStyle/>
+                    <a:p>
+                      <a:pPr algn="ctr"/>
+                      <a:r>
+                        <a:rPr sz="1300" b="0">
+                          <a:solidFill>
+                            <a:srgbClr val="5F5B66"/>
+                          </a:solidFill>
+                          <a:latin typeface="Helvetica Neue"/>
+                        </a:rPr>
+                        <a:t>Weeks</a:t>
+                      </a:r>
+                    </a:p>
+                  </a:txBody>
+                  <a:tcPr marL="137160" marR="137160" marT="45720" marB="45720" anchor="ctr">
+                    <a:solidFill>
+                      <a:srgbClr val="FFFFFF"/>
+                    </a:solidFill>
+                  </a:tcPr>
+                </a:tc>
+                <a:tc>
+                  <a:txBody>
+                    <a:bodyPr wrap="square"/>
+                    <a:lstStyle/>
+                    <a:p>
+                      <a:pPr algn="ctr"/>
+                      <a:r>
+                        <a:rPr sz="1300" b="0">
+                          <a:solidFill>
+                            <a:srgbClr val="5F5B66"/>
+                          </a:solidFill>
+                          <a:latin typeface="Helvetica Neue"/>
+                        </a:rPr>
+                        <a:t>Days</a:t>
+                      </a:r>
+                    </a:p>
+                  </a:txBody>
+                  <a:tcPr marL="137160" marR="137160" marT="45720" marB="45720" anchor="ctr">
+                    <a:solidFill>
+                      <a:srgbClr val="FFFFFF"/>
+                    </a:solidFill>
+                  </a:tcPr>
+                </a:tc>
+                <a:tc>
+                  <a:txBody>
+                    <a:bodyPr wrap="square"/>
+                    <a:lstStyle/>
+                    <a:p>
+                      <a:pPr algn="ctr"/>
+                      <a:r>
+                        <a:rPr sz="1300" b="1">
+                          <a:solidFill>
+                            <a:srgbClr val="2D3A5A"/>
+                          </a:solidFill>
+                          <a:latin typeface="Helvetica Neue"/>
+                        </a:rPr>
+                        <a:t>Minutes</a:t>
+                      </a:r>
+                    </a:p>
+                  </a:txBody>
+                  <a:tcPr marL="137160" marR="137160" marT="45720" marB="45720" anchor="ctr">
+                    <a:solidFill>
+                      <a:srgbClr val="FFFDF8"/>
+                    </a:solidFill>
+                  </a:tcPr>
+                </a:tc>
+              </a:tr>
+              <a:tr h="564385968000">
+                <a:tc>
+                  <a:txBody>
+                    <a:bodyPr wrap="square"/>
+                    <a:lstStyle/>
+                    <a:p>
+                      <a:pPr algn="ctr"/>
+                      <a:r>
+                        <a:rPr sz="1300" b="1">
+                          <a:solidFill>
+                            <a:srgbClr val="2D3A5A"/>
+                          </a:solidFill>
+                          <a:latin typeface="Helvetica Neue"/>
+                        </a:rPr>
+                        <a:t>Price tier</a:t>
+                      </a:r>
+                    </a:p>
+                  </a:txBody>
+                  <a:tcPr marL="137160" marR="137160" marT="45720" marB="45720" anchor="ctr">
+                    <a:solidFill>
+                      <a:srgbClr val="F1EEE6"/>
+                    </a:solidFill>
+                  </a:tcPr>
+                </a:tc>
+                <a:tc>
+                  <a:txBody>
+                    <a:bodyPr wrap="square"/>
+                    <a:lstStyle/>
+                    <a:p>
+                      <a:pPr algn="ctr"/>
+                      <a:r>
+                        <a:rPr sz="1300" b="0">
+                          <a:solidFill>
+                            <a:srgbClr val="5F5B66"/>
+                          </a:solidFill>
+                          <a:latin typeface="Helvetica Neue"/>
+                        </a:rPr>
+                        <a:t>$$$$</a:t>
+                      </a:r>
+                    </a:p>
+                  </a:txBody>
+                  <a:tcPr marL="137160" marR="137160" marT="45720" marB="45720" anchor="ctr">
+                    <a:solidFill>
+                      <a:srgbClr val="F1EEE6"/>
+                    </a:solidFill>
+                  </a:tcPr>
+                </a:tc>
+                <a:tc>
+                  <a:txBody>
+                    <a:bodyPr wrap="square"/>
+                    <a:lstStyle/>
+                    <a:p>
+                      <a:pPr algn="ctr"/>
+                      <a:r>
+                        <a:rPr sz="1300" b="0">
+                          <a:solidFill>
+                            <a:srgbClr val="5F5B66"/>
+                          </a:solidFill>
+                          <a:latin typeface="Helvetica Neue"/>
+                        </a:rPr>
+                        <a:t>$$$$</a:t>
+                      </a:r>
+                    </a:p>
+                  </a:txBody>
+                  <a:tcPr marL="137160" marR="137160" marT="45720" marB="45720" anchor="ctr">
+                    <a:solidFill>
+                      <a:srgbClr val="F1EEE6"/>
+                    </a:solidFill>
+                  </a:tcPr>
+                </a:tc>
+                <a:tc>
+                  <a:txBody>
+                    <a:bodyPr wrap="square"/>
+                    <a:lstStyle/>
+                    <a:p>
+                      <a:pPr algn="ctr"/>
+                      <a:r>
+                        <a:rPr sz="1300" b="0">
+                          <a:solidFill>
+                            <a:srgbClr val="5F5B66"/>
+                          </a:solidFill>
+                          <a:latin typeface="Helvetica Neue"/>
+                        </a:rPr>
+                        <a:t>$$$</a:t>
+                      </a:r>
+                    </a:p>
+                  </a:txBody>
+                  <a:tcPr marL="137160" marR="137160" marT="45720" marB="45720" anchor="ctr">
+                    <a:solidFill>
+                      <a:srgbClr val="F1EEE6"/>
+                    </a:solidFill>
+                  </a:tcPr>
+                </a:tc>
+                <a:tc>
+                  <a:txBody>
+                    <a:bodyPr wrap="square"/>
+                    <a:lstStyle/>
+                    <a:p>
+                      <a:pPr algn="ctr"/>
+                      <a:r>
+                        <a:rPr sz="1300" b="1">
+                          <a:solidFill>
+                            <a:srgbClr val="2D3A5A"/>
+                          </a:solidFill>
+                          <a:latin typeface="Helvetica Neue"/>
+                        </a:rPr>
+                        <a:t>$</a:t>
+                      </a:r>
+                    </a:p>
+                  </a:txBody>
+                  <a:tcPr marL="137160" marR="137160" marT="45720" marB="45720" anchor="ctr">
+                    <a:solidFill>
+                      <a:srgbClr val="FFFDF8"/>
+                    </a:solidFill>
+                  </a:tcPr>
+                </a:tc>
+              </a:tr>
+            </a:tbl>
+          </a:graphicData>
+        </a:graphic>
+      </p:graphicFrame>
+      <p:sp>
+        <p:nvSpPr>
+          <p:cNvPr id="7" name="Rounded Rectangle 6"/>
           <p:cNvSpPr/>
           <p:nvPr/>
         </p:nvSpPr>
         <p:spPr>
           <a:xfrm>
-            <a:off x="868680" y="1828800"/>
-            <a:ext cx="1554480" cy="594360"/>
+            <a:off x="868680" y="5212080"/>
+            <a:ext cx="10469880" cy="914400"/>
           </a:xfrm>
           <a:prstGeom prst="roundRect">
             <a:avLst>
-              <a:gd name="adj" fmla="val 15000"/>
-            </a:avLst>
-          </a:prstGeom>
-          <a:solidFill>
-            <a:srgbClr val="2D3A5A"/>
-          </a:solidFill>
-          <a:ln>
-            <a:noFill/>
-          </a:ln>
-          <a:effectLst/>
-        </p:spPr>
-        <p:style>
-          <a:lnRef idx="1">
-            <a:schemeClr val="accent1"/>
-          </a:lnRef>
-          <a:fillRef idx="3">
-            <a:schemeClr val="accent1"/>
-          </a:fillRef>
-          <a:effectRef idx="2">
-            <a:schemeClr val="accent1"/>
-          </a:effectRef>
-          <a:fontRef idx="minor">
-            <a:schemeClr val="lt1"/>
-          </a:fontRef>
-        </p:style>
-        <p:txBody>
-          <a:bodyPr rtlCol="0" anchor="ctr"/>
-          <a:lstStyle/>
-          <a:p>
-            <a:pPr algn="ctr"/>
-          </a:p>
-        </p:txBody>
-      </p:sp>
-      <p:sp>
-        <p:nvSpPr>
-          <p:cNvPr id="7" name="TextBox 6"/>
-          <p:cNvSpPr txBox="1"/>
-          <p:nvPr/>
-        </p:nvSpPr>
-        <p:spPr>
-          <a:xfrm>
-            <a:off x="868680" y="1828800"/>
-            <a:ext cx="1554480" cy="594360"/>
-          </a:xfrm>
-          <a:prstGeom prst="rect">
-            <a:avLst/>
-          </a:prstGeom>
-          <a:noFill/>
-        </p:spPr>
-        <p:txBody>
-          <a:bodyPr wrap="square" anchor="ctr" lIns="0" rIns="0" tIns="0" bIns="0">
-            <a:spAutoFit/>
-          </a:bodyPr>
-          <a:lstStyle/>
-          <a:p>
-            <a:pPr algn="ctr"/>
-            <a:r>
-              <a:rPr sz="1200" b="1" spc="80">
-                <a:solidFill>
-                  <a:srgbClr val="FFFFFF"/>
-                </a:solidFill>
-                <a:latin typeface="Helvetica Neue"/>
-              </a:rPr>
-              <a:t/>
-            </a:r>
-          </a:p>
-        </p:txBody>
-      </p:sp>
-      <p:sp>
-        <p:nvSpPr>
-          <p:cNvPr id="8" name="Rounded Rectangle 7"/>
-          <p:cNvSpPr/>
-          <p:nvPr/>
-        </p:nvSpPr>
-        <p:spPr>
-          <a:xfrm>
-            <a:off x="2423160" y="1828800"/>
-            <a:ext cx="2103120" cy="594360"/>
-          </a:xfrm>
-          <a:prstGeom prst="roundRect">
-            <a:avLst>
-              <a:gd name="adj" fmla="val 0"/>
-            </a:avLst>
-          </a:prstGeom>
-          <a:solidFill>
-            <a:srgbClr val="2D3A5A"/>
-          </a:solidFill>
-          <a:ln>
-            <a:noFill/>
-          </a:ln>
-          <a:effectLst/>
-        </p:spPr>
-        <p:style>
-          <a:lnRef idx="1">
-            <a:schemeClr val="accent1"/>
-          </a:lnRef>
-          <a:fillRef idx="3">
-            <a:schemeClr val="accent1"/>
-          </a:fillRef>
-          <a:effectRef idx="2">
-            <a:schemeClr val="accent1"/>
-          </a:effectRef>
-          <a:fontRef idx="minor">
-            <a:schemeClr val="lt1"/>
-          </a:fontRef>
-        </p:style>
-        <p:txBody>
-          <a:bodyPr rtlCol="0" anchor="ctr"/>
-          <a:lstStyle/>
-          <a:p>
-            <a:pPr algn="ctr"/>
-          </a:p>
-        </p:txBody>
-      </p:sp>
-      <p:sp>
-        <p:nvSpPr>
-          <p:cNvPr id="9" name="TextBox 8"/>
-          <p:cNvSpPr txBox="1"/>
-          <p:nvPr/>
-        </p:nvSpPr>
-        <p:spPr>
-          <a:xfrm>
-            <a:off x="2423160" y="1828800"/>
-            <a:ext cx="2103120" cy="594360"/>
-          </a:xfrm>
-          <a:prstGeom prst="rect">
-            <a:avLst/>
-          </a:prstGeom>
-          <a:noFill/>
-        </p:spPr>
-        <p:txBody>
-          <a:bodyPr wrap="square" anchor="ctr" lIns="0" rIns="0" tIns="0" bIns="0">
-            <a:spAutoFit/>
-          </a:bodyPr>
-          <a:lstStyle/>
-          <a:p>
-            <a:pPr algn="ctr"/>
-            <a:r>
-              <a:rPr sz="1200" b="1" spc="80">
-                <a:solidFill>
-                  <a:srgbClr val="FFFFFF"/>
-                </a:solidFill>
-                <a:latin typeface="Helvetica Neue"/>
-              </a:rPr>
-              <a:t>Procore</a:t>
-            </a:r>
-          </a:p>
-        </p:txBody>
-      </p:sp>
-      <p:sp>
-        <p:nvSpPr>
-          <p:cNvPr id="10" name="Rounded Rectangle 9"/>
-          <p:cNvSpPr/>
-          <p:nvPr/>
-        </p:nvSpPr>
-        <p:spPr>
-          <a:xfrm>
-            <a:off x="4526280" y="1828800"/>
-            <a:ext cx="2286000" cy="594360"/>
-          </a:xfrm>
-          <a:prstGeom prst="roundRect">
-            <a:avLst>
-              <a:gd name="adj" fmla="val 0"/>
-            </a:avLst>
-          </a:prstGeom>
-          <a:solidFill>
-            <a:srgbClr val="2D3A5A"/>
-          </a:solidFill>
-          <a:ln>
-            <a:noFill/>
-          </a:ln>
-          <a:effectLst/>
-        </p:spPr>
-        <p:style>
-          <a:lnRef idx="1">
-            <a:schemeClr val="accent1"/>
-          </a:lnRef>
-          <a:fillRef idx="3">
-            <a:schemeClr val="accent1"/>
-          </a:fillRef>
-          <a:effectRef idx="2">
-            <a:schemeClr val="accent1"/>
-          </a:effectRef>
-          <a:fontRef idx="minor">
-            <a:schemeClr val="lt1"/>
-          </a:fontRef>
-        </p:style>
-        <p:txBody>
-          <a:bodyPr rtlCol="0" anchor="ctr"/>
-          <a:lstStyle/>
-          <a:p>
-            <a:pPr algn="ctr"/>
-          </a:p>
-        </p:txBody>
-      </p:sp>
-      <p:sp>
-        <p:nvSpPr>
-          <p:cNvPr id="11" name="TextBox 10"/>
-          <p:cNvSpPr txBox="1"/>
-          <p:nvPr/>
-        </p:nvSpPr>
-        <p:spPr>
-          <a:xfrm>
-            <a:off x="4526280" y="1828800"/>
-            <a:ext cx="2286000" cy="594360"/>
-          </a:xfrm>
-          <a:prstGeom prst="rect">
-            <a:avLst/>
-          </a:prstGeom>
-          <a:noFill/>
-        </p:spPr>
-        <p:txBody>
-          <a:bodyPr wrap="square" anchor="ctr" lIns="0" rIns="0" tIns="0" bIns="0">
-            <a:spAutoFit/>
-          </a:bodyPr>
-          <a:lstStyle/>
-          <a:p>
-            <a:pPr algn="ctr"/>
-            <a:r>
-              <a:rPr sz="1200" b="1" spc="80">
-                <a:solidFill>
-                  <a:srgbClr val="FFFFFF"/>
-                </a:solidFill>
-                <a:latin typeface="Helvetica Neue"/>
-              </a:rPr>
-              <a:t>Buildots /</a:t>
-            </a:r>
-          </a:p>
-          <a:p>
-            <a:pPr algn="ctr"/>
-            <a:r>
-              <a:rPr sz="1200" b="1" spc="80">
-                <a:solidFill>
-                  <a:srgbClr val="FFFFFF"/>
-                </a:solidFill>
-                <a:latin typeface="Helvetica Neue"/>
-              </a:rPr>
-              <a:t>OpenSpace</a:t>
-            </a:r>
-          </a:p>
-        </p:txBody>
-      </p:sp>
-      <p:sp>
-        <p:nvSpPr>
-          <p:cNvPr id="12" name="Rounded Rectangle 11"/>
-          <p:cNvSpPr/>
-          <p:nvPr/>
-        </p:nvSpPr>
-        <p:spPr>
-          <a:xfrm>
-            <a:off x="6812280" y="1828800"/>
-            <a:ext cx="2103120" cy="594360"/>
-          </a:xfrm>
-          <a:prstGeom prst="roundRect">
-            <a:avLst>
-              <a:gd name="adj" fmla="val 0"/>
-            </a:avLst>
-          </a:prstGeom>
-          <a:solidFill>
-            <a:srgbClr val="2D3A5A"/>
-          </a:solidFill>
-          <a:ln>
-            <a:noFill/>
-          </a:ln>
-          <a:effectLst/>
-        </p:spPr>
-        <p:style>
-          <a:lnRef idx="1">
-            <a:schemeClr val="accent1"/>
-          </a:lnRef>
-          <a:fillRef idx="3">
-            <a:schemeClr val="accent1"/>
-          </a:fillRef>
-          <a:effectRef idx="2">
-            <a:schemeClr val="accent1"/>
-          </a:effectRef>
-          <a:fontRef idx="minor">
-            <a:schemeClr val="lt1"/>
-          </a:fontRef>
-        </p:style>
-        <p:txBody>
-          <a:bodyPr rtlCol="0" anchor="ctr"/>
-          <a:lstStyle/>
-          <a:p>
-            <a:pPr algn="ctr"/>
-          </a:p>
-        </p:txBody>
-      </p:sp>
-      <p:sp>
-        <p:nvSpPr>
-          <p:cNvPr id="13" name="TextBox 12"/>
-          <p:cNvSpPr txBox="1"/>
-          <p:nvPr/>
-        </p:nvSpPr>
-        <p:spPr>
-          <a:xfrm>
-            <a:off x="6812280" y="1828800"/>
-            <a:ext cx="2103120" cy="594360"/>
-          </a:xfrm>
-          <a:prstGeom prst="rect">
-            <a:avLst/>
-          </a:prstGeom>
-          <a:noFill/>
-        </p:spPr>
-        <p:txBody>
-          <a:bodyPr wrap="square" anchor="ctr" lIns="0" rIns="0" tIns="0" bIns="0">
-            <a:spAutoFit/>
-          </a:bodyPr>
-          <a:lstStyle/>
-          <a:p>
-            <a:pPr algn="ctr"/>
-            <a:r>
-              <a:rPr sz="1200" b="1" spc="80">
-                <a:solidFill>
-                  <a:srgbClr val="FFFFFF"/>
-                </a:solidFill>
-                <a:latin typeface="Helvetica Neue"/>
-              </a:rPr>
-              <a:t>Fieldwire</a:t>
-            </a:r>
-          </a:p>
-        </p:txBody>
-      </p:sp>
-      <p:sp>
-        <p:nvSpPr>
-          <p:cNvPr id="14" name="Rounded Rectangle 13"/>
-          <p:cNvSpPr/>
-          <p:nvPr/>
-        </p:nvSpPr>
-        <p:spPr>
-          <a:xfrm>
-            <a:off x="8915400" y="1828800"/>
-            <a:ext cx="2468880" cy="594360"/>
-          </a:xfrm>
-          <a:prstGeom prst="roundRect">
-            <a:avLst>
-              <a:gd name="adj" fmla="val 15000"/>
+              <a:gd name="adj" fmla="val 5000"/>
             </a:avLst>
           </a:prstGeom>
           <a:solidFill>
@@ -10506,376 +10652,19 @@
       </p:sp>
       <p:sp>
         <p:nvSpPr>
-          <p:cNvPr id="15" name="TextBox 14"/>
-          <p:cNvSpPr txBox="1"/>
-          <p:nvPr/>
-        </p:nvSpPr>
-        <p:spPr>
-          <a:xfrm>
-            <a:off x="8915400" y="1828800"/>
-            <a:ext cx="2468880" cy="594360"/>
-          </a:xfrm>
-          <a:prstGeom prst="rect">
-            <a:avLst/>
-          </a:prstGeom>
-          <a:noFill/>
-        </p:spPr>
-        <p:txBody>
-          <a:bodyPr wrap="square" anchor="ctr" lIns="0" rIns="0" tIns="0" bIns="0">
-            <a:spAutoFit/>
-          </a:bodyPr>
-          <a:lstStyle/>
-          <a:p>
-            <a:pPr algn="ctr"/>
-            <a:r>
-              <a:rPr sz="1200" b="1" spc="80">
-                <a:solidFill>
-                  <a:srgbClr val="FFFFFF"/>
-                </a:solidFill>
-                <a:latin typeface="Helvetica Neue"/>
-              </a:rPr>
-              <a:t>Harpa Pro</a:t>
-            </a:r>
-          </a:p>
-        </p:txBody>
-      </p:sp>
-      <p:sp>
-        <p:nvSpPr>
-          <p:cNvPr id="16" name="Rectangle 15"/>
+          <p:cNvPr id="8" name="Rounded Rectangle 7"/>
           <p:cNvSpPr/>
           <p:nvPr/>
         </p:nvSpPr>
         <p:spPr>
           <a:xfrm>
-            <a:off x="868680" y="2423160"/>
-            <a:ext cx="1554480" cy="594360"/>
-          </a:xfrm>
-          <a:prstGeom prst="rect">
-            <a:avLst/>
-          </a:prstGeom>
-          <a:solidFill>
-            <a:srgbClr val="F1EEE6"/>
-          </a:solidFill>
-          <a:ln w="9525">
-            <a:solidFill>
-              <a:srgbClr val="B9B4A8"/>
-            </a:solidFill>
-          </a:ln>
-          <a:effectLst/>
-        </p:spPr>
-        <p:style>
-          <a:lnRef idx="1">
-            <a:schemeClr val="accent1"/>
-          </a:lnRef>
-          <a:fillRef idx="3">
-            <a:schemeClr val="accent1"/>
-          </a:fillRef>
-          <a:effectRef idx="2">
-            <a:schemeClr val="accent1"/>
-          </a:effectRef>
-          <a:fontRef idx="minor">
-            <a:schemeClr val="lt1"/>
-          </a:fontRef>
-        </p:style>
-        <p:txBody>
-          <a:bodyPr rtlCol="0" anchor="ctr"/>
-          <a:lstStyle/>
-          <a:p>
-            <a:pPr algn="ctr"/>
-          </a:p>
-        </p:txBody>
-      </p:sp>
-      <p:sp>
-        <p:nvSpPr>
-          <p:cNvPr id="17" name="TextBox 16"/>
-          <p:cNvSpPr txBox="1"/>
-          <p:nvPr/>
-        </p:nvSpPr>
-        <p:spPr>
-          <a:xfrm>
-            <a:off x="868680" y="2423160"/>
-            <a:ext cx="1554480" cy="594360"/>
-          </a:xfrm>
-          <a:prstGeom prst="rect">
-            <a:avLst/>
-          </a:prstGeom>
-          <a:noFill/>
-        </p:spPr>
-        <p:txBody>
-          <a:bodyPr wrap="square" anchor="ctr" lIns="0" rIns="0" tIns="0" bIns="0">
-            <a:spAutoFit/>
-          </a:bodyPr>
-          <a:lstStyle/>
-          <a:p>
-            <a:pPr algn="ctr"/>
-            <a:r>
-              <a:rPr sz="1300" b="1">
-                <a:solidFill>
-                  <a:srgbClr val="2D3A5A"/>
-                </a:solidFill>
-                <a:latin typeface="Helvetica Neue"/>
-              </a:rPr>
-              <a:t>Buyer</a:t>
-            </a:r>
-          </a:p>
-        </p:txBody>
-      </p:sp>
-      <p:sp>
-        <p:nvSpPr>
-          <p:cNvPr id="18" name="Rectangle 17"/>
-          <p:cNvSpPr/>
-          <p:nvPr/>
-        </p:nvSpPr>
-        <p:spPr>
-          <a:xfrm>
-            <a:off x="2423160" y="2423160"/>
-            <a:ext cx="2103120" cy="594360"/>
-          </a:xfrm>
-          <a:prstGeom prst="rect">
-            <a:avLst/>
-          </a:prstGeom>
-          <a:solidFill>
-            <a:srgbClr val="FFFFFF"/>
-          </a:solidFill>
-          <a:ln w="9525">
-            <a:solidFill>
-              <a:srgbClr val="B9B4A8"/>
-            </a:solidFill>
-          </a:ln>
-          <a:effectLst/>
-        </p:spPr>
-        <p:style>
-          <a:lnRef idx="1">
-            <a:schemeClr val="accent1"/>
-          </a:lnRef>
-          <a:fillRef idx="3">
-            <a:schemeClr val="accent1"/>
-          </a:fillRef>
-          <a:effectRef idx="2">
-            <a:schemeClr val="accent1"/>
-          </a:effectRef>
-          <a:fontRef idx="minor">
-            <a:schemeClr val="lt1"/>
-          </a:fontRef>
-        </p:style>
-        <p:txBody>
-          <a:bodyPr rtlCol="0" anchor="ctr"/>
-          <a:lstStyle/>
-          <a:p>
-            <a:pPr algn="ctr"/>
-          </a:p>
-        </p:txBody>
-      </p:sp>
-      <p:sp>
-        <p:nvSpPr>
-          <p:cNvPr id="19" name="TextBox 18"/>
-          <p:cNvSpPr txBox="1"/>
-          <p:nvPr/>
-        </p:nvSpPr>
-        <p:spPr>
-          <a:xfrm>
-            <a:off x="2423160" y="2423160"/>
-            <a:ext cx="2103120" cy="594360"/>
-          </a:xfrm>
-          <a:prstGeom prst="rect">
-            <a:avLst/>
-          </a:prstGeom>
-          <a:noFill/>
-        </p:spPr>
-        <p:txBody>
-          <a:bodyPr wrap="square" anchor="ctr" lIns="0" rIns="0" tIns="0" bIns="0">
-            <a:spAutoFit/>
-          </a:bodyPr>
-          <a:lstStyle/>
-          <a:p>
-            <a:pPr algn="ctr"/>
-            <a:r>
-              <a:rPr sz="1300" b="0">
-                <a:solidFill>
-                  <a:srgbClr val="5F5B66"/>
-                </a:solidFill>
-                <a:latin typeface="Helvetica Neue"/>
-              </a:rPr>
-              <a:t>Enterprise GC</a:t>
-            </a:r>
-          </a:p>
-        </p:txBody>
-      </p:sp>
-      <p:sp>
-        <p:nvSpPr>
-          <p:cNvPr id="20" name="Rectangle 19"/>
-          <p:cNvSpPr/>
-          <p:nvPr/>
-        </p:nvSpPr>
-        <p:spPr>
-          <a:xfrm>
-            <a:off x="4526280" y="2423160"/>
-            <a:ext cx="2286000" cy="594360"/>
-          </a:xfrm>
-          <a:prstGeom prst="rect">
-            <a:avLst/>
-          </a:prstGeom>
-          <a:solidFill>
-            <a:srgbClr val="FFFFFF"/>
-          </a:solidFill>
-          <a:ln w="9525">
-            <a:solidFill>
-              <a:srgbClr val="B9B4A8"/>
-            </a:solidFill>
-          </a:ln>
-          <a:effectLst/>
-        </p:spPr>
-        <p:style>
-          <a:lnRef idx="1">
-            <a:schemeClr val="accent1"/>
-          </a:lnRef>
-          <a:fillRef idx="3">
-            <a:schemeClr val="accent1"/>
-          </a:fillRef>
-          <a:effectRef idx="2">
-            <a:schemeClr val="accent1"/>
-          </a:effectRef>
-          <a:fontRef idx="minor">
-            <a:schemeClr val="lt1"/>
-          </a:fontRef>
-        </p:style>
-        <p:txBody>
-          <a:bodyPr rtlCol="0" anchor="ctr"/>
-          <a:lstStyle/>
-          <a:p>
-            <a:pPr algn="ctr"/>
-          </a:p>
-        </p:txBody>
-      </p:sp>
-      <p:sp>
-        <p:nvSpPr>
-          <p:cNvPr id="21" name="TextBox 20"/>
-          <p:cNvSpPr txBox="1"/>
-          <p:nvPr/>
-        </p:nvSpPr>
-        <p:spPr>
-          <a:xfrm>
-            <a:off x="4526280" y="2423160"/>
-            <a:ext cx="2286000" cy="594360"/>
-          </a:xfrm>
-          <a:prstGeom prst="rect">
-            <a:avLst/>
-          </a:prstGeom>
-          <a:noFill/>
-        </p:spPr>
-        <p:txBody>
-          <a:bodyPr wrap="square" anchor="ctr" lIns="0" rIns="0" tIns="0" bIns="0">
-            <a:spAutoFit/>
-          </a:bodyPr>
-          <a:lstStyle/>
-          <a:p>
-            <a:pPr algn="ctr"/>
-            <a:r>
-              <a:rPr sz="1300" b="0">
-                <a:solidFill>
-                  <a:srgbClr val="5F5B66"/>
-                </a:solidFill>
-                <a:latin typeface="Helvetica Neue"/>
-              </a:rPr>
-              <a:t>Enterprise GC</a:t>
-            </a:r>
-          </a:p>
-        </p:txBody>
-      </p:sp>
-      <p:sp>
-        <p:nvSpPr>
-          <p:cNvPr id="22" name="Rectangle 21"/>
-          <p:cNvSpPr/>
-          <p:nvPr/>
-        </p:nvSpPr>
-        <p:spPr>
-          <a:xfrm>
-            <a:off x="6812280" y="2423160"/>
-            <a:ext cx="2103120" cy="594360"/>
-          </a:xfrm>
-          <a:prstGeom prst="rect">
-            <a:avLst/>
-          </a:prstGeom>
-          <a:solidFill>
-            <a:srgbClr val="FFFFFF"/>
-          </a:solidFill>
-          <a:ln w="9525">
-            <a:solidFill>
-              <a:srgbClr val="B9B4A8"/>
-            </a:solidFill>
-          </a:ln>
-          <a:effectLst/>
-        </p:spPr>
-        <p:style>
-          <a:lnRef idx="1">
-            <a:schemeClr val="accent1"/>
-          </a:lnRef>
-          <a:fillRef idx="3">
-            <a:schemeClr val="accent1"/>
-          </a:fillRef>
-          <a:effectRef idx="2">
-            <a:schemeClr val="accent1"/>
-          </a:effectRef>
-          <a:fontRef idx="minor">
-            <a:schemeClr val="lt1"/>
-          </a:fontRef>
-        </p:style>
-        <p:txBody>
-          <a:bodyPr rtlCol="0" anchor="ctr"/>
-          <a:lstStyle/>
-          <a:p>
-            <a:pPr algn="ctr"/>
-          </a:p>
-        </p:txBody>
-      </p:sp>
-      <p:sp>
-        <p:nvSpPr>
-          <p:cNvPr id="23" name="TextBox 22"/>
-          <p:cNvSpPr txBox="1"/>
-          <p:nvPr/>
-        </p:nvSpPr>
-        <p:spPr>
-          <a:xfrm>
-            <a:off x="6812280" y="2423160"/>
-            <a:ext cx="2103120" cy="594360"/>
-          </a:xfrm>
-          <a:prstGeom prst="rect">
-            <a:avLst/>
-          </a:prstGeom>
-          <a:noFill/>
-        </p:spPr>
-        <p:txBody>
-          <a:bodyPr wrap="square" anchor="ctr" lIns="0" rIns="0" tIns="0" bIns="0">
-            <a:spAutoFit/>
-          </a:bodyPr>
-          <a:lstStyle/>
-          <a:p>
-            <a:pPr algn="ctr"/>
-            <a:r>
-              <a:rPr sz="1300" b="0">
-                <a:solidFill>
-                  <a:srgbClr val="5F5B66"/>
-                </a:solidFill>
-                <a:latin typeface="Helvetica Neue"/>
-              </a:rPr>
-              <a:t>Mid-market</a:t>
-            </a:r>
-          </a:p>
-        </p:txBody>
-      </p:sp>
-      <p:sp>
-        <p:nvSpPr>
-          <p:cNvPr id="24" name="Rectangle 23"/>
-          <p:cNvSpPr/>
-          <p:nvPr/>
-        </p:nvSpPr>
-        <p:spPr>
-          <a:xfrm>
-            <a:off x="8915400" y="2423160"/>
-            <a:ext cx="2468880" cy="594360"/>
-          </a:xfrm>
-          <a:prstGeom prst="rect">
-            <a:avLst/>
+            <a:off x="960120" y="5212080"/>
+            <a:ext cx="10378440" cy="914400"/>
+          </a:xfrm>
+          <a:prstGeom prst="roundRect">
+            <a:avLst>
+              <a:gd name="adj" fmla="val 5000"/>
+            </a:avLst>
           </a:prstGeom>
           <a:solidFill>
             <a:srgbClr val="FFFDF8"/>
@@ -10911,14 +10700,14 @@
       </p:sp>
       <p:sp>
         <p:nvSpPr>
-          <p:cNvPr id="25" name="TextBox 24"/>
+          <p:cNvPr id="9" name="TextBox 8"/>
           <p:cNvSpPr txBox="1"/>
           <p:nvPr/>
         </p:nvSpPr>
         <p:spPr>
           <a:xfrm>
-            <a:off x="8915400" y="2423160"/>
-            <a:ext cx="2468880" cy="594360"/>
+            <a:off x="1234440" y="5349240"/>
+            <a:ext cx="10469880" cy="274320"/>
           </a:xfrm>
           <a:prstGeom prst="rect">
             <a:avLst/>
@@ -10926,1300 +10715,74 @@
           <a:noFill/>
         </p:spPr>
         <p:txBody>
-          <a:bodyPr wrap="square" anchor="ctr" lIns="0" rIns="0" tIns="0" bIns="0">
+          <a:bodyPr wrap="square" anchor="t" lIns="0" rIns="0" tIns="0" bIns="0">
             <a:spAutoFit/>
           </a:bodyPr>
           <a:lstStyle/>
           <a:p>
-            <a:pPr algn="ctr"/>
-            <a:r>
-              <a:rPr sz="1300" b="1">
+            <a:pPr algn="l"/>
+            <a:r>
+              <a:rPr sz="1000" b="1" spc="160">
+                <a:solidFill>
+                  <a:srgbClr val="EA580C"/>
+                </a:solidFill>
+                <a:latin typeface="Helvetica Neue"/>
+              </a:rPr>
+              <a:t>OUR WEDGE</a:t>
+            </a:r>
+          </a:p>
+        </p:txBody>
+      </p:sp>
+      <p:sp>
+        <p:nvSpPr>
+          <p:cNvPr id="10" name="TextBox 9"/>
+          <p:cNvSpPr txBox="1"/>
+          <p:nvPr/>
+        </p:nvSpPr>
+        <p:spPr>
+          <a:xfrm>
+            <a:off x="1234440" y="5623560"/>
+            <a:ext cx="9738360" cy="457200"/>
+          </a:xfrm>
+          <a:prstGeom prst="rect">
+            <a:avLst/>
+          </a:prstGeom>
+          <a:noFill/>
+        </p:spPr>
+        <p:txBody>
+          <a:bodyPr wrap="square" anchor="t" lIns="0" rIns="0" tIns="0" bIns="0">
+            <a:spAutoFit/>
+          </a:bodyPr>
+          <a:lstStyle/>
+          <a:p>
+            <a:pPr algn="l"/>
+            <a:r>
+              <a:rPr sz="1500" b="1">
                 <a:solidFill>
                   <a:srgbClr val="2D3A5A"/>
                 </a:solidFill>
                 <a:latin typeface="Helvetica Neue"/>
               </a:rPr>
-              <a:t>Site supervisor</a:t>
-            </a:r>
-          </a:p>
-        </p:txBody>
-      </p:sp>
-      <p:sp>
-        <p:nvSpPr>
-          <p:cNvPr id="26" name="Rectangle 25"/>
+              <a:t>Voice-first input  ·  supervisor-grade UX  ·  onboarding in minutes, not weeks.</a:t>
+            </a:r>
+          </a:p>
+        </p:txBody>
+      </p:sp>
+      <p:sp>
+        <p:nvSpPr>
+          <p:cNvPr id="11" name="Rounded Rectangle 10"/>
           <p:cNvSpPr/>
           <p:nvPr/>
         </p:nvSpPr>
         <p:spPr>
           <a:xfrm>
-            <a:off x="868680" y="3017520"/>
-            <a:ext cx="1554480" cy="594360"/>
-          </a:xfrm>
-          <a:prstGeom prst="rect">
-            <a:avLst/>
-          </a:prstGeom>
-          <a:solidFill>
-            <a:srgbClr val="F1EEE6"/>
-          </a:solidFill>
-          <a:ln w="9525">
-            <a:solidFill>
-              <a:srgbClr val="B9B4A8"/>
-            </a:solidFill>
-          </a:ln>
-          <a:effectLst/>
-        </p:spPr>
-        <p:style>
-          <a:lnRef idx="1">
-            <a:schemeClr val="accent1"/>
-          </a:lnRef>
-          <a:fillRef idx="3">
-            <a:schemeClr val="accent1"/>
-          </a:fillRef>
-          <a:effectRef idx="2">
-            <a:schemeClr val="accent1"/>
-          </a:effectRef>
-          <a:fontRef idx="minor">
-            <a:schemeClr val="lt1"/>
-          </a:fontRef>
-        </p:style>
-        <p:txBody>
-          <a:bodyPr rtlCol="0" anchor="ctr"/>
-          <a:lstStyle/>
-          <a:p>
-            <a:pPr algn="ctr"/>
-          </a:p>
-        </p:txBody>
-      </p:sp>
-      <p:sp>
-        <p:nvSpPr>
-          <p:cNvPr id="27" name="TextBox 26"/>
-          <p:cNvSpPr txBox="1"/>
-          <p:nvPr/>
-        </p:nvSpPr>
-        <p:spPr>
-          <a:xfrm>
-            <a:off x="868680" y="3017520"/>
-            <a:ext cx="1554480" cy="594360"/>
-          </a:xfrm>
-          <a:prstGeom prst="rect">
-            <a:avLst/>
-          </a:prstGeom>
-          <a:noFill/>
-        </p:spPr>
-        <p:txBody>
-          <a:bodyPr wrap="square" anchor="ctr" lIns="0" rIns="0" tIns="0" bIns="0">
-            <a:spAutoFit/>
-          </a:bodyPr>
-          <a:lstStyle/>
-          <a:p>
-            <a:pPr algn="ctr"/>
-            <a:r>
-              <a:rPr sz="1300" b="1">
-                <a:solidFill>
-                  <a:srgbClr val="2D3A5A"/>
-                </a:solidFill>
-                <a:latin typeface="Helvetica Neue"/>
-              </a:rPr>
-              <a:t>Input</a:t>
-            </a:r>
-          </a:p>
-        </p:txBody>
-      </p:sp>
-      <p:sp>
-        <p:nvSpPr>
-          <p:cNvPr id="28" name="Rectangle 27"/>
-          <p:cNvSpPr/>
-          <p:nvPr/>
-        </p:nvSpPr>
-        <p:spPr>
-          <a:xfrm>
-            <a:off x="2423160" y="3017520"/>
-            <a:ext cx="2103120" cy="594360"/>
-          </a:xfrm>
-          <a:prstGeom prst="rect">
-            <a:avLst/>
-          </a:prstGeom>
-          <a:solidFill>
-            <a:srgbClr val="F1EEE6"/>
-          </a:solidFill>
-          <a:ln w="9525">
-            <a:solidFill>
-              <a:srgbClr val="B9B4A8"/>
-            </a:solidFill>
-          </a:ln>
-          <a:effectLst/>
-        </p:spPr>
-        <p:style>
-          <a:lnRef idx="1">
-            <a:schemeClr val="accent1"/>
-          </a:lnRef>
-          <a:fillRef idx="3">
-            <a:schemeClr val="accent1"/>
-          </a:fillRef>
-          <a:effectRef idx="2">
-            <a:schemeClr val="accent1"/>
-          </a:effectRef>
-          <a:fontRef idx="minor">
-            <a:schemeClr val="lt1"/>
-          </a:fontRef>
-        </p:style>
-        <p:txBody>
-          <a:bodyPr rtlCol="0" anchor="ctr"/>
-          <a:lstStyle/>
-          <a:p>
-            <a:pPr algn="ctr"/>
-          </a:p>
-        </p:txBody>
-      </p:sp>
-      <p:sp>
-        <p:nvSpPr>
-          <p:cNvPr id="29" name="TextBox 28"/>
-          <p:cNvSpPr txBox="1"/>
-          <p:nvPr/>
-        </p:nvSpPr>
-        <p:spPr>
-          <a:xfrm>
-            <a:off x="2423160" y="3017520"/>
-            <a:ext cx="2103120" cy="594360"/>
-          </a:xfrm>
-          <a:prstGeom prst="rect">
-            <a:avLst/>
-          </a:prstGeom>
-          <a:noFill/>
-        </p:spPr>
-        <p:txBody>
-          <a:bodyPr wrap="square" anchor="ctr" lIns="0" rIns="0" tIns="0" bIns="0">
-            <a:spAutoFit/>
-          </a:bodyPr>
-          <a:lstStyle/>
-          <a:p>
-            <a:pPr algn="ctr"/>
-            <a:r>
-              <a:rPr sz="1300" b="0">
-                <a:solidFill>
-                  <a:srgbClr val="5F5B66"/>
-                </a:solidFill>
-                <a:latin typeface="Helvetica Neue"/>
-              </a:rPr>
-              <a:t>Manual forms</a:t>
-            </a:r>
-          </a:p>
-        </p:txBody>
-      </p:sp>
-      <p:sp>
-        <p:nvSpPr>
-          <p:cNvPr id="30" name="Rectangle 29"/>
-          <p:cNvSpPr/>
-          <p:nvPr/>
-        </p:nvSpPr>
-        <p:spPr>
-          <a:xfrm>
-            <a:off x="4526280" y="3017520"/>
-            <a:ext cx="2286000" cy="594360"/>
-          </a:xfrm>
-          <a:prstGeom prst="rect">
-            <a:avLst/>
-          </a:prstGeom>
-          <a:solidFill>
-            <a:srgbClr val="F1EEE6"/>
-          </a:solidFill>
-          <a:ln w="9525">
-            <a:solidFill>
-              <a:srgbClr val="B9B4A8"/>
-            </a:solidFill>
-          </a:ln>
-          <a:effectLst/>
-        </p:spPr>
-        <p:style>
-          <a:lnRef idx="1">
-            <a:schemeClr val="accent1"/>
-          </a:lnRef>
-          <a:fillRef idx="3">
-            <a:schemeClr val="accent1"/>
-          </a:fillRef>
-          <a:effectRef idx="2">
-            <a:schemeClr val="accent1"/>
-          </a:effectRef>
-          <a:fontRef idx="minor">
-            <a:schemeClr val="lt1"/>
-          </a:fontRef>
-        </p:style>
-        <p:txBody>
-          <a:bodyPr rtlCol="0" anchor="ctr"/>
-          <a:lstStyle/>
-          <a:p>
-            <a:pPr algn="ctr"/>
-          </a:p>
-        </p:txBody>
-      </p:sp>
-      <p:sp>
-        <p:nvSpPr>
-          <p:cNvPr id="31" name="TextBox 30"/>
-          <p:cNvSpPr txBox="1"/>
-          <p:nvPr/>
-        </p:nvSpPr>
-        <p:spPr>
-          <a:xfrm>
-            <a:off x="4526280" y="3017520"/>
-            <a:ext cx="2286000" cy="594360"/>
-          </a:xfrm>
-          <a:prstGeom prst="rect">
-            <a:avLst/>
-          </a:prstGeom>
-          <a:noFill/>
-        </p:spPr>
-        <p:txBody>
-          <a:bodyPr wrap="square" anchor="ctr" lIns="0" rIns="0" tIns="0" bIns="0">
-            <a:spAutoFit/>
-          </a:bodyPr>
-          <a:lstStyle/>
-          <a:p>
-            <a:pPr algn="ctr"/>
-            <a:r>
-              <a:rPr sz="1300" b="0">
-                <a:solidFill>
-                  <a:srgbClr val="5F5B66"/>
-                </a:solidFill>
-                <a:latin typeface="Helvetica Neue"/>
-              </a:rPr>
-              <a:t>360° camera</a:t>
-            </a:r>
-          </a:p>
-        </p:txBody>
-      </p:sp>
-      <p:sp>
-        <p:nvSpPr>
-          <p:cNvPr id="32" name="Rectangle 31"/>
-          <p:cNvSpPr/>
-          <p:nvPr/>
-        </p:nvSpPr>
-        <p:spPr>
-          <a:xfrm>
-            <a:off x="6812280" y="3017520"/>
-            <a:ext cx="2103120" cy="594360"/>
-          </a:xfrm>
-          <a:prstGeom prst="rect">
-            <a:avLst/>
-          </a:prstGeom>
-          <a:solidFill>
-            <a:srgbClr val="F1EEE6"/>
-          </a:solidFill>
-          <a:ln w="9525">
-            <a:solidFill>
-              <a:srgbClr val="B9B4A8"/>
-            </a:solidFill>
-          </a:ln>
-          <a:effectLst/>
-        </p:spPr>
-        <p:style>
-          <a:lnRef idx="1">
-            <a:schemeClr val="accent1"/>
-          </a:lnRef>
-          <a:fillRef idx="3">
-            <a:schemeClr val="accent1"/>
-          </a:fillRef>
-          <a:effectRef idx="2">
-            <a:schemeClr val="accent1"/>
-          </a:effectRef>
-          <a:fontRef idx="minor">
-            <a:schemeClr val="lt1"/>
-          </a:fontRef>
-        </p:style>
-        <p:txBody>
-          <a:bodyPr rtlCol="0" anchor="ctr"/>
-          <a:lstStyle/>
-          <a:p>
-            <a:pPr algn="ctr"/>
-          </a:p>
-        </p:txBody>
-      </p:sp>
-      <p:sp>
-        <p:nvSpPr>
-          <p:cNvPr id="33" name="TextBox 32"/>
-          <p:cNvSpPr txBox="1"/>
-          <p:nvPr/>
-        </p:nvSpPr>
-        <p:spPr>
-          <a:xfrm>
-            <a:off x="6812280" y="3017520"/>
-            <a:ext cx="2103120" cy="594360"/>
-          </a:xfrm>
-          <a:prstGeom prst="rect">
-            <a:avLst/>
-          </a:prstGeom>
-          <a:noFill/>
-        </p:spPr>
-        <p:txBody>
-          <a:bodyPr wrap="square" anchor="ctr" lIns="0" rIns="0" tIns="0" bIns="0">
-            <a:spAutoFit/>
-          </a:bodyPr>
-          <a:lstStyle/>
-          <a:p>
-            <a:pPr algn="ctr"/>
-            <a:r>
-              <a:rPr sz="1300" b="0">
-                <a:solidFill>
-                  <a:srgbClr val="5F5B66"/>
-                </a:solidFill>
-                <a:latin typeface="Helvetica Neue"/>
-              </a:rPr>
-              <a:t>Manual forms</a:t>
-            </a:r>
-          </a:p>
-        </p:txBody>
-      </p:sp>
-      <p:sp>
-        <p:nvSpPr>
-          <p:cNvPr id="34" name="Rectangle 33"/>
-          <p:cNvSpPr/>
-          <p:nvPr/>
-        </p:nvSpPr>
-        <p:spPr>
-          <a:xfrm>
-            <a:off x="8915400" y="3017520"/>
-            <a:ext cx="2468880" cy="594360"/>
-          </a:xfrm>
-          <a:prstGeom prst="rect">
-            <a:avLst/>
-          </a:prstGeom>
-          <a:solidFill>
-            <a:srgbClr val="FFFDF8"/>
-          </a:solidFill>
-          <a:ln w="9525">
-            <a:solidFill>
-              <a:srgbClr val="B9B4A8"/>
-            </a:solidFill>
-          </a:ln>
-          <a:effectLst/>
-        </p:spPr>
-        <p:style>
-          <a:lnRef idx="1">
-            <a:schemeClr val="accent1"/>
-          </a:lnRef>
-          <a:fillRef idx="3">
-            <a:schemeClr val="accent1"/>
-          </a:fillRef>
-          <a:effectRef idx="2">
-            <a:schemeClr val="accent1"/>
-          </a:effectRef>
-          <a:fontRef idx="minor">
-            <a:schemeClr val="lt1"/>
-          </a:fontRef>
-        </p:style>
-        <p:txBody>
-          <a:bodyPr rtlCol="0" anchor="ctr"/>
-          <a:lstStyle/>
-          <a:p>
-            <a:pPr algn="ctr"/>
-          </a:p>
-        </p:txBody>
-      </p:sp>
-      <p:sp>
-        <p:nvSpPr>
-          <p:cNvPr id="35" name="TextBox 34"/>
-          <p:cNvSpPr txBox="1"/>
-          <p:nvPr/>
-        </p:nvSpPr>
-        <p:spPr>
-          <a:xfrm>
-            <a:off x="8915400" y="3017520"/>
-            <a:ext cx="2468880" cy="594360"/>
-          </a:xfrm>
-          <a:prstGeom prst="rect">
-            <a:avLst/>
-          </a:prstGeom>
-          <a:noFill/>
-        </p:spPr>
-        <p:txBody>
-          <a:bodyPr wrap="square" anchor="ctr" lIns="0" rIns="0" tIns="0" bIns="0">
-            <a:spAutoFit/>
-          </a:bodyPr>
-          <a:lstStyle/>
-          <a:p>
-            <a:pPr algn="ctr"/>
-            <a:r>
-              <a:rPr sz="1300" b="1">
-                <a:solidFill>
-                  <a:srgbClr val="2D3A5A"/>
-                </a:solidFill>
-                <a:latin typeface="Helvetica Neue"/>
-              </a:rPr>
-              <a:t>Voice</a:t>
-            </a:r>
-          </a:p>
-        </p:txBody>
-      </p:sp>
-      <p:sp>
-        <p:nvSpPr>
-          <p:cNvPr id="36" name="Rectangle 35"/>
-          <p:cNvSpPr/>
-          <p:nvPr/>
-        </p:nvSpPr>
-        <p:spPr>
-          <a:xfrm>
-            <a:off x="868680" y="3611880"/>
-            <a:ext cx="1554480" cy="594360"/>
-          </a:xfrm>
-          <a:prstGeom prst="rect">
-            <a:avLst/>
-          </a:prstGeom>
-          <a:solidFill>
-            <a:srgbClr val="F1EEE6"/>
-          </a:solidFill>
-          <a:ln w="9525">
-            <a:solidFill>
-              <a:srgbClr val="B9B4A8"/>
-            </a:solidFill>
-          </a:ln>
-          <a:effectLst/>
-        </p:spPr>
-        <p:style>
-          <a:lnRef idx="1">
-            <a:schemeClr val="accent1"/>
-          </a:lnRef>
-          <a:fillRef idx="3">
-            <a:schemeClr val="accent1"/>
-          </a:fillRef>
-          <a:effectRef idx="2">
-            <a:schemeClr val="accent1"/>
-          </a:effectRef>
-          <a:fontRef idx="minor">
-            <a:schemeClr val="lt1"/>
-          </a:fontRef>
-        </p:style>
-        <p:txBody>
-          <a:bodyPr rtlCol="0" anchor="ctr"/>
-          <a:lstStyle/>
-          <a:p>
-            <a:pPr algn="ctr"/>
-          </a:p>
-        </p:txBody>
-      </p:sp>
-      <p:sp>
-        <p:nvSpPr>
-          <p:cNvPr id="37" name="TextBox 36"/>
-          <p:cNvSpPr txBox="1"/>
-          <p:nvPr/>
-        </p:nvSpPr>
-        <p:spPr>
-          <a:xfrm>
-            <a:off x="868680" y="3611880"/>
-            <a:ext cx="1554480" cy="594360"/>
-          </a:xfrm>
-          <a:prstGeom prst="rect">
-            <a:avLst/>
-          </a:prstGeom>
-          <a:noFill/>
-        </p:spPr>
-        <p:txBody>
-          <a:bodyPr wrap="square" anchor="ctr" lIns="0" rIns="0" tIns="0" bIns="0">
-            <a:spAutoFit/>
-          </a:bodyPr>
-          <a:lstStyle/>
-          <a:p>
-            <a:pPr algn="ctr"/>
-            <a:r>
-              <a:rPr sz="1300" b="1">
-                <a:solidFill>
-                  <a:srgbClr val="2D3A5A"/>
-                </a:solidFill>
-                <a:latin typeface="Helvetica Neue"/>
-              </a:rPr>
-              <a:t>Onboarding</a:t>
-            </a:r>
-          </a:p>
-        </p:txBody>
-      </p:sp>
-      <p:sp>
-        <p:nvSpPr>
-          <p:cNvPr id="38" name="Rectangle 37"/>
-          <p:cNvSpPr/>
-          <p:nvPr/>
-        </p:nvSpPr>
-        <p:spPr>
-          <a:xfrm>
-            <a:off x="2423160" y="3611880"/>
-            <a:ext cx="2103120" cy="594360"/>
-          </a:xfrm>
-          <a:prstGeom prst="rect">
-            <a:avLst/>
-          </a:prstGeom>
-          <a:solidFill>
-            <a:srgbClr val="FFFFFF"/>
-          </a:solidFill>
-          <a:ln w="9525">
-            <a:solidFill>
-              <a:srgbClr val="B9B4A8"/>
-            </a:solidFill>
-          </a:ln>
-          <a:effectLst/>
-        </p:spPr>
-        <p:style>
-          <a:lnRef idx="1">
-            <a:schemeClr val="accent1"/>
-          </a:lnRef>
-          <a:fillRef idx="3">
-            <a:schemeClr val="accent1"/>
-          </a:fillRef>
-          <a:effectRef idx="2">
-            <a:schemeClr val="accent1"/>
-          </a:effectRef>
-          <a:fontRef idx="minor">
-            <a:schemeClr val="lt1"/>
-          </a:fontRef>
-        </p:style>
-        <p:txBody>
-          <a:bodyPr rtlCol="0" anchor="ctr"/>
-          <a:lstStyle/>
-          <a:p>
-            <a:pPr algn="ctr"/>
-          </a:p>
-        </p:txBody>
-      </p:sp>
-      <p:sp>
-        <p:nvSpPr>
-          <p:cNvPr id="39" name="TextBox 38"/>
-          <p:cNvSpPr txBox="1"/>
-          <p:nvPr/>
-        </p:nvSpPr>
-        <p:spPr>
-          <a:xfrm>
-            <a:off x="2423160" y="3611880"/>
-            <a:ext cx="2103120" cy="594360"/>
-          </a:xfrm>
-          <a:prstGeom prst="rect">
-            <a:avLst/>
-          </a:prstGeom>
-          <a:noFill/>
-        </p:spPr>
-        <p:txBody>
-          <a:bodyPr wrap="square" anchor="ctr" lIns="0" rIns="0" tIns="0" bIns="0">
-            <a:spAutoFit/>
-          </a:bodyPr>
-          <a:lstStyle/>
-          <a:p>
-            <a:pPr algn="ctr"/>
-            <a:r>
-              <a:rPr sz="1300" b="0">
-                <a:solidFill>
-                  <a:srgbClr val="5F5B66"/>
-                </a:solidFill>
-                <a:latin typeface="Helvetica Neue"/>
-              </a:rPr>
-              <a:t>Weeks</a:t>
-            </a:r>
-          </a:p>
-        </p:txBody>
-      </p:sp>
-      <p:sp>
-        <p:nvSpPr>
-          <p:cNvPr id="40" name="Rectangle 39"/>
-          <p:cNvSpPr/>
-          <p:nvPr/>
-        </p:nvSpPr>
-        <p:spPr>
-          <a:xfrm>
-            <a:off x="4526280" y="3611880"/>
-            <a:ext cx="2286000" cy="594360"/>
-          </a:xfrm>
-          <a:prstGeom prst="rect">
-            <a:avLst/>
-          </a:prstGeom>
-          <a:solidFill>
-            <a:srgbClr val="FFFFFF"/>
-          </a:solidFill>
-          <a:ln w="9525">
-            <a:solidFill>
-              <a:srgbClr val="B9B4A8"/>
-            </a:solidFill>
-          </a:ln>
-          <a:effectLst/>
-        </p:spPr>
-        <p:style>
-          <a:lnRef idx="1">
-            <a:schemeClr val="accent1"/>
-          </a:lnRef>
-          <a:fillRef idx="3">
-            <a:schemeClr val="accent1"/>
-          </a:fillRef>
-          <a:effectRef idx="2">
-            <a:schemeClr val="accent1"/>
-          </a:effectRef>
-          <a:fontRef idx="minor">
-            <a:schemeClr val="lt1"/>
-          </a:fontRef>
-        </p:style>
-        <p:txBody>
-          <a:bodyPr rtlCol="0" anchor="ctr"/>
-          <a:lstStyle/>
-          <a:p>
-            <a:pPr algn="ctr"/>
-          </a:p>
-        </p:txBody>
-      </p:sp>
-      <p:sp>
-        <p:nvSpPr>
-          <p:cNvPr id="41" name="TextBox 40"/>
-          <p:cNvSpPr txBox="1"/>
-          <p:nvPr/>
-        </p:nvSpPr>
-        <p:spPr>
-          <a:xfrm>
-            <a:off x="4526280" y="3611880"/>
-            <a:ext cx="2286000" cy="594360"/>
-          </a:xfrm>
-          <a:prstGeom prst="rect">
-            <a:avLst/>
-          </a:prstGeom>
-          <a:noFill/>
-        </p:spPr>
-        <p:txBody>
-          <a:bodyPr wrap="square" anchor="ctr" lIns="0" rIns="0" tIns="0" bIns="0">
-            <a:spAutoFit/>
-          </a:bodyPr>
-          <a:lstStyle/>
-          <a:p>
-            <a:pPr algn="ctr"/>
-            <a:r>
-              <a:rPr sz="1300" b="0">
-                <a:solidFill>
-                  <a:srgbClr val="5F5B66"/>
-                </a:solidFill>
-                <a:latin typeface="Helvetica Neue"/>
-              </a:rPr>
-              <a:t>Weeks</a:t>
-            </a:r>
-          </a:p>
-        </p:txBody>
-      </p:sp>
-      <p:sp>
-        <p:nvSpPr>
-          <p:cNvPr id="42" name="Rectangle 41"/>
-          <p:cNvSpPr/>
-          <p:nvPr/>
-        </p:nvSpPr>
-        <p:spPr>
-          <a:xfrm>
-            <a:off x="6812280" y="3611880"/>
-            <a:ext cx="2103120" cy="594360"/>
-          </a:xfrm>
-          <a:prstGeom prst="rect">
-            <a:avLst/>
-          </a:prstGeom>
-          <a:solidFill>
-            <a:srgbClr val="FFFFFF"/>
-          </a:solidFill>
-          <a:ln w="9525">
-            <a:solidFill>
-              <a:srgbClr val="B9B4A8"/>
-            </a:solidFill>
-          </a:ln>
-          <a:effectLst/>
-        </p:spPr>
-        <p:style>
-          <a:lnRef idx="1">
-            <a:schemeClr val="accent1"/>
-          </a:lnRef>
-          <a:fillRef idx="3">
-            <a:schemeClr val="accent1"/>
-          </a:fillRef>
-          <a:effectRef idx="2">
-            <a:schemeClr val="accent1"/>
-          </a:effectRef>
-          <a:fontRef idx="minor">
-            <a:schemeClr val="lt1"/>
-          </a:fontRef>
-        </p:style>
-        <p:txBody>
-          <a:bodyPr rtlCol="0" anchor="ctr"/>
-          <a:lstStyle/>
-          <a:p>
-            <a:pPr algn="ctr"/>
-          </a:p>
-        </p:txBody>
-      </p:sp>
-      <p:sp>
-        <p:nvSpPr>
-          <p:cNvPr id="43" name="TextBox 42"/>
-          <p:cNvSpPr txBox="1"/>
-          <p:nvPr/>
-        </p:nvSpPr>
-        <p:spPr>
-          <a:xfrm>
-            <a:off x="6812280" y="3611880"/>
-            <a:ext cx="2103120" cy="594360"/>
-          </a:xfrm>
-          <a:prstGeom prst="rect">
-            <a:avLst/>
-          </a:prstGeom>
-          <a:noFill/>
-        </p:spPr>
-        <p:txBody>
-          <a:bodyPr wrap="square" anchor="ctr" lIns="0" rIns="0" tIns="0" bIns="0">
-            <a:spAutoFit/>
-          </a:bodyPr>
-          <a:lstStyle/>
-          <a:p>
-            <a:pPr algn="ctr"/>
-            <a:r>
-              <a:rPr sz="1300" b="0">
-                <a:solidFill>
-                  <a:srgbClr val="5F5B66"/>
-                </a:solidFill>
-                <a:latin typeface="Helvetica Neue"/>
-              </a:rPr>
-              <a:t>Days</a:t>
-            </a:r>
-          </a:p>
-        </p:txBody>
-      </p:sp>
-      <p:sp>
-        <p:nvSpPr>
-          <p:cNvPr id="44" name="Rectangle 43"/>
-          <p:cNvSpPr/>
-          <p:nvPr/>
-        </p:nvSpPr>
-        <p:spPr>
-          <a:xfrm>
-            <a:off x="8915400" y="3611880"/>
-            <a:ext cx="2468880" cy="594360"/>
-          </a:xfrm>
-          <a:prstGeom prst="rect">
-            <a:avLst/>
-          </a:prstGeom>
-          <a:solidFill>
-            <a:srgbClr val="FFFDF8"/>
-          </a:solidFill>
-          <a:ln w="9525">
-            <a:solidFill>
-              <a:srgbClr val="B9B4A8"/>
-            </a:solidFill>
-          </a:ln>
-          <a:effectLst/>
-        </p:spPr>
-        <p:style>
-          <a:lnRef idx="1">
-            <a:schemeClr val="accent1"/>
-          </a:lnRef>
-          <a:fillRef idx="3">
-            <a:schemeClr val="accent1"/>
-          </a:fillRef>
-          <a:effectRef idx="2">
-            <a:schemeClr val="accent1"/>
-          </a:effectRef>
-          <a:fontRef idx="minor">
-            <a:schemeClr val="lt1"/>
-          </a:fontRef>
-        </p:style>
-        <p:txBody>
-          <a:bodyPr rtlCol="0" anchor="ctr"/>
-          <a:lstStyle/>
-          <a:p>
-            <a:pPr algn="ctr"/>
-          </a:p>
-        </p:txBody>
-      </p:sp>
-      <p:sp>
-        <p:nvSpPr>
-          <p:cNvPr id="45" name="TextBox 44"/>
-          <p:cNvSpPr txBox="1"/>
-          <p:nvPr/>
-        </p:nvSpPr>
-        <p:spPr>
-          <a:xfrm>
-            <a:off x="8915400" y="3611880"/>
-            <a:ext cx="2468880" cy="594360"/>
-          </a:xfrm>
-          <a:prstGeom prst="rect">
-            <a:avLst/>
-          </a:prstGeom>
-          <a:noFill/>
-        </p:spPr>
-        <p:txBody>
-          <a:bodyPr wrap="square" anchor="ctr" lIns="0" rIns="0" tIns="0" bIns="0">
-            <a:spAutoFit/>
-          </a:bodyPr>
-          <a:lstStyle/>
-          <a:p>
-            <a:pPr algn="ctr"/>
-            <a:r>
-              <a:rPr sz="1300" b="1">
-                <a:solidFill>
-                  <a:srgbClr val="2D3A5A"/>
-                </a:solidFill>
-                <a:latin typeface="Helvetica Neue"/>
-              </a:rPr>
-              <a:t>Minutes</a:t>
-            </a:r>
-          </a:p>
-        </p:txBody>
-      </p:sp>
-      <p:sp>
-        <p:nvSpPr>
-          <p:cNvPr id="46" name="Rectangle 45"/>
-          <p:cNvSpPr/>
-          <p:nvPr/>
-        </p:nvSpPr>
-        <p:spPr>
-          <a:xfrm>
-            <a:off x="868680" y="4206240"/>
-            <a:ext cx="1554480" cy="594360"/>
-          </a:xfrm>
-          <a:prstGeom prst="rect">
-            <a:avLst/>
-          </a:prstGeom>
-          <a:solidFill>
-            <a:srgbClr val="F1EEE6"/>
-          </a:solidFill>
-          <a:ln w="9525">
-            <a:solidFill>
-              <a:srgbClr val="B9B4A8"/>
-            </a:solidFill>
-          </a:ln>
-          <a:effectLst/>
-        </p:spPr>
-        <p:style>
-          <a:lnRef idx="1">
-            <a:schemeClr val="accent1"/>
-          </a:lnRef>
-          <a:fillRef idx="3">
-            <a:schemeClr val="accent1"/>
-          </a:fillRef>
-          <a:effectRef idx="2">
-            <a:schemeClr val="accent1"/>
-          </a:effectRef>
-          <a:fontRef idx="minor">
-            <a:schemeClr val="lt1"/>
-          </a:fontRef>
-        </p:style>
-        <p:txBody>
-          <a:bodyPr rtlCol="0" anchor="ctr"/>
-          <a:lstStyle/>
-          <a:p>
-            <a:pPr algn="ctr"/>
-          </a:p>
-        </p:txBody>
-      </p:sp>
-      <p:sp>
-        <p:nvSpPr>
-          <p:cNvPr id="47" name="TextBox 46"/>
-          <p:cNvSpPr txBox="1"/>
-          <p:nvPr/>
-        </p:nvSpPr>
-        <p:spPr>
-          <a:xfrm>
-            <a:off x="868680" y="4206240"/>
-            <a:ext cx="1554480" cy="594360"/>
-          </a:xfrm>
-          <a:prstGeom prst="rect">
-            <a:avLst/>
-          </a:prstGeom>
-          <a:noFill/>
-        </p:spPr>
-        <p:txBody>
-          <a:bodyPr wrap="square" anchor="ctr" lIns="0" rIns="0" tIns="0" bIns="0">
-            <a:spAutoFit/>
-          </a:bodyPr>
-          <a:lstStyle/>
-          <a:p>
-            <a:pPr algn="ctr"/>
-            <a:r>
-              <a:rPr sz="1300" b="1">
-                <a:solidFill>
-                  <a:srgbClr val="2D3A5A"/>
-                </a:solidFill>
-                <a:latin typeface="Helvetica Neue"/>
-              </a:rPr>
-              <a:t>Price tier</a:t>
-            </a:r>
-          </a:p>
-        </p:txBody>
-      </p:sp>
-      <p:sp>
-        <p:nvSpPr>
-          <p:cNvPr id="48" name="Rectangle 47"/>
-          <p:cNvSpPr/>
-          <p:nvPr/>
-        </p:nvSpPr>
-        <p:spPr>
-          <a:xfrm>
-            <a:off x="2423160" y="4206240"/>
-            <a:ext cx="2103120" cy="594360"/>
-          </a:xfrm>
-          <a:prstGeom prst="rect">
-            <a:avLst/>
-          </a:prstGeom>
-          <a:solidFill>
-            <a:srgbClr val="F1EEE6"/>
-          </a:solidFill>
-          <a:ln w="9525">
-            <a:solidFill>
-              <a:srgbClr val="B9B4A8"/>
-            </a:solidFill>
-          </a:ln>
-          <a:effectLst/>
-        </p:spPr>
-        <p:style>
-          <a:lnRef idx="1">
-            <a:schemeClr val="accent1"/>
-          </a:lnRef>
-          <a:fillRef idx="3">
-            <a:schemeClr val="accent1"/>
-          </a:fillRef>
-          <a:effectRef idx="2">
-            <a:schemeClr val="accent1"/>
-          </a:effectRef>
-          <a:fontRef idx="minor">
-            <a:schemeClr val="lt1"/>
-          </a:fontRef>
-        </p:style>
-        <p:txBody>
-          <a:bodyPr rtlCol="0" anchor="ctr"/>
-          <a:lstStyle/>
-          <a:p>
-            <a:pPr algn="ctr"/>
-          </a:p>
-        </p:txBody>
-      </p:sp>
-      <p:sp>
-        <p:nvSpPr>
-          <p:cNvPr id="49" name="TextBox 48"/>
-          <p:cNvSpPr txBox="1"/>
-          <p:nvPr/>
-        </p:nvSpPr>
-        <p:spPr>
-          <a:xfrm>
-            <a:off x="2423160" y="4206240"/>
-            <a:ext cx="2103120" cy="594360"/>
-          </a:xfrm>
-          <a:prstGeom prst="rect">
-            <a:avLst/>
-          </a:prstGeom>
-          <a:noFill/>
-        </p:spPr>
-        <p:txBody>
-          <a:bodyPr wrap="square" anchor="ctr" lIns="0" rIns="0" tIns="0" bIns="0">
-            <a:spAutoFit/>
-          </a:bodyPr>
-          <a:lstStyle/>
-          <a:p>
-            <a:pPr algn="ctr"/>
-            <a:r>
-              <a:rPr sz="1300" b="0">
-                <a:solidFill>
-                  <a:srgbClr val="5F5B66"/>
-                </a:solidFill>
-                <a:latin typeface="Helvetica Neue"/>
-              </a:rPr>
-              <a:t>$$$$</a:t>
-            </a:r>
-          </a:p>
-        </p:txBody>
-      </p:sp>
-      <p:sp>
-        <p:nvSpPr>
-          <p:cNvPr id="50" name="Rectangle 49"/>
-          <p:cNvSpPr/>
-          <p:nvPr/>
-        </p:nvSpPr>
-        <p:spPr>
-          <a:xfrm>
-            <a:off x="4526280" y="4206240"/>
-            <a:ext cx="2286000" cy="594360"/>
-          </a:xfrm>
-          <a:prstGeom prst="rect">
-            <a:avLst/>
-          </a:prstGeom>
-          <a:solidFill>
-            <a:srgbClr val="F1EEE6"/>
-          </a:solidFill>
-          <a:ln w="9525">
-            <a:solidFill>
-              <a:srgbClr val="B9B4A8"/>
-            </a:solidFill>
-          </a:ln>
-          <a:effectLst/>
-        </p:spPr>
-        <p:style>
-          <a:lnRef idx="1">
-            <a:schemeClr val="accent1"/>
-          </a:lnRef>
-          <a:fillRef idx="3">
-            <a:schemeClr val="accent1"/>
-          </a:fillRef>
-          <a:effectRef idx="2">
-            <a:schemeClr val="accent1"/>
-          </a:effectRef>
-          <a:fontRef idx="minor">
-            <a:schemeClr val="lt1"/>
-          </a:fontRef>
-        </p:style>
-        <p:txBody>
-          <a:bodyPr rtlCol="0" anchor="ctr"/>
-          <a:lstStyle/>
-          <a:p>
-            <a:pPr algn="ctr"/>
-          </a:p>
-        </p:txBody>
-      </p:sp>
-      <p:sp>
-        <p:nvSpPr>
-          <p:cNvPr id="51" name="TextBox 50"/>
-          <p:cNvSpPr txBox="1"/>
-          <p:nvPr/>
-        </p:nvSpPr>
-        <p:spPr>
-          <a:xfrm>
-            <a:off x="4526280" y="4206240"/>
-            <a:ext cx="2286000" cy="594360"/>
-          </a:xfrm>
-          <a:prstGeom prst="rect">
-            <a:avLst/>
-          </a:prstGeom>
-          <a:noFill/>
-        </p:spPr>
-        <p:txBody>
-          <a:bodyPr wrap="square" anchor="ctr" lIns="0" rIns="0" tIns="0" bIns="0">
-            <a:spAutoFit/>
-          </a:bodyPr>
-          <a:lstStyle/>
-          <a:p>
-            <a:pPr algn="ctr"/>
-            <a:r>
-              <a:rPr sz="1300" b="0">
-                <a:solidFill>
-                  <a:srgbClr val="5F5B66"/>
-                </a:solidFill>
-                <a:latin typeface="Helvetica Neue"/>
-              </a:rPr>
-              <a:t>$$$$</a:t>
-            </a:r>
-          </a:p>
-        </p:txBody>
-      </p:sp>
-      <p:sp>
-        <p:nvSpPr>
-          <p:cNvPr id="52" name="Rectangle 51"/>
-          <p:cNvSpPr/>
-          <p:nvPr/>
-        </p:nvSpPr>
-        <p:spPr>
-          <a:xfrm>
-            <a:off x="6812280" y="4206240"/>
-            <a:ext cx="2103120" cy="594360"/>
-          </a:xfrm>
-          <a:prstGeom prst="rect">
-            <a:avLst/>
-          </a:prstGeom>
-          <a:solidFill>
-            <a:srgbClr val="F1EEE6"/>
-          </a:solidFill>
-          <a:ln w="9525">
-            <a:solidFill>
-              <a:srgbClr val="B9B4A8"/>
-            </a:solidFill>
-          </a:ln>
-          <a:effectLst/>
-        </p:spPr>
-        <p:style>
-          <a:lnRef idx="1">
-            <a:schemeClr val="accent1"/>
-          </a:lnRef>
-          <a:fillRef idx="3">
-            <a:schemeClr val="accent1"/>
-          </a:fillRef>
-          <a:effectRef idx="2">
-            <a:schemeClr val="accent1"/>
-          </a:effectRef>
-          <a:fontRef idx="minor">
-            <a:schemeClr val="lt1"/>
-          </a:fontRef>
-        </p:style>
-        <p:txBody>
-          <a:bodyPr rtlCol="0" anchor="ctr"/>
-          <a:lstStyle/>
-          <a:p>
-            <a:pPr algn="ctr"/>
-          </a:p>
-        </p:txBody>
-      </p:sp>
-      <p:sp>
-        <p:nvSpPr>
-          <p:cNvPr id="53" name="TextBox 52"/>
-          <p:cNvSpPr txBox="1"/>
-          <p:nvPr/>
-        </p:nvSpPr>
-        <p:spPr>
-          <a:xfrm>
-            <a:off x="6812280" y="4206240"/>
-            <a:ext cx="2103120" cy="594360"/>
-          </a:xfrm>
-          <a:prstGeom prst="rect">
-            <a:avLst/>
-          </a:prstGeom>
-          <a:noFill/>
-        </p:spPr>
-        <p:txBody>
-          <a:bodyPr wrap="square" anchor="ctr" lIns="0" rIns="0" tIns="0" bIns="0">
-            <a:spAutoFit/>
-          </a:bodyPr>
-          <a:lstStyle/>
-          <a:p>
-            <a:pPr algn="ctr"/>
-            <a:r>
-              <a:rPr sz="1300" b="0">
-                <a:solidFill>
-                  <a:srgbClr val="5F5B66"/>
-                </a:solidFill>
-                <a:latin typeface="Helvetica Neue"/>
-              </a:rPr>
-              <a:t>$$$</a:t>
-            </a:r>
-          </a:p>
-        </p:txBody>
-      </p:sp>
-      <p:sp>
-        <p:nvSpPr>
-          <p:cNvPr id="54" name="Rectangle 53"/>
-          <p:cNvSpPr/>
-          <p:nvPr/>
-        </p:nvSpPr>
-        <p:spPr>
-          <a:xfrm>
-            <a:off x="8915400" y="4206240"/>
-            <a:ext cx="2468880" cy="594360"/>
-          </a:xfrm>
-          <a:prstGeom prst="rect">
-            <a:avLst/>
-          </a:prstGeom>
-          <a:solidFill>
-            <a:srgbClr val="FFFDF8"/>
-          </a:solidFill>
-          <a:ln w="9525">
-            <a:solidFill>
-              <a:srgbClr val="B9B4A8"/>
-            </a:solidFill>
-          </a:ln>
-          <a:effectLst/>
-        </p:spPr>
-        <p:style>
-          <a:lnRef idx="1">
-            <a:schemeClr val="accent1"/>
-          </a:lnRef>
-          <a:fillRef idx="3">
-            <a:schemeClr val="accent1"/>
-          </a:fillRef>
-          <a:effectRef idx="2">
-            <a:schemeClr val="accent1"/>
-          </a:effectRef>
-          <a:fontRef idx="minor">
-            <a:schemeClr val="lt1"/>
-          </a:fontRef>
-        </p:style>
-        <p:txBody>
-          <a:bodyPr rtlCol="0" anchor="ctr"/>
-          <a:lstStyle/>
-          <a:p>
-            <a:pPr algn="ctr"/>
-          </a:p>
-        </p:txBody>
-      </p:sp>
-      <p:sp>
-        <p:nvSpPr>
-          <p:cNvPr id="55" name="TextBox 54"/>
-          <p:cNvSpPr txBox="1"/>
-          <p:nvPr/>
-        </p:nvSpPr>
-        <p:spPr>
-          <a:xfrm>
-            <a:off x="8915400" y="4206240"/>
-            <a:ext cx="2468880" cy="594360"/>
-          </a:xfrm>
-          <a:prstGeom prst="rect">
-            <a:avLst/>
-          </a:prstGeom>
-          <a:noFill/>
-        </p:spPr>
-        <p:txBody>
-          <a:bodyPr wrap="square" anchor="ctr" lIns="0" rIns="0" tIns="0" bIns="0">
-            <a:spAutoFit/>
-          </a:bodyPr>
-          <a:lstStyle/>
-          <a:p>
-            <a:pPr algn="ctr"/>
-            <a:r>
-              <a:rPr sz="1300" b="1">
-                <a:solidFill>
-                  <a:srgbClr val="2D3A5A"/>
-                </a:solidFill>
-                <a:latin typeface="Helvetica Neue"/>
-              </a:rPr>
-              <a:t>$</a:t>
-            </a:r>
-          </a:p>
-        </p:txBody>
-      </p:sp>
-      <p:sp>
-        <p:nvSpPr>
-          <p:cNvPr id="56" name="Rounded Rectangle 55"/>
-          <p:cNvSpPr/>
-          <p:nvPr/>
-        </p:nvSpPr>
-        <p:spPr>
-          <a:xfrm>
-            <a:off x="868680" y="5029200"/>
-            <a:ext cx="10469880" cy="914400"/>
+            <a:off x="868680" y="6492240"/>
+            <a:ext cx="164592" cy="164592"/>
           </a:xfrm>
           <a:prstGeom prst="roundRect">
             <a:avLst>
-              <a:gd name="adj" fmla="val 5000"/>
+              <a:gd name="adj" fmla="val 50000"/>
             </a:avLst>
-          </a:prstGeom>
-          <a:solidFill>
-            <a:srgbClr val="FFFDF8"/>
-          </a:solidFill>
-          <a:ln w="9525">
-            <a:solidFill>
-              <a:srgbClr val="B9B4A8"/>
-            </a:solidFill>
-          </a:ln>
-          <a:effectLst/>
-        </p:spPr>
-        <p:style>
-          <a:lnRef idx="1">
-            <a:schemeClr val="accent1"/>
-          </a:lnRef>
-          <a:fillRef idx="3">
-            <a:schemeClr val="accent1"/>
-          </a:fillRef>
-          <a:effectRef idx="2">
-            <a:schemeClr val="accent1"/>
-          </a:effectRef>
-          <a:fontRef idx="minor">
-            <a:schemeClr val="lt1"/>
-          </a:fontRef>
-        </p:style>
-        <p:txBody>
-          <a:bodyPr rtlCol="0" anchor="ctr"/>
-          <a:lstStyle/>
-          <a:p>
-            <a:pPr algn="ctr"/>
-          </a:p>
-        </p:txBody>
-      </p:sp>
-      <p:sp>
-        <p:nvSpPr>
-          <p:cNvPr id="57" name="Rectangle 56"/>
-          <p:cNvSpPr/>
-          <p:nvPr/>
-        </p:nvSpPr>
-        <p:spPr>
-          <a:xfrm>
-            <a:off x="868680" y="5029200"/>
-            <a:ext cx="73152" cy="914400"/>
-          </a:xfrm>
-          <a:prstGeom prst="rect">
-            <a:avLst/>
           </a:prstGeom>
           <a:solidFill>
             <a:srgbClr val="EA580C"/>
@@ -12253,14 +10816,14 @@
       </p:sp>
       <p:sp>
         <p:nvSpPr>
-          <p:cNvPr id="58" name="TextBox 57"/>
+          <p:cNvPr id="12" name="TextBox 11"/>
           <p:cNvSpPr txBox="1"/>
           <p:nvPr/>
         </p:nvSpPr>
         <p:spPr>
           <a:xfrm>
-            <a:off x="1234440" y="5166360"/>
-            <a:ext cx="10469880" cy="274320"/>
+            <a:off x="1143000" y="6446520"/>
+            <a:ext cx="2286000" cy="274320"/>
           </a:xfrm>
           <a:prstGeom prst="rect">
             <a:avLst/>
@@ -12275,27 +10838,27 @@
           <a:p>
             <a:pPr algn="l"/>
             <a:r>
-              <a:rPr sz="1000" b="1" spc="160">
-                <a:solidFill>
-                  <a:srgbClr val="EA580C"/>
+              <a:rPr sz="1000" b="1">
+                <a:solidFill>
+                  <a:srgbClr val="2D3A5A"/>
                 </a:solidFill>
                 <a:latin typeface="Helvetica Neue"/>
               </a:rPr>
-              <a:t>OUR WEDGE</a:t>
-            </a:r>
-          </a:p>
-        </p:txBody>
-      </p:sp>
-      <p:sp>
-        <p:nvSpPr>
-          <p:cNvPr id="59" name="TextBox 58"/>
+              <a:t>Harpa Pro</a:t>
+            </a:r>
+          </a:p>
+        </p:txBody>
+      </p:sp>
+      <p:sp>
+        <p:nvSpPr>
+          <p:cNvPr id="13" name="TextBox 12"/>
           <p:cNvSpPr txBox="1"/>
           <p:nvPr/>
         </p:nvSpPr>
         <p:spPr>
           <a:xfrm>
-            <a:off x="1234440" y="5440680"/>
-            <a:ext cx="9738360" cy="457200"/>
+            <a:off x="10241280" y="6446520"/>
+            <a:ext cx="1097280" cy="274320"/>
           </a:xfrm>
           <a:prstGeom prst="rect">
             <a:avLst/>
@@ -12308,122 +10871,6 @@
           </a:bodyPr>
           <a:lstStyle/>
           <a:p>
-            <a:pPr algn="l"/>
-            <a:r>
-              <a:rPr sz="1500" b="1">
-                <a:solidFill>
-                  <a:srgbClr val="2D3A5A"/>
-                </a:solidFill>
-                <a:latin typeface="Helvetica Neue"/>
-              </a:rPr>
-              <a:t>Voice-first input  ·  supervisor-grade UX  ·  onboarding in minutes, not weeks.</a:t>
-            </a:r>
-          </a:p>
-        </p:txBody>
-      </p:sp>
-      <p:sp>
-        <p:nvSpPr>
-          <p:cNvPr id="60" name="Rounded Rectangle 59"/>
-          <p:cNvSpPr/>
-          <p:nvPr/>
-        </p:nvSpPr>
-        <p:spPr>
-          <a:xfrm>
-            <a:off x="868680" y="6492240"/>
-            <a:ext cx="164592" cy="164592"/>
-          </a:xfrm>
-          <a:prstGeom prst="roundRect">
-            <a:avLst>
-              <a:gd name="adj" fmla="val 50000"/>
-            </a:avLst>
-          </a:prstGeom>
-          <a:solidFill>
-            <a:srgbClr val="EA580C"/>
-          </a:solidFill>
-          <a:ln>
-            <a:noFill/>
-          </a:ln>
-          <a:effectLst/>
-        </p:spPr>
-        <p:style>
-          <a:lnRef idx="1">
-            <a:schemeClr val="accent1"/>
-          </a:lnRef>
-          <a:fillRef idx="3">
-            <a:schemeClr val="accent1"/>
-          </a:fillRef>
-          <a:effectRef idx="2">
-            <a:schemeClr val="accent1"/>
-          </a:effectRef>
-          <a:fontRef idx="minor">
-            <a:schemeClr val="lt1"/>
-          </a:fontRef>
-        </p:style>
-        <p:txBody>
-          <a:bodyPr rtlCol="0" anchor="ctr"/>
-          <a:lstStyle/>
-          <a:p>
-            <a:pPr algn="ctr"/>
-          </a:p>
-        </p:txBody>
-      </p:sp>
-      <p:sp>
-        <p:nvSpPr>
-          <p:cNvPr id="61" name="TextBox 60"/>
-          <p:cNvSpPr txBox="1"/>
-          <p:nvPr/>
-        </p:nvSpPr>
-        <p:spPr>
-          <a:xfrm>
-            <a:off x="1143000" y="6446520"/>
-            <a:ext cx="2286000" cy="274320"/>
-          </a:xfrm>
-          <a:prstGeom prst="rect">
-            <a:avLst/>
-          </a:prstGeom>
-          <a:noFill/>
-        </p:spPr>
-        <p:txBody>
-          <a:bodyPr wrap="square" anchor="t" lIns="0" rIns="0" tIns="0" bIns="0">
-            <a:spAutoFit/>
-          </a:bodyPr>
-          <a:lstStyle/>
-          <a:p>
-            <a:pPr algn="l"/>
-            <a:r>
-              <a:rPr sz="1000" b="1">
-                <a:solidFill>
-                  <a:srgbClr val="2D3A5A"/>
-                </a:solidFill>
-                <a:latin typeface="Helvetica Neue"/>
-              </a:rPr>
-              <a:t>Harpa Pro</a:t>
-            </a:r>
-          </a:p>
-        </p:txBody>
-      </p:sp>
-      <p:sp>
-        <p:nvSpPr>
-          <p:cNvPr id="62" name="TextBox 61"/>
-          <p:cNvSpPr txBox="1"/>
-          <p:nvPr/>
-        </p:nvSpPr>
-        <p:spPr>
-          <a:xfrm>
-            <a:off x="10241280" y="6446520"/>
-            <a:ext cx="1097280" cy="274320"/>
-          </a:xfrm>
-          <a:prstGeom prst="rect">
-            <a:avLst/>
-          </a:prstGeom>
-          <a:noFill/>
-        </p:spPr>
-        <p:txBody>
-          <a:bodyPr wrap="square" anchor="t" lIns="0" rIns="0" tIns="0" bIns="0">
-            <a:spAutoFit/>
-          </a:bodyPr>
-          <a:lstStyle/>
-          <a:p>
             <a:pPr algn="r"/>
             <a:r>
               <a:rPr sz="1000" b="0">
@@ -12439,7 +10886,7 @@
       </p:sp>
       <p:sp>
         <p:nvSpPr>
-          <p:cNvPr id="63" name="TextBox 62"/>
+          <p:cNvPr id="14" name="TextBox 13"/>
           <p:cNvSpPr txBox="1"/>
           <p:nvPr/>
         </p:nvSpPr>
@@ -12665,56 +11112,58 @@
             </a:avLst>
           </a:prstGeom>
           <a:solidFill>
+            <a:srgbClr val="EA580C"/>
+          </a:solidFill>
+          <a:ln>
+            <a:noFill/>
+          </a:ln>
+          <a:effectLst/>
+        </p:spPr>
+        <p:style>
+          <a:lnRef idx="1">
+            <a:schemeClr val="accent1"/>
+          </a:lnRef>
+          <a:fillRef idx="3">
+            <a:schemeClr val="accent1"/>
+          </a:fillRef>
+          <a:effectRef idx="2">
+            <a:schemeClr val="accent1"/>
+          </a:effectRef>
+          <a:fontRef idx="minor">
+            <a:schemeClr val="lt1"/>
+          </a:fontRef>
+        </p:style>
+        <p:txBody>
+          <a:bodyPr rtlCol="0" anchor="ctr"/>
+          <a:lstStyle/>
+          <a:p>
+            <a:pPr algn="ctr"/>
+          </a:p>
+        </p:txBody>
+      </p:sp>
+      <p:sp>
+        <p:nvSpPr>
+          <p:cNvPr id="7" name="Rounded Rectangle 6"/>
+          <p:cNvSpPr/>
+          <p:nvPr/>
+        </p:nvSpPr>
+        <p:spPr>
+          <a:xfrm>
+            <a:off x="495147" y="2103120"/>
+            <a:ext cx="2697480" cy="2606040"/>
+          </a:xfrm>
+          <a:prstGeom prst="roundRect">
+            <a:avLst>
+              <a:gd name="adj" fmla="val 5000"/>
+            </a:avLst>
+          </a:prstGeom>
+          <a:solidFill>
             <a:srgbClr val="FFFDF8"/>
           </a:solidFill>
           <a:ln w="9525">
             <a:solidFill>
               <a:srgbClr val="B9B4A8"/>
             </a:solidFill>
-          </a:ln>
-          <a:effectLst/>
-        </p:spPr>
-        <p:style>
-          <a:lnRef idx="1">
-            <a:schemeClr val="accent1"/>
-          </a:lnRef>
-          <a:fillRef idx="3">
-            <a:schemeClr val="accent1"/>
-          </a:fillRef>
-          <a:effectRef idx="2">
-            <a:schemeClr val="accent1"/>
-          </a:effectRef>
-          <a:fontRef idx="minor">
-            <a:schemeClr val="lt1"/>
-          </a:fontRef>
-        </p:style>
-        <p:txBody>
-          <a:bodyPr rtlCol="0" anchor="ctr"/>
-          <a:lstStyle/>
-          <a:p>
-            <a:pPr algn="ctr"/>
-          </a:p>
-        </p:txBody>
-      </p:sp>
-      <p:sp>
-        <p:nvSpPr>
-          <p:cNvPr id="7" name="Rectangle 6"/>
-          <p:cNvSpPr/>
-          <p:nvPr/>
-        </p:nvSpPr>
-        <p:spPr>
-          <a:xfrm>
-            <a:off x="495147" y="2011680"/>
-            <a:ext cx="2697480" cy="73152"/>
-          </a:xfrm>
-          <a:prstGeom prst="rect">
-            <a:avLst/>
-          </a:prstGeom>
-          <a:solidFill>
-            <a:srgbClr val="EA580C"/>
-          </a:solidFill>
-          <a:ln>
-            <a:noFill/>
           </a:ln>
           <a:effectLst/>
         </p:spPr>

</xml_diff>

<commit_message>
docs(investor): update Harpa-Pro-Deck v2 presentation
</commit_message>
<xml_diff>
--- a/docs/investor/Harpa-Pro-Deck-v2.pptx
+++ b/docs/investor/Harpa-Pro-Deck-v2.pptx
@@ -5,18 +5,18 @@
     <p:sldMasterId id="2147483648" r:id="rId1"/>
   </p:sldMasterIdLst>
   <p:sldIdLst>
-    <p:sldId id="256" r:id="rId7"/>
-    <p:sldId id="257" r:id="rId8"/>
-    <p:sldId id="258" r:id="rId9"/>
-    <p:sldId id="259" r:id="rId10"/>
-    <p:sldId id="260" r:id="rId11"/>
-    <p:sldId id="261" r:id="rId12"/>
-    <p:sldId id="262" r:id="rId13"/>
-    <p:sldId id="263" r:id="rId14"/>
-    <p:sldId id="264" r:id="rId15"/>
-    <p:sldId id="265" r:id="rId16"/>
+    <p:sldId id="256" r:id="rId2"/>
+    <p:sldId id="257" r:id="rId3"/>
+    <p:sldId id="258" r:id="rId4"/>
+    <p:sldId id="259" r:id="rId5"/>
+    <p:sldId id="260" r:id="rId6"/>
+    <p:sldId id="261" r:id="rId7"/>
+    <p:sldId id="262" r:id="rId8"/>
+    <p:sldId id="263" r:id="rId9"/>
+    <p:sldId id="264" r:id="rId10"/>
+    <p:sldId id="265" r:id="rId11"/>
   </p:sldIdLst>
-  <p:sldSz cx="12191695" cy="6858000" type="screen4x3"/>
+  <p:sldSz cx="12192000" cy="6858000"/>
   <p:notesSz cx="6858000" cy="9144000"/>
   <p:defaultTextStyle>
     <a:defPPr>
@@ -113,6 +113,22 @@
       </a:defRPr>
     </a:lvl9pPr>
   </p:defaultTextStyle>
+  <p:extLst>
+    <p:ext uri="{EFAFB233-063F-42B5-8137-9DF3F51BA10A}">
+      <p15:sldGuideLst xmlns:p15="http://schemas.microsoft.com/office/powerpoint/2012/main">
+        <p15:guide id="1" orient="horz" pos="2160">
+          <p15:clr>
+            <a:srgbClr val="A4A3A4"/>
+          </p15:clr>
+        </p15:guide>
+        <p15:guide id="2" pos="2880">
+          <p15:clr>
+            <a:srgbClr val="A4A3A4"/>
+          </p15:clr>
+        </p15:guide>
+      </p15:sldGuideLst>
+    </p:ext>
+  </p:extLst>
 </p:presentation>
 </file>
 
@@ -154,10 +170,9 @@
           <a:lstStyle/>
           <a:p>
             <a:r>
-              <a:rPr lang="en-US" smtClean="0"/>
+              <a:rPr lang="en-US"/>
               <a:t>Click to edit Master title style</a:t>
             </a:r>
-            <a:endParaRPr lang="en-US"/>
           </a:p>
         </p:txBody>
       </p:sp>
@@ -273,10 +288,9 @@
           </a:lstStyle>
           <a:p>
             <a:r>
-              <a:rPr lang="en-US" smtClean="0"/>
+              <a:rPr lang="en-US"/>
               <a:t>Click to edit Master subtitle style</a:t>
             </a:r>
-            <a:endParaRPr lang="en-US"/>
           </a:p>
         </p:txBody>
       </p:sp>
@@ -297,7 +311,7 @@
           <a:p>
             <a:fld id="{5BCAD085-E8A6-8845-BD4E-CB4CCA059FC4}" type="datetimeFigureOut">
               <a:rPr lang="en-US" smtClean="0"/>
-              <a:t>1/27/13</a:t>
+              <a:t>5/7/26</a:t>
             </a:fld>
             <a:endParaRPr lang="en-US"/>
           </a:p>
@@ -391,10 +405,9 @@
           <a:lstStyle/>
           <a:p>
             <a:r>
-              <a:rPr lang="en-US" smtClean="0"/>
+              <a:rPr lang="en-US"/>
               <a:t>Click to edit Master title style</a:t>
             </a:r>
-            <a:endParaRPr lang="en-US"/>
           </a:p>
         </p:txBody>
       </p:sp>
@@ -415,38 +428,37 @@
           <a:p>
             <a:pPr lvl="0"/>
             <a:r>
-              <a:rPr lang="en-US" smtClean="0"/>
+              <a:rPr lang="en-US"/>
               <a:t>Click to edit Master text styles</a:t>
             </a:r>
           </a:p>
           <a:p>
             <a:pPr lvl="1"/>
             <a:r>
-              <a:rPr lang="en-US" smtClean="0"/>
+              <a:rPr lang="en-US"/>
               <a:t>Second level</a:t>
             </a:r>
           </a:p>
           <a:p>
             <a:pPr lvl="2"/>
             <a:r>
-              <a:rPr lang="en-US" smtClean="0"/>
+              <a:rPr lang="en-US"/>
               <a:t>Third level</a:t>
             </a:r>
           </a:p>
           <a:p>
             <a:pPr lvl="3"/>
             <a:r>
-              <a:rPr lang="en-US" smtClean="0"/>
+              <a:rPr lang="en-US"/>
               <a:t>Fourth level</a:t>
             </a:r>
           </a:p>
           <a:p>
             <a:pPr lvl="4"/>
             <a:r>
-              <a:rPr lang="en-US" smtClean="0"/>
+              <a:rPr lang="en-US"/>
               <a:t>Fifth level</a:t>
             </a:r>
-            <a:endParaRPr lang="en-US"/>
           </a:p>
         </p:txBody>
       </p:sp>
@@ -467,7 +479,7 @@
           <a:p>
             <a:fld id="{5BCAD085-E8A6-8845-BD4E-CB4CCA059FC4}" type="datetimeFigureOut">
               <a:rPr lang="en-US" smtClean="0"/>
-              <a:t>1/27/13</a:t>
+              <a:t>5/7/26</a:t>
             </a:fld>
             <a:endParaRPr lang="en-US"/>
           </a:p>
@@ -566,10 +578,9 @@
           <a:lstStyle/>
           <a:p>
             <a:r>
-              <a:rPr lang="en-US" smtClean="0"/>
+              <a:rPr lang="en-US"/>
               <a:t>Click to edit Master title style</a:t>
             </a:r>
-            <a:endParaRPr lang="en-US"/>
           </a:p>
         </p:txBody>
       </p:sp>
@@ -595,38 +606,37 @@
           <a:p>
             <a:pPr lvl="0"/>
             <a:r>
-              <a:rPr lang="en-US" smtClean="0"/>
+              <a:rPr lang="en-US"/>
               <a:t>Click to edit Master text styles</a:t>
             </a:r>
           </a:p>
           <a:p>
             <a:pPr lvl="1"/>
             <a:r>
-              <a:rPr lang="en-US" smtClean="0"/>
+              <a:rPr lang="en-US"/>
               <a:t>Second level</a:t>
             </a:r>
           </a:p>
           <a:p>
             <a:pPr lvl="2"/>
             <a:r>
-              <a:rPr lang="en-US" smtClean="0"/>
+              <a:rPr lang="en-US"/>
               <a:t>Third level</a:t>
             </a:r>
           </a:p>
           <a:p>
             <a:pPr lvl="3"/>
             <a:r>
-              <a:rPr lang="en-US" smtClean="0"/>
+              <a:rPr lang="en-US"/>
               <a:t>Fourth level</a:t>
             </a:r>
           </a:p>
           <a:p>
             <a:pPr lvl="4"/>
             <a:r>
-              <a:rPr lang="en-US" smtClean="0"/>
+              <a:rPr lang="en-US"/>
               <a:t>Fifth level</a:t>
             </a:r>
-            <a:endParaRPr lang="en-US"/>
           </a:p>
         </p:txBody>
       </p:sp>
@@ -647,7 +657,7 @@
           <a:p>
             <a:fld id="{5BCAD085-E8A6-8845-BD4E-CB4CCA059FC4}" type="datetimeFigureOut">
               <a:rPr lang="en-US" smtClean="0"/>
-              <a:t>1/27/13</a:t>
+              <a:t>5/7/26</a:t>
             </a:fld>
             <a:endParaRPr lang="en-US"/>
           </a:p>
@@ -741,10 +751,9 @@
           <a:lstStyle/>
           <a:p>
             <a:r>
-              <a:rPr lang="en-US" smtClean="0"/>
+              <a:rPr lang="en-US"/>
               <a:t>Click to edit Master title style</a:t>
             </a:r>
-            <a:endParaRPr lang="en-US"/>
           </a:p>
         </p:txBody>
       </p:sp>
@@ -765,38 +774,37 @@
           <a:p>
             <a:pPr lvl="0"/>
             <a:r>
-              <a:rPr lang="en-US" smtClean="0"/>
+              <a:rPr lang="en-US"/>
               <a:t>Click to edit Master text styles</a:t>
             </a:r>
           </a:p>
           <a:p>
             <a:pPr lvl="1"/>
             <a:r>
-              <a:rPr lang="en-US" smtClean="0"/>
+              <a:rPr lang="en-US"/>
               <a:t>Second level</a:t>
             </a:r>
           </a:p>
           <a:p>
             <a:pPr lvl="2"/>
             <a:r>
-              <a:rPr lang="en-US" smtClean="0"/>
+              <a:rPr lang="en-US"/>
               <a:t>Third level</a:t>
             </a:r>
           </a:p>
           <a:p>
             <a:pPr lvl="3"/>
             <a:r>
-              <a:rPr lang="en-US" smtClean="0"/>
+              <a:rPr lang="en-US"/>
               <a:t>Fourth level</a:t>
             </a:r>
           </a:p>
           <a:p>
             <a:pPr lvl="4"/>
             <a:r>
-              <a:rPr lang="en-US" smtClean="0"/>
+              <a:rPr lang="en-US"/>
               <a:t>Fifth level</a:t>
             </a:r>
-            <a:endParaRPr lang="en-US"/>
           </a:p>
         </p:txBody>
       </p:sp>
@@ -817,7 +825,7 @@
           <a:p>
             <a:fld id="{5BCAD085-E8A6-8845-BD4E-CB4CCA059FC4}" type="datetimeFigureOut">
               <a:rPr lang="en-US" smtClean="0"/>
-              <a:t>1/27/13</a:t>
+              <a:t>5/7/26</a:t>
             </a:fld>
             <a:endParaRPr lang="en-US"/>
           </a:p>
@@ -920,10 +928,9 @@
           </a:lstStyle>
           <a:p>
             <a:r>
-              <a:rPr lang="en-US" smtClean="0"/>
+              <a:rPr lang="en-US"/>
               <a:t>Click to edit Master title style</a:t>
             </a:r>
-            <a:endParaRPr lang="en-US"/>
           </a:p>
         </p:txBody>
       </p:sp>
@@ -1040,7 +1047,7 @@
           <a:p>
             <a:pPr lvl="0"/>
             <a:r>
-              <a:rPr lang="en-US" smtClean="0"/>
+              <a:rPr lang="en-US"/>
               <a:t>Click to edit Master text styles</a:t>
             </a:r>
           </a:p>
@@ -1063,7 +1070,7 @@
           <a:p>
             <a:fld id="{5BCAD085-E8A6-8845-BD4E-CB4CCA059FC4}" type="datetimeFigureOut">
               <a:rPr lang="en-US" smtClean="0"/>
-              <a:t>1/27/13</a:t>
+              <a:t>5/7/26</a:t>
             </a:fld>
             <a:endParaRPr lang="en-US"/>
           </a:p>
@@ -1157,10 +1164,9 @@
           <a:lstStyle/>
           <a:p>
             <a:r>
-              <a:rPr lang="en-US" smtClean="0"/>
+              <a:rPr lang="en-US"/>
               <a:t>Click to edit Master title style</a:t>
             </a:r>
-            <a:endParaRPr lang="en-US"/>
           </a:p>
         </p:txBody>
       </p:sp>
@@ -1214,38 +1220,37 @@
           <a:p>
             <a:pPr lvl="0"/>
             <a:r>
-              <a:rPr lang="en-US" smtClean="0"/>
+              <a:rPr lang="en-US"/>
               <a:t>Click to edit Master text styles</a:t>
             </a:r>
           </a:p>
           <a:p>
             <a:pPr lvl="1"/>
             <a:r>
-              <a:rPr lang="en-US" smtClean="0"/>
+              <a:rPr lang="en-US"/>
               <a:t>Second level</a:t>
             </a:r>
           </a:p>
           <a:p>
             <a:pPr lvl="2"/>
             <a:r>
-              <a:rPr lang="en-US" smtClean="0"/>
+              <a:rPr lang="en-US"/>
               <a:t>Third level</a:t>
             </a:r>
           </a:p>
           <a:p>
             <a:pPr lvl="3"/>
             <a:r>
-              <a:rPr lang="en-US" smtClean="0"/>
+              <a:rPr lang="en-US"/>
               <a:t>Fourth level</a:t>
             </a:r>
           </a:p>
           <a:p>
             <a:pPr lvl="4"/>
             <a:r>
-              <a:rPr lang="en-US" smtClean="0"/>
+              <a:rPr lang="en-US"/>
               <a:t>Fifth level</a:t>
             </a:r>
-            <a:endParaRPr lang="en-US"/>
           </a:p>
         </p:txBody>
       </p:sp>
@@ -1299,38 +1304,37 @@
           <a:p>
             <a:pPr lvl="0"/>
             <a:r>
-              <a:rPr lang="en-US" smtClean="0"/>
+              <a:rPr lang="en-US"/>
               <a:t>Click to edit Master text styles</a:t>
             </a:r>
           </a:p>
           <a:p>
             <a:pPr lvl="1"/>
             <a:r>
-              <a:rPr lang="en-US" smtClean="0"/>
+              <a:rPr lang="en-US"/>
               <a:t>Second level</a:t>
             </a:r>
           </a:p>
           <a:p>
             <a:pPr lvl="2"/>
             <a:r>
-              <a:rPr lang="en-US" smtClean="0"/>
+              <a:rPr lang="en-US"/>
               <a:t>Third level</a:t>
             </a:r>
           </a:p>
           <a:p>
             <a:pPr lvl="3"/>
             <a:r>
-              <a:rPr lang="en-US" smtClean="0"/>
+              <a:rPr lang="en-US"/>
               <a:t>Fourth level</a:t>
             </a:r>
           </a:p>
           <a:p>
             <a:pPr lvl="4"/>
             <a:r>
-              <a:rPr lang="en-US" smtClean="0"/>
+              <a:rPr lang="en-US"/>
               <a:t>Fifth level</a:t>
             </a:r>
-            <a:endParaRPr lang="en-US"/>
           </a:p>
         </p:txBody>
       </p:sp>
@@ -1351,7 +1355,7 @@
           <a:p>
             <a:fld id="{5BCAD085-E8A6-8845-BD4E-CB4CCA059FC4}" type="datetimeFigureOut">
               <a:rPr lang="en-US" smtClean="0"/>
-              <a:t>1/27/13</a:t>
+              <a:t>5/7/26</a:t>
             </a:fld>
             <a:endParaRPr lang="en-US"/>
           </a:p>
@@ -1449,10 +1453,9 @@
           </a:lstStyle>
           <a:p>
             <a:r>
-              <a:rPr lang="en-US" smtClean="0"/>
+              <a:rPr lang="en-US"/>
               <a:t>Click to edit Master title style</a:t>
             </a:r>
-            <a:endParaRPr lang="en-US"/>
           </a:p>
         </p:txBody>
       </p:sp>
@@ -1515,7 +1518,7 @@
           <a:p>
             <a:pPr lvl="0"/>
             <a:r>
-              <a:rPr lang="en-US" smtClean="0"/>
+              <a:rPr lang="en-US"/>
               <a:t>Click to edit Master text styles</a:t>
             </a:r>
           </a:p>
@@ -1571,38 +1574,37 @@
           <a:p>
             <a:pPr lvl="0"/>
             <a:r>
-              <a:rPr lang="en-US" smtClean="0"/>
+              <a:rPr lang="en-US"/>
               <a:t>Click to edit Master text styles</a:t>
             </a:r>
           </a:p>
           <a:p>
             <a:pPr lvl="1"/>
             <a:r>
-              <a:rPr lang="en-US" smtClean="0"/>
+              <a:rPr lang="en-US"/>
               <a:t>Second level</a:t>
             </a:r>
           </a:p>
           <a:p>
             <a:pPr lvl="2"/>
             <a:r>
-              <a:rPr lang="en-US" smtClean="0"/>
+              <a:rPr lang="en-US"/>
               <a:t>Third level</a:t>
             </a:r>
           </a:p>
           <a:p>
             <a:pPr lvl="3"/>
             <a:r>
-              <a:rPr lang="en-US" smtClean="0"/>
+              <a:rPr lang="en-US"/>
               <a:t>Fourth level</a:t>
             </a:r>
           </a:p>
           <a:p>
             <a:pPr lvl="4"/>
             <a:r>
-              <a:rPr lang="en-US" smtClean="0"/>
+              <a:rPr lang="en-US"/>
               <a:t>Fifth level</a:t>
             </a:r>
-            <a:endParaRPr lang="en-US"/>
           </a:p>
         </p:txBody>
       </p:sp>
@@ -1665,7 +1667,7 @@
           <a:p>
             <a:pPr lvl="0"/>
             <a:r>
-              <a:rPr lang="en-US" smtClean="0"/>
+              <a:rPr lang="en-US"/>
               <a:t>Click to edit Master text styles</a:t>
             </a:r>
           </a:p>
@@ -1721,38 +1723,37 @@
           <a:p>
             <a:pPr lvl="0"/>
             <a:r>
-              <a:rPr lang="en-US" smtClean="0"/>
+              <a:rPr lang="en-US"/>
               <a:t>Click to edit Master text styles</a:t>
             </a:r>
           </a:p>
           <a:p>
             <a:pPr lvl="1"/>
             <a:r>
-              <a:rPr lang="en-US" smtClean="0"/>
+              <a:rPr lang="en-US"/>
               <a:t>Second level</a:t>
             </a:r>
           </a:p>
           <a:p>
             <a:pPr lvl="2"/>
             <a:r>
-              <a:rPr lang="en-US" smtClean="0"/>
+              <a:rPr lang="en-US"/>
               <a:t>Third level</a:t>
             </a:r>
           </a:p>
           <a:p>
             <a:pPr lvl="3"/>
             <a:r>
-              <a:rPr lang="en-US" smtClean="0"/>
+              <a:rPr lang="en-US"/>
               <a:t>Fourth level</a:t>
             </a:r>
           </a:p>
           <a:p>
             <a:pPr lvl="4"/>
             <a:r>
-              <a:rPr lang="en-US" smtClean="0"/>
+              <a:rPr lang="en-US"/>
               <a:t>Fifth level</a:t>
             </a:r>
-            <a:endParaRPr lang="en-US"/>
           </a:p>
         </p:txBody>
       </p:sp>
@@ -1773,7 +1774,7 @@
           <a:p>
             <a:fld id="{5BCAD085-E8A6-8845-BD4E-CB4CCA059FC4}" type="datetimeFigureOut">
               <a:rPr lang="en-US" smtClean="0"/>
-              <a:t>1/27/13</a:t>
+              <a:t>5/7/26</a:t>
             </a:fld>
             <a:endParaRPr lang="en-US"/>
           </a:p>
@@ -1867,10 +1868,9 @@
           <a:lstStyle/>
           <a:p>
             <a:r>
-              <a:rPr lang="en-US" smtClean="0"/>
+              <a:rPr lang="en-US"/>
               <a:t>Click to edit Master title style</a:t>
             </a:r>
-            <a:endParaRPr lang="en-US"/>
           </a:p>
         </p:txBody>
       </p:sp>
@@ -1891,7 +1891,7 @@
           <a:p>
             <a:fld id="{5BCAD085-E8A6-8845-BD4E-CB4CCA059FC4}" type="datetimeFigureOut">
               <a:rPr lang="en-US" smtClean="0"/>
-              <a:t>1/27/13</a:t>
+              <a:t>5/7/26</a:t>
             </a:fld>
             <a:endParaRPr lang="en-US"/>
           </a:p>
@@ -1986,7 +1986,7 @@
           <a:p>
             <a:fld id="{5BCAD085-E8A6-8845-BD4E-CB4CCA059FC4}" type="datetimeFigureOut">
               <a:rPr lang="en-US" smtClean="0"/>
-              <a:t>1/27/13</a:t>
+              <a:t>5/7/26</a:t>
             </a:fld>
             <a:endParaRPr lang="en-US"/>
           </a:p>
@@ -2089,10 +2089,9 @@
           </a:lstStyle>
           <a:p>
             <a:r>
-              <a:rPr lang="en-US" smtClean="0"/>
+              <a:rPr lang="en-US"/>
               <a:t>Click to edit Master title style</a:t>
             </a:r>
-            <a:endParaRPr lang="en-US"/>
           </a:p>
         </p:txBody>
       </p:sp>
@@ -2146,38 +2145,37 @@
           <a:p>
             <a:pPr lvl="0"/>
             <a:r>
-              <a:rPr lang="en-US" smtClean="0"/>
+              <a:rPr lang="en-US"/>
               <a:t>Click to edit Master text styles</a:t>
             </a:r>
           </a:p>
           <a:p>
             <a:pPr lvl="1"/>
             <a:r>
-              <a:rPr lang="en-US" smtClean="0"/>
+              <a:rPr lang="en-US"/>
               <a:t>Second level</a:t>
             </a:r>
           </a:p>
           <a:p>
             <a:pPr lvl="2"/>
             <a:r>
-              <a:rPr lang="en-US" smtClean="0"/>
+              <a:rPr lang="en-US"/>
               <a:t>Third level</a:t>
             </a:r>
           </a:p>
           <a:p>
             <a:pPr lvl="3"/>
             <a:r>
-              <a:rPr lang="en-US" smtClean="0"/>
+              <a:rPr lang="en-US"/>
               <a:t>Fourth level</a:t>
             </a:r>
           </a:p>
           <a:p>
             <a:pPr lvl="4"/>
             <a:r>
-              <a:rPr lang="en-US" smtClean="0"/>
+              <a:rPr lang="en-US"/>
               <a:t>Fifth level</a:t>
             </a:r>
-            <a:endParaRPr lang="en-US"/>
           </a:p>
         </p:txBody>
       </p:sp>
@@ -2240,7 +2238,7 @@
           <a:p>
             <a:pPr lvl="0"/>
             <a:r>
-              <a:rPr lang="en-US" smtClean="0"/>
+              <a:rPr lang="en-US"/>
               <a:t>Click to edit Master text styles</a:t>
             </a:r>
           </a:p>
@@ -2263,7 +2261,7 @@
           <a:p>
             <a:fld id="{5BCAD085-E8A6-8845-BD4E-CB4CCA059FC4}" type="datetimeFigureOut">
               <a:rPr lang="en-US" smtClean="0"/>
-              <a:t>1/27/13</a:t>
+              <a:t>5/7/26</a:t>
             </a:fld>
             <a:endParaRPr lang="en-US"/>
           </a:p>
@@ -2366,10 +2364,9 @@
           </a:lstStyle>
           <a:p>
             <a:r>
-              <a:rPr lang="en-US" smtClean="0"/>
+              <a:rPr lang="en-US"/>
               <a:t>Click to edit Master title style</a:t>
             </a:r>
-            <a:endParaRPr lang="en-US"/>
           </a:p>
         </p:txBody>
       </p:sp>
@@ -2493,7 +2490,7 @@
           <a:p>
             <a:pPr lvl="0"/>
             <a:r>
-              <a:rPr lang="en-US" smtClean="0"/>
+              <a:rPr lang="en-US"/>
               <a:t>Click to edit Master text styles</a:t>
             </a:r>
           </a:p>
@@ -2516,7 +2513,7 @@
           <a:p>
             <a:fld id="{5BCAD085-E8A6-8845-BD4E-CB4CCA059FC4}" type="datetimeFigureOut">
               <a:rPr lang="en-US" smtClean="0"/>
-              <a:t>1/27/13</a:t>
+              <a:t>5/7/26</a:t>
             </a:fld>
             <a:endParaRPr lang="en-US"/>
           </a:p>
@@ -2625,10 +2622,9 @@
           <a:lstStyle/>
           <a:p>
             <a:r>
-              <a:rPr lang="en-US" smtClean="0"/>
+              <a:rPr lang="en-US"/>
               <a:t>Click to edit Master title style</a:t>
             </a:r>
-            <a:endParaRPr lang="en-US"/>
           </a:p>
         </p:txBody>
       </p:sp>
@@ -2659,38 +2655,37 @@
           <a:p>
             <a:pPr lvl="0"/>
             <a:r>
-              <a:rPr lang="en-US" smtClean="0"/>
+              <a:rPr lang="en-US"/>
               <a:t>Click to edit Master text styles</a:t>
             </a:r>
           </a:p>
           <a:p>
             <a:pPr lvl="1"/>
             <a:r>
-              <a:rPr lang="en-US" smtClean="0"/>
+              <a:rPr lang="en-US"/>
               <a:t>Second level</a:t>
             </a:r>
           </a:p>
           <a:p>
             <a:pPr lvl="2"/>
             <a:r>
-              <a:rPr lang="en-US" smtClean="0"/>
+              <a:rPr lang="en-US"/>
               <a:t>Third level</a:t>
             </a:r>
           </a:p>
           <a:p>
             <a:pPr lvl="3"/>
             <a:r>
-              <a:rPr lang="en-US" smtClean="0"/>
+              <a:rPr lang="en-US"/>
               <a:t>Fourth level</a:t>
             </a:r>
           </a:p>
           <a:p>
             <a:pPr lvl="4"/>
             <a:r>
-              <a:rPr lang="en-US" smtClean="0"/>
+              <a:rPr lang="en-US"/>
               <a:t>Fifth level</a:t>
             </a:r>
-            <a:endParaRPr lang="en-US"/>
           </a:p>
         </p:txBody>
       </p:sp>
@@ -2729,7 +2724,7 @@
           <a:p>
             <a:fld id="{5BCAD085-E8A6-8845-BD4E-CB4CCA059FC4}" type="datetimeFigureOut">
               <a:rPr lang="en-US" smtClean="0"/>
-              <a:t>1/27/13</a:t>
+              <a:t>5/7/26</a:t>
             </a:fld>
             <a:endParaRPr lang="en-US"/>
           </a:p>
@@ -3088,7 +3083,7 @@
 </file>
 
 <file path=ppt/slides/slide1.xml><?xml version="1.0" encoding="utf-8"?>
-<p:sld xmlns:a="http://schemas.openxmlformats.org/drawingml/2006/main" xmlns:p="http://schemas.openxmlformats.org/presentationml/2006/main" xmlns:r="http://schemas.openxmlformats.org/officeDocument/2006/relationships">
+<p:sld xmlns:a="http://schemas.openxmlformats.org/drawingml/2006/main" xmlns:r="http://schemas.openxmlformats.org/officeDocument/2006/relationships" xmlns:p="http://schemas.openxmlformats.org/presentationml/2006/main">
   <p:cSld>
     <p:spTree>
       <p:nvGrpSpPr>
@@ -3096,7 +3091,14 @@
         <p:cNvGrpSpPr/>
         <p:nvPr/>
       </p:nvGrpSpPr>
-      <p:grpSpPr/>
+      <p:grpSpPr>
+        <a:xfrm>
+          <a:off x="0" y="0"/>
+          <a:ext cx="0" cy="0"/>
+          <a:chOff x="0" y="0"/>
+          <a:chExt cx="0" cy="0"/>
+        </a:xfrm>
+      </p:grpSpPr>
       <p:sp>
         <p:nvSpPr>
           <p:cNvPr id="2" name="Rectangle 1"/>
@@ -3138,6 +3140,7 @@
           <a:lstStyle/>
           <a:p>
             <a:pPr algn="ctr"/>
+            <a:endParaRPr/>
           </a:p>
         </p:txBody>
       </p:sp>
@@ -3182,6 +3185,7 @@
           <a:lstStyle/>
           <a:p>
             <a:pPr algn="ctr"/>
+            <a:endParaRPr/>
           </a:p>
         </p:txBody>
       </p:sp>
@@ -3228,6 +3232,7 @@
           <a:lstStyle/>
           <a:p>
             <a:pPr algn="ctr"/>
+            <a:endParaRPr/>
           </a:p>
         </p:txBody>
       </p:sp>
@@ -3248,7 +3253,7 @@
           <a:noFill/>
         </p:spPr>
         <p:txBody>
-          <a:bodyPr wrap="square" anchor="t" lIns="0" rIns="0" tIns="0" bIns="0">
+          <a:bodyPr wrap="square" lIns="0" tIns="0" rIns="0" bIns="0" anchor="t">
             <a:spAutoFit/>
           </a:bodyPr>
           <a:lstStyle/>
@@ -3283,7 +3288,7 @@
           <a:noFill/>
         </p:spPr>
         <p:txBody>
-          <a:bodyPr wrap="square" anchor="t" lIns="0" rIns="0" tIns="0" bIns="0">
+          <a:bodyPr wrap="square" lIns="0" tIns="0" rIns="0" bIns="0" anchor="t">
             <a:spAutoFit/>
           </a:bodyPr>
           <a:lstStyle/>
@@ -3362,6 +3367,7 @@
           <a:lstStyle/>
           <a:p>
             <a:pPr algn="ctr"/>
+            <a:endParaRPr/>
           </a:p>
         </p:txBody>
       </p:sp>
@@ -3382,7 +3388,7 @@
           <a:noFill/>
         </p:spPr>
         <p:txBody>
-          <a:bodyPr wrap="square" anchor="t" lIns="0" rIns="0" tIns="0" bIns="0">
+          <a:bodyPr wrap="square" lIns="0" tIns="0" rIns="0" bIns="0" anchor="t">
             <a:spAutoFit/>
           </a:bodyPr>
           <a:lstStyle/>
@@ -3417,7 +3423,7 @@
           <a:noFill/>
         </p:spPr>
         <p:txBody>
-          <a:bodyPr wrap="square" anchor="t" lIns="0" rIns="0" tIns="0" bIns="0">
+          <a:bodyPr wrap="square" lIns="0" tIns="0" rIns="0" bIns="0" anchor="t">
             <a:spAutoFit/>
           </a:bodyPr>
           <a:lstStyle/>
@@ -3452,7 +3458,7 @@
           <a:noFill/>
         </p:spPr>
         <p:txBody>
-          <a:bodyPr wrap="square" anchor="t" lIns="0" rIns="0" tIns="0" bIns="0">
+          <a:bodyPr wrap="square" lIns="0" tIns="0" rIns="0" bIns="0" anchor="t">
             <a:spAutoFit/>
           </a:bodyPr>
           <a:lstStyle/>
@@ -3487,7 +3493,7 @@
           <a:noFill/>
         </p:spPr>
         <p:txBody>
-          <a:bodyPr wrap="square" anchor="t" lIns="0" rIns="0" tIns="0" bIns="0">
+          <a:bodyPr wrap="square" lIns="0" tIns="0" rIns="0" bIns="0" anchor="t">
             <a:spAutoFit/>
           </a:bodyPr>
           <a:lstStyle/>
@@ -3514,7 +3520,7 @@
 </file>
 
 <file path=ppt/slides/slide10.xml><?xml version="1.0" encoding="utf-8"?>
-<p:sld xmlns:a="http://schemas.openxmlformats.org/drawingml/2006/main" xmlns:p="http://schemas.openxmlformats.org/presentationml/2006/main" xmlns:r="http://schemas.openxmlformats.org/officeDocument/2006/relationships">
+<p:sld xmlns:a="http://schemas.openxmlformats.org/drawingml/2006/main" xmlns:r="http://schemas.openxmlformats.org/officeDocument/2006/relationships" xmlns:p="http://schemas.openxmlformats.org/presentationml/2006/main">
   <p:cSld>
     <p:spTree>
       <p:nvGrpSpPr>
@@ -3522,7 +3528,14 @@
         <p:cNvGrpSpPr/>
         <p:nvPr/>
       </p:nvGrpSpPr>
-      <p:grpSpPr/>
+      <p:grpSpPr>
+        <a:xfrm>
+          <a:off x="0" y="0"/>
+          <a:ext cx="0" cy="0"/>
+          <a:chOff x="0" y="0"/>
+          <a:chExt cx="0" cy="0"/>
+        </a:xfrm>
+      </p:grpSpPr>
       <p:sp>
         <p:nvSpPr>
           <p:cNvPr id="2" name="Rectangle 1"/>
@@ -3564,6 +3577,7 @@
           <a:lstStyle/>
           <a:p>
             <a:pPr algn="ctr"/>
+            <a:endParaRPr/>
           </a:p>
         </p:txBody>
       </p:sp>
@@ -3584,7 +3598,7 @@
           <a:noFill/>
         </p:spPr>
         <p:txBody>
-          <a:bodyPr wrap="square" anchor="t" lIns="0" rIns="0" tIns="0" bIns="0">
+          <a:bodyPr wrap="square" lIns="0" tIns="0" rIns="0" bIns="0" anchor="t">
             <a:spAutoFit/>
           </a:bodyPr>
           <a:lstStyle/>
@@ -3619,7 +3633,7 @@
           <a:noFill/>
         </p:spPr>
         <p:txBody>
-          <a:bodyPr wrap="square" anchor="t" lIns="0" rIns="0" tIns="0" bIns="0">
+          <a:bodyPr wrap="square" lIns="0" tIns="0" rIns="0" bIns="0" anchor="t">
             <a:spAutoFit/>
           </a:bodyPr>
           <a:lstStyle/>
@@ -3678,6 +3692,7 @@
           <a:lstStyle/>
           <a:p>
             <a:pPr algn="ctr"/>
+            <a:endParaRPr/>
           </a:p>
         </p:txBody>
       </p:sp>
@@ -3698,7 +3713,7 @@
           <a:noFill/>
         </p:spPr>
         <p:txBody>
-          <a:bodyPr wrap="square" anchor="t" lIns="0" rIns="0" tIns="0" bIns="0">
+          <a:bodyPr wrap="square" lIns="0" tIns="0" rIns="0" bIns="0" anchor="t">
             <a:spAutoFit/>
           </a:bodyPr>
           <a:lstStyle/>
@@ -3733,7 +3748,7 @@
           <a:noFill/>
         </p:spPr>
         <p:txBody>
-          <a:bodyPr wrap="square" anchor="t" lIns="0" rIns="0" tIns="0" bIns="0">
+          <a:bodyPr wrap="square" lIns="0" tIns="0" rIns="0" bIns="0" anchor="t">
             <a:spAutoFit/>
           </a:bodyPr>
           <a:lstStyle/>
@@ -3796,6 +3811,7 @@
           <a:lstStyle/>
           <a:p>
             <a:pPr algn="ctr"/>
+            <a:endParaRPr/>
           </a:p>
         </p:txBody>
       </p:sp>
@@ -3816,7 +3832,7 @@
           <a:noFill/>
         </p:spPr>
         <p:txBody>
-          <a:bodyPr wrap="square" anchor="t" lIns="0" rIns="0" tIns="0" bIns="0">
+          <a:bodyPr wrap="square" lIns="0" tIns="0" rIns="0" bIns="0" anchor="t">
             <a:spAutoFit/>
           </a:bodyPr>
           <a:lstStyle/>
@@ -3950,6 +3966,7 @@
           <a:lstStyle/>
           <a:p>
             <a:pPr algn="ctr"/>
+            <a:endParaRPr/>
           </a:p>
         </p:txBody>
       </p:sp>
@@ -3970,7 +3987,7 @@
           <a:noFill/>
         </p:spPr>
         <p:txBody>
-          <a:bodyPr wrap="square" anchor="t" lIns="0" rIns="0" tIns="0" bIns="0">
+          <a:bodyPr wrap="square" lIns="0" tIns="0" rIns="0" bIns="0" anchor="t">
             <a:spAutoFit/>
           </a:bodyPr>
           <a:lstStyle/>
@@ -4100,6 +4117,7 @@
           <a:lstStyle/>
           <a:p>
             <a:pPr algn="ctr"/>
+            <a:endParaRPr/>
           </a:p>
         </p:txBody>
       </p:sp>
@@ -4120,7 +4138,7 @@
           <a:noFill/>
         </p:spPr>
         <p:txBody>
-          <a:bodyPr wrap="square" anchor="t" lIns="0" rIns="0" tIns="0" bIns="0">
+          <a:bodyPr wrap="square" lIns="0" tIns="0" rIns="0" bIns="0" anchor="t">
             <a:spAutoFit/>
           </a:bodyPr>
           <a:lstStyle/>
@@ -4181,6 +4199,7 @@
           <a:lstStyle/>
           <a:p>
             <a:pPr algn="ctr"/>
+            <a:endParaRPr/>
           </a:p>
         </p:txBody>
       </p:sp>
@@ -4201,7 +4220,7 @@
           <a:noFill/>
         </p:spPr>
         <p:txBody>
-          <a:bodyPr wrap="square" anchor="t" lIns="0" rIns="0" tIns="0" bIns="0">
+          <a:bodyPr wrap="square" lIns="0" tIns="0" rIns="0" bIns="0" anchor="t">
             <a:spAutoFit/>
           </a:bodyPr>
           <a:lstStyle/>
@@ -4236,7 +4255,7 @@
           <a:noFill/>
         </p:spPr>
         <p:txBody>
-          <a:bodyPr wrap="square" anchor="t" lIns="0" rIns="0" tIns="0" bIns="0">
+          <a:bodyPr wrap="square" lIns="0" tIns="0" rIns="0" bIns="0" anchor="t">
             <a:spAutoFit/>
           </a:bodyPr>
           <a:lstStyle/>
@@ -4271,7 +4290,7 @@
           <a:noFill/>
         </p:spPr>
         <p:txBody>
-          <a:bodyPr wrap="square" anchor="t" lIns="0" rIns="0" tIns="0" bIns="0">
+          <a:bodyPr wrap="square" lIns="0" tIns="0" rIns="0" bIns="0" anchor="t">
             <a:spAutoFit/>
           </a:bodyPr>
           <a:lstStyle/>
@@ -4298,7 +4317,7 @@
 </file>
 
 <file path=ppt/slides/slide2.xml><?xml version="1.0" encoding="utf-8"?>
-<p:sld xmlns:a="http://schemas.openxmlformats.org/drawingml/2006/main" xmlns:p="http://schemas.openxmlformats.org/presentationml/2006/main" xmlns:r="http://schemas.openxmlformats.org/officeDocument/2006/relationships">
+<p:sld xmlns:a="http://schemas.openxmlformats.org/drawingml/2006/main" xmlns:r="http://schemas.openxmlformats.org/officeDocument/2006/relationships" xmlns:p="http://schemas.openxmlformats.org/presentationml/2006/main">
   <p:cSld>
     <p:spTree>
       <p:nvGrpSpPr>
@@ -4306,7 +4325,14 @@
         <p:cNvGrpSpPr/>
         <p:nvPr/>
       </p:nvGrpSpPr>
-      <p:grpSpPr/>
+      <p:grpSpPr>
+        <a:xfrm>
+          <a:off x="0" y="0"/>
+          <a:ext cx="0" cy="0"/>
+          <a:chOff x="0" y="0"/>
+          <a:chExt cx="0" cy="0"/>
+        </a:xfrm>
+      </p:grpSpPr>
       <p:sp>
         <p:nvSpPr>
           <p:cNvPr id="2" name="Rectangle 1"/>
@@ -4348,6 +4374,7 @@
           <a:lstStyle/>
           <a:p>
             <a:pPr algn="ctr"/>
+            <a:endParaRPr/>
           </a:p>
         </p:txBody>
       </p:sp>
@@ -4368,7 +4395,7 @@
           <a:noFill/>
         </p:spPr>
         <p:txBody>
-          <a:bodyPr wrap="square" anchor="t" lIns="0" rIns="0" tIns="0" bIns="0">
+          <a:bodyPr wrap="square" lIns="0" tIns="0" rIns="0" bIns="0" anchor="t">
             <a:spAutoFit/>
           </a:bodyPr>
           <a:lstStyle/>
@@ -4403,7 +4430,7 @@
           <a:noFill/>
         </p:spPr>
         <p:txBody>
-          <a:bodyPr wrap="square" anchor="t" lIns="0" rIns="0" tIns="0" bIns="0">
+          <a:bodyPr wrap="square" lIns="0" tIns="0" rIns="0" bIns="0" anchor="t">
             <a:spAutoFit/>
           </a:bodyPr>
           <a:lstStyle/>
@@ -4462,6 +4489,7 @@
           <a:lstStyle/>
           <a:p>
             <a:pPr algn="ctr"/>
+            <a:endParaRPr/>
           </a:p>
         </p:txBody>
       </p:sp>
@@ -4482,7 +4510,7 @@
           <a:noFill/>
         </p:spPr>
         <p:txBody>
-          <a:bodyPr wrap="square" anchor="t" lIns="0" rIns="0" tIns="0" bIns="0">
+          <a:bodyPr wrap="square" lIns="0" tIns="0" rIns="0" bIns="0" anchor="t">
             <a:spAutoFit/>
           </a:bodyPr>
           <a:lstStyle/>
@@ -4581,6 +4609,7 @@
           <a:lstStyle/>
           <a:p>
             <a:pPr algn="ctr"/>
+            <a:endParaRPr/>
           </a:p>
         </p:txBody>
       </p:sp>
@@ -4601,7 +4630,7 @@
           <a:noFill/>
         </p:spPr>
         <p:txBody>
-          <a:bodyPr wrap="square" anchor="t" lIns="0" rIns="0" tIns="0" bIns="0">
+          <a:bodyPr wrap="square" lIns="0" tIns="0" rIns="0" bIns="0" anchor="t">
             <a:spAutoFit/>
           </a:bodyPr>
           <a:lstStyle/>
@@ -4636,7 +4665,7 @@
           <a:noFill/>
         </p:spPr>
         <p:txBody>
-          <a:bodyPr wrap="square" anchor="ctr" lIns="0" rIns="0" tIns="0" bIns="0">
+          <a:bodyPr wrap="square" lIns="0" tIns="0" rIns="0" bIns="0" anchor="ctr">
             <a:spAutoFit/>
           </a:bodyPr>
           <a:lstStyle/>
@@ -4719,6 +4748,7 @@
           <a:lstStyle/>
           <a:p>
             <a:pPr algn="ctr"/>
+            <a:endParaRPr/>
           </a:p>
         </p:txBody>
       </p:sp>
@@ -4739,7 +4769,7 @@
           <a:noFill/>
         </p:spPr>
         <p:txBody>
-          <a:bodyPr wrap="square" anchor="t" lIns="0" rIns="0" tIns="0" bIns="0">
+          <a:bodyPr wrap="square" lIns="0" tIns="0" rIns="0" bIns="0" anchor="t">
             <a:spAutoFit/>
           </a:bodyPr>
           <a:lstStyle/>
@@ -4774,7 +4804,7 @@
           <a:noFill/>
         </p:spPr>
         <p:txBody>
-          <a:bodyPr wrap="square" anchor="ctr" lIns="0" rIns="0" tIns="0" bIns="0">
+          <a:bodyPr wrap="square" lIns="0" tIns="0" rIns="0" bIns="0" anchor="ctr">
             <a:spAutoFit/>
           </a:bodyPr>
           <a:lstStyle/>
@@ -4857,6 +4887,7 @@
           <a:lstStyle/>
           <a:p>
             <a:pPr algn="ctr"/>
+            <a:endParaRPr/>
           </a:p>
         </p:txBody>
       </p:sp>
@@ -4877,7 +4908,7 @@
           <a:noFill/>
         </p:spPr>
         <p:txBody>
-          <a:bodyPr wrap="square" anchor="t" lIns="0" rIns="0" tIns="0" bIns="0">
+          <a:bodyPr wrap="square" lIns="0" tIns="0" rIns="0" bIns="0" anchor="t">
             <a:spAutoFit/>
           </a:bodyPr>
           <a:lstStyle/>
@@ -4912,7 +4943,7 @@
           <a:noFill/>
         </p:spPr>
         <p:txBody>
-          <a:bodyPr wrap="square" anchor="ctr" lIns="0" rIns="0" tIns="0" bIns="0">
+          <a:bodyPr wrap="square" lIns="0" tIns="0" rIns="0" bIns="0" anchor="ctr">
             <a:spAutoFit/>
           </a:bodyPr>
           <a:lstStyle/>
@@ -4979,6 +5010,7 @@
           <a:lstStyle/>
           <a:p>
             <a:pPr algn="ctr"/>
+            <a:endParaRPr/>
           </a:p>
         </p:txBody>
       </p:sp>
@@ -4999,7 +5031,7 @@
           <a:noFill/>
         </p:spPr>
         <p:txBody>
-          <a:bodyPr wrap="square" anchor="t" lIns="0" rIns="0" tIns="0" bIns="0">
+          <a:bodyPr wrap="square" lIns="0" tIns="0" rIns="0" bIns="0" anchor="t">
             <a:spAutoFit/>
           </a:bodyPr>
           <a:lstStyle/>
@@ -5034,7 +5066,7 @@
           <a:noFill/>
         </p:spPr>
         <p:txBody>
-          <a:bodyPr wrap="square" anchor="ctr" lIns="0" rIns="0" tIns="0" bIns="0">
+          <a:bodyPr wrap="square" lIns="0" tIns="0" rIns="0" bIns="0" anchor="ctr">
             <a:spAutoFit/>
           </a:bodyPr>
           <a:lstStyle/>
@@ -5117,6 +5149,7 @@
           <a:lstStyle/>
           <a:p>
             <a:pPr algn="ctr"/>
+            <a:endParaRPr/>
           </a:p>
         </p:txBody>
       </p:sp>
@@ -5137,7 +5170,7 @@
           <a:noFill/>
         </p:spPr>
         <p:txBody>
-          <a:bodyPr wrap="square" anchor="t" lIns="0" rIns="0" tIns="0" bIns="0">
+          <a:bodyPr wrap="square" lIns="0" tIns="0" rIns="0" bIns="0" anchor="t">
             <a:spAutoFit/>
           </a:bodyPr>
           <a:lstStyle/>
@@ -5172,7 +5205,7 @@
           <a:noFill/>
         </p:spPr>
         <p:txBody>
-          <a:bodyPr wrap="square" anchor="ctr" lIns="0" rIns="0" tIns="0" bIns="0">
+          <a:bodyPr wrap="square" lIns="0" tIns="0" rIns="0" bIns="0" anchor="ctr">
             <a:spAutoFit/>
           </a:bodyPr>
           <a:lstStyle/>
@@ -5255,6 +5288,7 @@
           <a:lstStyle/>
           <a:p>
             <a:pPr algn="ctr"/>
+            <a:endParaRPr/>
           </a:p>
         </p:txBody>
       </p:sp>
@@ -5275,7 +5309,7 @@
           <a:noFill/>
         </p:spPr>
         <p:txBody>
-          <a:bodyPr wrap="square" anchor="t" lIns="0" rIns="0" tIns="0" bIns="0">
+          <a:bodyPr wrap="square" lIns="0" tIns="0" rIns="0" bIns="0" anchor="t">
             <a:spAutoFit/>
           </a:bodyPr>
           <a:lstStyle/>
@@ -5310,7 +5344,7 @@
           <a:noFill/>
         </p:spPr>
         <p:txBody>
-          <a:bodyPr wrap="square" anchor="ctr" lIns="0" rIns="0" tIns="0" bIns="0">
+          <a:bodyPr wrap="square" lIns="0" tIns="0" rIns="0" bIns="0" anchor="ctr">
             <a:spAutoFit/>
           </a:bodyPr>
           <a:lstStyle/>
@@ -5391,6 +5425,7 @@
           <a:lstStyle/>
           <a:p>
             <a:pPr algn="ctr"/>
+            <a:endParaRPr/>
           </a:p>
         </p:txBody>
       </p:sp>
@@ -5411,7 +5446,7 @@
           <a:noFill/>
         </p:spPr>
         <p:txBody>
-          <a:bodyPr wrap="square" anchor="t" lIns="0" rIns="0" tIns="0" bIns="0">
+          <a:bodyPr wrap="square" lIns="0" tIns="0" rIns="0" bIns="0" anchor="t">
             <a:spAutoFit/>
           </a:bodyPr>
           <a:lstStyle/>
@@ -5446,7 +5481,7 @@
           <a:noFill/>
         </p:spPr>
         <p:txBody>
-          <a:bodyPr wrap="square" anchor="ctr" lIns="0" rIns="0" tIns="0" bIns="0">
+          <a:bodyPr wrap="square" lIns="0" tIns="0" rIns="0" bIns="0" anchor="ctr">
             <a:spAutoFit/>
           </a:bodyPr>
           <a:lstStyle/>
@@ -5527,6 +5562,7 @@
           <a:lstStyle/>
           <a:p>
             <a:pPr algn="ctr"/>
+            <a:endParaRPr/>
           </a:p>
         </p:txBody>
       </p:sp>
@@ -5547,7 +5583,7 @@
           <a:noFill/>
         </p:spPr>
         <p:txBody>
-          <a:bodyPr wrap="square" anchor="t" lIns="0" rIns="0" tIns="0" bIns="0">
+          <a:bodyPr wrap="square" lIns="0" tIns="0" rIns="0" bIns="0" anchor="t">
             <a:spAutoFit/>
           </a:bodyPr>
           <a:lstStyle/>
@@ -5582,7 +5618,7 @@
           <a:noFill/>
         </p:spPr>
         <p:txBody>
-          <a:bodyPr wrap="square" anchor="t" lIns="0" rIns="0" tIns="0" bIns="0">
+          <a:bodyPr wrap="square" lIns="0" tIns="0" rIns="0" bIns="0" anchor="t">
             <a:spAutoFit/>
           </a:bodyPr>
           <a:lstStyle/>
@@ -5617,7 +5653,7 @@
           <a:noFill/>
         </p:spPr>
         <p:txBody>
-          <a:bodyPr wrap="square" anchor="t" lIns="0" rIns="0" tIns="0" bIns="0">
+          <a:bodyPr wrap="square" lIns="0" tIns="0" rIns="0" bIns="0" anchor="t">
             <a:spAutoFit/>
           </a:bodyPr>
           <a:lstStyle/>
@@ -5644,7 +5680,7 @@
 </file>
 
 <file path=ppt/slides/slide3.xml><?xml version="1.0" encoding="utf-8"?>
-<p:sld xmlns:a="http://schemas.openxmlformats.org/drawingml/2006/main" xmlns:p="http://schemas.openxmlformats.org/presentationml/2006/main" xmlns:r="http://schemas.openxmlformats.org/officeDocument/2006/relationships">
+<p:sld xmlns:a="http://schemas.openxmlformats.org/drawingml/2006/main" xmlns:r="http://schemas.openxmlformats.org/officeDocument/2006/relationships" xmlns:p="http://schemas.openxmlformats.org/presentationml/2006/main">
   <p:cSld>
     <p:spTree>
       <p:nvGrpSpPr>
@@ -5652,7 +5688,14 @@
         <p:cNvGrpSpPr/>
         <p:nvPr/>
       </p:nvGrpSpPr>
-      <p:grpSpPr/>
+      <p:grpSpPr>
+        <a:xfrm>
+          <a:off x="0" y="0"/>
+          <a:ext cx="0" cy="0"/>
+          <a:chOff x="0" y="0"/>
+          <a:chExt cx="0" cy="0"/>
+        </a:xfrm>
+      </p:grpSpPr>
       <p:sp>
         <p:nvSpPr>
           <p:cNvPr id="2" name="Rectangle 1"/>
@@ -5694,6 +5737,7 @@
           <a:lstStyle/>
           <a:p>
             <a:pPr algn="ctr"/>
+            <a:endParaRPr/>
           </a:p>
         </p:txBody>
       </p:sp>
@@ -5714,7 +5758,7 @@
           <a:noFill/>
         </p:spPr>
         <p:txBody>
-          <a:bodyPr wrap="square" anchor="t" lIns="0" rIns="0" tIns="0" bIns="0">
+          <a:bodyPr wrap="square" lIns="0" tIns="0" rIns="0" bIns="0" anchor="t">
             <a:spAutoFit/>
           </a:bodyPr>
           <a:lstStyle/>
@@ -5749,7 +5793,7 @@
           <a:noFill/>
         </p:spPr>
         <p:txBody>
-          <a:bodyPr wrap="square" anchor="t" lIns="0" rIns="0" tIns="0" bIns="0">
+          <a:bodyPr wrap="square" lIns="0" tIns="0" rIns="0" bIns="0" anchor="t">
             <a:spAutoFit/>
           </a:bodyPr>
           <a:lstStyle/>
@@ -5808,6 +5852,7 @@
           <a:lstStyle/>
           <a:p>
             <a:pPr algn="ctr"/>
+            <a:endParaRPr/>
           </a:p>
         </p:txBody>
       </p:sp>
@@ -5828,21 +5873,54 @@
           <a:noFill/>
         </p:spPr>
         <p:txBody>
-          <a:bodyPr wrap="square" anchor="t" lIns="0" rIns="0" tIns="0" bIns="0">
+          <a:bodyPr wrap="square" lIns="0" tIns="0" rIns="0" bIns="0" anchor="t">
             <a:spAutoFit/>
           </a:bodyPr>
           <a:lstStyle/>
           <a:p>
             <a:pPr algn="l"/>
             <a:r>
-              <a:rPr sz="8400" b="1">
+              <a:rPr sz="8400" b="1" dirty="0">
                 <a:solidFill>
                   <a:srgbClr val="EA580C"/>
                 </a:solidFill>
                 <a:latin typeface="Helvetica Neue"/>
               </a:rPr>
-              <a:t>3–8 hrs</a:t>
-            </a:r>
+              <a:t>3</a:t>
+            </a:r>
+            <a:r>
+              <a:rPr lang="en-GB" sz="8400" b="1" dirty="0">
+                <a:solidFill>
+                  <a:srgbClr val="EA580C"/>
+                </a:solidFill>
+                <a:latin typeface="Helvetica Neue"/>
+              </a:rPr>
+              <a:t>-</a:t>
+            </a:r>
+            <a:r>
+              <a:rPr sz="8400" b="1" dirty="0">
+                <a:solidFill>
+                  <a:srgbClr val="EA580C"/>
+                </a:solidFill>
+                <a:latin typeface="Helvetica Neue"/>
+              </a:rPr>
+              <a:t>8 </a:t>
+            </a:r>
+            <a:r>
+              <a:rPr sz="8400" b="1" dirty="0" err="1">
+                <a:solidFill>
+                  <a:srgbClr val="EA580C"/>
+                </a:solidFill>
+                <a:latin typeface="Helvetica Neue"/>
+              </a:rPr>
+              <a:t>hrs</a:t>
+            </a:r>
+            <a:endParaRPr sz="8400" b="1" dirty="0">
+              <a:solidFill>
+                <a:srgbClr val="EA580C"/>
+              </a:solidFill>
+              <a:latin typeface="Helvetica Neue"/>
+            </a:endParaRPr>
           </a:p>
         </p:txBody>
       </p:sp>
@@ -5863,7 +5941,7 @@
           <a:noFill/>
         </p:spPr>
         <p:txBody>
-          <a:bodyPr wrap="square" anchor="t" lIns="0" rIns="0" tIns="0" bIns="0">
+          <a:bodyPr wrap="square" lIns="0" tIns="0" rIns="0" bIns="0" anchor="t">
             <a:spAutoFit/>
           </a:bodyPr>
           <a:lstStyle/>
@@ -5898,7 +5976,7 @@
           <a:noFill/>
         </p:spPr>
         <p:txBody>
-          <a:bodyPr wrap="square" anchor="t" lIns="0" rIns="0" tIns="0" bIns="0">
+          <a:bodyPr wrap="square" lIns="0" tIns="0" rIns="0" bIns="0" anchor="t">
             <a:spAutoFit/>
           </a:bodyPr>
           <a:lstStyle/>
@@ -5961,6 +6039,7 @@
           <a:lstStyle/>
           <a:p>
             <a:pPr algn="ctr"/>
+            <a:endParaRPr/>
           </a:p>
         </p:txBody>
       </p:sp>
@@ -5981,7 +6060,7 @@
           <a:noFill/>
         </p:spPr>
         <p:txBody>
-          <a:bodyPr wrap="square" anchor="t" lIns="0" rIns="0" tIns="0" bIns="0">
+          <a:bodyPr wrap="square" lIns="0" tIns="0" rIns="0" bIns="0" anchor="t">
             <a:spAutoFit/>
           </a:bodyPr>
           <a:lstStyle/>
@@ -6016,7 +6095,7 @@
           <a:noFill/>
         </p:spPr>
         <p:txBody>
-          <a:bodyPr wrap="square" anchor="t" lIns="0" rIns="0" tIns="0" bIns="0">
+          <a:bodyPr wrap="square" lIns="0" tIns="0" rIns="0" bIns="0" anchor="t">
             <a:spAutoFit/>
           </a:bodyPr>
           <a:lstStyle/>
@@ -6099,6 +6178,7 @@
           <a:lstStyle/>
           <a:p>
             <a:pPr algn="ctr"/>
+            <a:endParaRPr/>
           </a:p>
         </p:txBody>
       </p:sp>
@@ -6119,7 +6199,7 @@
           <a:noFill/>
         </p:spPr>
         <p:txBody>
-          <a:bodyPr wrap="square" anchor="t" lIns="0" rIns="0" tIns="0" bIns="0">
+          <a:bodyPr wrap="square" lIns="0" tIns="0" rIns="0" bIns="0" anchor="t">
             <a:spAutoFit/>
           </a:bodyPr>
           <a:lstStyle/>
@@ -6154,7 +6234,7 @@
           <a:noFill/>
         </p:spPr>
         <p:txBody>
-          <a:bodyPr wrap="square" anchor="t" lIns="0" rIns="0" tIns="0" bIns="0">
+          <a:bodyPr wrap="square" lIns="0" tIns="0" rIns="0" bIns="0" anchor="t">
             <a:spAutoFit/>
           </a:bodyPr>
           <a:lstStyle/>
@@ -6237,6 +6317,7 @@
           <a:lstStyle/>
           <a:p>
             <a:pPr algn="ctr"/>
+            <a:endParaRPr/>
           </a:p>
         </p:txBody>
       </p:sp>
@@ -6257,7 +6338,7 @@
           <a:noFill/>
         </p:spPr>
         <p:txBody>
-          <a:bodyPr wrap="square" anchor="t" lIns="0" rIns="0" tIns="0" bIns="0">
+          <a:bodyPr wrap="square" lIns="0" tIns="0" rIns="0" bIns="0" anchor="t">
             <a:spAutoFit/>
           </a:bodyPr>
           <a:lstStyle/>
@@ -6292,7 +6373,7 @@
           <a:noFill/>
         </p:spPr>
         <p:txBody>
-          <a:bodyPr wrap="square" anchor="t" lIns="0" rIns="0" tIns="0" bIns="0">
+          <a:bodyPr wrap="square" lIns="0" tIns="0" rIns="0" bIns="0" anchor="t">
             <a:spAutoFit/>
           </a:bodyPr>
           <a:lstStyle/>
@@ -6373,6 +6454,7 @@
           <a:lstStyle/>
           <a:p>
             <a:pPr algn="ctr"/>
+            <a:endParaRPr/>
           </a:p>
         </p:txBody>
       </p:sp>
@@ -6393,7 +6475,7 @@
           <a:noFill/>
         </p:spPr>
         <p:txBody>
-          <a:bodyPr wrap="square" anchor="t" lIns="0" rIns="0" tIns="0" bIns="0">
+          <a:bodyPr wrap="square" lIns="0" tIns="0" rIns="0" bIns="0" anchor="t">
             <a:spAutoFit/>
           </a:bodyPr>
           <a:lstStyle/>
@@ -6428,7 +6510,7 @@
           <a:noFill/>
         </p:spPr>
         <p:txBody>
-          <a:bodyPr wrap="square" anchor="t" lIns="0" rIns="0" tIns="0" bIns="0">
+          <a:bodyPr wrap="square" lIns="0" tIns="0" rIns="0" bIns="0" anchor="t">
             <a:spAutoFit/>
           </a:bodyPr>
           <a:lstStyle/>
@@ -6463,7 +6545,7 @@
           <a:noFill/>
         </p:spPr>
         <p:txBody>
-          <a:bodyPr wrap="square" anchor="t" lIns="0" rIns="0" tIns="0" bIns="0">
+          <a:bodyPr wrap="square" lIns="0" tIns="0" rIns="0" bIns="0" anchor="t">
             <a:spAutoFit/>
           </a:bodyPr>
           <a:lstStyle/>
@@ -6490,7 +6572,7 @@
 </file>
 
 <file path=ppt/slides/slide4.xml><?xml version="1.0" encoding="utf-8"?>
-<p:sld xmlns:a="http://schemas.openxmlformats.org/drawingml/2006/main" xmlns:p="http://schemas.openxmlformats.org/presentationml/2006/main" xmlns:r="http://schemas.openxmlformats.org/officeDocument/2006/relationships">
+<p:sld xmlns:a="http://schemas.openxmlformats.org/drawingml/2006/main" xmlns:r="http://schemas.openxmlformats.org/officeDocument/2006/relationships" xmlns:p="http://schemas.openxmlformats.org/presentationml/2006/main">
   <p:cSld>
     <p:spTree>
       <p:nvGrpSpPr>
@@ -6498,7 +6580,14 @@
         <p:cNvGrpSpPr/>
         <p:nvPr/>
       </p:nvGrpSpPr>
-      <p:grpSpPr/>
+      <p:grpSpPr>
+        <a:xfrm>
+          <a:off x="0" y="0"/>
+          <a:ext cx="0" cy="0"/>
+          <a:chOff x="0" y="0"/>
+          <a:chExt cx="0" cy="0"/>
+        </a:xfrm>
+      </p:grpSpPr>
       <p:sp>
         <p:nvSpPr>
           <p:cNvPr id="2" name="Rectangle 1"/>
@@ -6540,6 +6629,7 @@
           <a:lstStyle/>
           <a:p>
             <a:pPr algn="ctr"/>
+            <a:endParaRPr/>
           </a:p>
         </p:txBody>
       </p:sp>
@@ -6560,7 +6650,7 @@
           <a:noFill/>
         </p:spPr>
         <p:txBody>
-          <a:bodyPr wrap="square" anchor="t" lIns="0" rIns="0" tIns="0" bIns="0">
+          <a:bodyPr wrap="square" lIns="0" tIns="0" rIns="0" bIns="0" anchor="t">
             <a:spAutoFit/>
           </a:bodyPr>
           <a:lstStyle/>
@@ -6595,7 +6685,7 @@
           <a:noFill/>
         </p:spPr>
         <p:txBody>
-          <a:bodyPr wrap="square" anchor="t" lIns="0" rIns="0" tIns="0" bIns="0">
+          <a:bodyPr wrap="square" lIns="0" tIns="0" rIns="0" bIns="0" anchor="t">
             <a:spAutoFit/>
           </a:bodyPr>
           <a:lstStyle/>
@@ -6654,6 +6744,7 @@
           <a:lstStyle/>
           <a:p>
             <a:pPr algn="ctr"/>
+            <a:endParaRPr/>
           </a:p>
         </p:txBody>
       </p:sp>
@@ -6674,7 +6765,7 @@
           <a:noFill/>
         </p:spPr>
         <p:txBody>
-          <a:bodyPr wrap="square" anchor="t" lIns="0" rIns="0" tIns="0" bIns="0">
+          <a:bodyPr wrap="square" lIns="0" tIns="0" rIns="0" bIns="0" anchor="t">
             <a:spAutoFit/>
           </a:bodyPr>
           <a:lstStyle/>
@@ -6709,7 +6800,7 @@
           <a:noFill/>
         </p:spPr>
         <p:txBody>
-          <a:bodyPr wrap="square" anchor="t" lIns="0" rIns="0" tIns="0" bIns="0">
+          <a:bodyPr wrap="square" lIns="0" tIns="0" rIns="0" bIns="0" anchor="t">
             <a:spAutoFit/>
           </a:bodyPr>
           <a:lstStyle/>
@@ -6792,6 +6883,7 @@
           <a:lstStyle/>
           <a:p>
             <a:pPr algn="ctr"/>
+            <a:endParaRPr/>
           </a:p>
         </p:txBody>
       </p:sp>
@@ -6838,6 +6930,7 @@
           <a:lstStyle/>
           <a:p>
             <a:pPr algn="ctr"/>
+            <a:endParaRPr/>
           </a:p>
         </p:txBody>
       </p:sp>
@@ -6884,6 +6977,7 @@
           <a:lstStyle/>
           <a:p>
             <a:pPr algn="ctr"/>
+            <a:endParaRPr/>
           </a:p>
         </p:txBody>
       </p:sp>
@@ -6930,6 +7024,7 @@
           <a:lstStyle/>
           <a:p>
             <a:pPr algn="ctr"/>
+            <a:endParaRPr/>
           </a:p>
         </p:txBody>
       </p:sp>
@@ -6976,6 +7071,7 @@
           <a:lstStyle/>
           <a:p>
             <a:pPr algn="ctr"/>
+            <a:endParaRPr/>
           </a:p>
         </p:txBody>
       </p:sp>
@@ -7022,6 +7118,7 @@
           <a:lstStyle/>
           <a:p>
             <a:pPr algn="ctr"/>
+            <a:endParaRPr/>
           </a:p>
         </p:txBody>
       </p:sp>
@@ -7042,7 +7139,7 @@
           <a:noFill/>
         </p:spPr>
         <p:txBody>
-          <a:bodyPr wrap="square" anchor="t" lIns="0" rIns="0" tIns="0" bIns="0">
+          <a:bodyPr wrap="square" lIns="0" tIns="0" rIns="0" bIns="0" anchor="t">
             <a:spAutoFit/>
           </a:bodyPr>
           <a:lstStyle/>
@@ -7077,7 +7174,7 @@
           <a:noFill/>
         </p:spPr>
         <p:txBody>
-          <a:bodyPr wrap="square" anchor="t" lIns="0" rIns="0" tIns="0" bIns="0">
+          <a:bodyPr wrap="square" lIns="0" tIns="0" rIns="0" bIns="0" anchor="t">
             <a:spAutoFit/>
           </a:bodyPr>
           <a:lstStyle/>
@@ -7160,6 +7257,7 @@
           <a:lstStyle/>
           <a:p>
             <a:pPr algn="ctr"/>
+            <a:endParaRPr/>
           </a:p>
         </p:txBody>
       </p:sp>
@@ -7206,6 +7304,7 @@
           <a:lstStyle/>
           <a:p>
             <a:pPr algn="ctr"/>
+            <a:endParaRPr/>
           </a:p>
         </p:txBody>
       </p:sp>
@@ -7252,6 +7351,7 @@
           <a:lstStyle/>
           <a:p>
             <a:pPr algn="ctr"/>
+            <a:endParaRPr/>
           </a:p>
         </p:txBody>
       </p:sp>
@@ -7298,6 +7398,7 @@
           <a:lstStyle/>
           <a:p>
             <a:pPr algn="ctr"/>
+            <a:endParaRPr/>
           </a:p>
         </p:txBody>
       </p:sp>
@@ -7344,6 +7445,7 @@
           <a:lstStyle/>
           <a:p>
             <a:pPr algn="ctr"/>
+            <a:endParaRPr/>
           </a:p>
         </p:txBody>
       </p:sp>
@@ -7390,6 +7492,7 @@
           <a:lstStyle/>
           <a:p>
             <a:pPr algn="ctr"/>
+            <a:endParaRPr/>
           </a:p>
         </p:txBody>
       </p:sp>
@@ -7410,7 +7513,7 @@
           <a:noFill/>
         </p:spPr>
         <p:txBody>
-          <a:bodyPr wrap="square" anchor="t" lIns="0" rIns="0" tIns="0" bIns="0">
+          <a:bodyPr wrap="square" lIns="0" tIns="0" rIns="0" bIns="0" anchor="t">
             <a:spAutoFit/>
           </a:bodyPr>
           <a:lstStyle/>
@@ -7445,7 +7548,7 @@
           <a:noFill/>
         </p:spPr>
         <p:txBody>
-          <a:bodyPr wrap="square" anchor="t" lIns="0" rIns="0" tIns="0" bIns="0">
+          <a:bodyPr wrap="square" lIns="0" tIns="0" rIns="0" bIns="0" anchor="t">
             <a:spAutoFit/>
           </a:bodyPr>
           <a:lstStyle/>
@@ -7528,6 +7631,7 @@
           <a:lstStyle/>
           <a:p>
             <a:pPr algn="ctr"/>
+            <a:endParaRPr/>
           </a:p>
         </p:txBody>
       </p:sp>
@@ -7574,6 +7678,7 @@
           <a:lstStyle/>
           <a:p>
             <a:pPr algn="ctr"/>
+            <a:endParaRPr/>
           </a:p>
         </p:txBody>
       </p:sp>
@@ -7620,6 +7725,7 @@
           <a:lstStyle/>
           <a:p>
             <a:pPr algn="ctr"/>
+            <a:endParaRPr/>
           </a:p>
         </p:txBody>
       </p:sp>
@@ -7666,6 +7772,7 @@
           <a:lstStyle/>
           <a:p>
             <a:pPr algn="ctr"/>
+            <a:endParaRPr/>
           </a:p>
         </p:txBody>
       </p:sp>
@@ -7712,6 +7819,7 @@
           <a:lstStyle/>
           <a:p>
             <a:pPr algn="ctr"/>
+            <a:endParaRPr/>
           </a:p>
         </p:txBody>
       </p:sp>
@@ -7758,6 +7866,7 @@
           <a:lstStyle/>
           <a:p>
             <a:pPr algn="ctr"/>
+            <a:endParaRPr/>
           </a:p>
         </p:txBody>
       </p:sp>
@@ -7778,7 +7887,7 @@
           <a:noFill/>
         </p:spPr>
         <p:txBody>
-          <a:bodyPr wrap="square" anchor="t" lIns="0" rIns="0" tIns="0" bIns="0">
+          <a:bodyPr wrap="square" lIns="0" tIns="0" rIns="0" bIns="0" anchor="t">
             <a:spAutoFit/>
           </a:bodyPr>
           <a:lstStyle/>
@@ -7839,6 +7948,7 @@
           <a:lstStyle/>
           <a:p>
             <a:pPr algn="ctr"/>
+            <a:endParaRPr/>
           </a:p>
         </p:txBody>
       </p:sp>
@@ -7859,7 +7969,7 @@
           <a:noFill/>
         </p:spPr>
         <p:txBody>
-          <a:bodyPr wrap="square" anchor="t" lIns="0" rIns="0" tIns="0" bIns="0">
+          <a:bodyPr wrap="square" lIns="0" tIns="0" rIns="0" bIns="0" anchor="t">
             <a:spAutoFit/>
           </a:bodyPr>
           <a:lstStyle/>
@@ -7894,7 +8004,7 @@
           <a:noFill/>
         </p:spPr>
         <p:txBody>
-          <a:bodyPr wrap="square" anchor="t" lIns="0" rIns="0" tIns="0" bIns="0">
+          <a:bodyPr wrap="square" lIns="0" tIns="0" rIns="0" bIns="0" anchor="t">
             <a:spAutoFit/>
           </a:bodyPr>
           <a:lstStyle/>
@@ -7929,7 +8039,7 @@
           <a:noFill/>
         </p:spPr>
         <p:txBody>
-          <a:bodyPr wrap="square" anchor="t" lIns="0" rIns="0" tIns="0" bIns="0">
+          <a:bodyPr wrap="square" lIns="0" tIns="0" rIns="0" bIns="0" anchor="t">
             <a:spAutoFit/>
           </a:bodyPr>
           <a:lstStyle/>
@@ -7956,7 +8066,7 @@
 </file>
 
 <file path=ppt/slides/slide5.xml><?xml version="1.0" encoding="utf-8"?>
-<p:sld xmlns:a="http://schemas.openxmlformats.org/drawingml/2006/main" xmlns:p="http://schemas.openxmlformats.org/presentationml/2006/main" xmlns:r="http://schemas.openxmlformats.org/officeDocument/2006/relationships">
+<p:sld xmlns:a="http://schemas.openxmlformats.org/drawingml/2006/main" xmlns:r="http://schemas.openxmlformats.org/officeDocument/2006/relationships" xmlns:p="http://schemas.openxmlformats.org/presentationml/2006/main">
   <p:cSld>
     <p:spTree>
       <p:nvGrpSpPr>
@@ -7964,7 +8074,14 @@
         <p:cNvGrpSpPr/>
         <p:nvPr/>
       </p:nvGrpSpPr>
-      <p:grpSpPr/>
+      <p:grpSpPr>
+        <a:xfrm>
+          <a:off x="0" y="0"/>
+          <a:ext cx="0" cy="0"/>
+          <a:chOff x="0" y="0"/>
+          <a:chExt cx="0" cy="0"/>
+        </a:xfrm>
+      </p:grpSpPr>
       <p:sp>
         <p:nvSpPr>
           <p:cNvPr id="2" name="Rectangle 1"/>
@@ -8006,6 +8123,7 @@
           <a:lstStyle/>
           <a:p>
             <a:pPr algn="ctr"/>
+            <a:endParaRPr/>
           </a:p>
         </p:txBody>
       </p:sp>
@@ -8026,7 +8144,7 @@
           <a:noFill/>
         </p:spPr>
         <p:txBody>
-          <a:bodyPr wrap="square" anchor="t" lIns="0" rIns="0" tIns="0" bIns="0">
+          <a:bodyPr wrap="square" lIns="0" tIns="0" rIns="0" bIns="0" anchor="t">
             <a:spAutoFit/>
           </a:bodyPr>
           <a:lstStyle/>
@@ -8061,7 +8179,7 @@
           <a:noFill/>
         </p:spPr>
         <p:txBody>
-          <a:bodyPr wrap="square" anchor="t" lIns="0" rIns="0" tIns="0" bIns="0">
+          <a:bodyPr wrap="square" lIns="0" tIns="0" rIns="0" bIns="0" anchor="t">
             <a:spAutoFit/>
           </a:bodyPr>
           <a:lstStyle/>
@@ -8120,6 +8238,7 @@
           <a:lstStyle/>
           <a:p>
             <a:pPr algn="ctr"/>
+            <a:endParaRPr/>
           </a:p>
         </p:txBody>
       </p:sp>
@@ -8166,6 +8285,7 @@
           <a:lstStyle/>
           <a:p>
             <a:pPr algn="ctr"/>
+            <a:endParaRPr/>
           </a:p>
         </p:txBody>
       </p:sp>
@@ -8214,6 +8334,7 @@
           <a:lstStyle/>
           <a:p>
             <a:pPr algn="ctr"/>
+            <a:endParaRPr/>
           </a:p>
         </p:txBody>
       </p:sp>
@@ -8234,7 +8355,7 @@
           <a:noFill/>
         </p:spPr>
         <p:txBody>
-          <a:bodyPr wrap="square" anchor="ctr" lIns="0" rIns="0" tIns="0" bIns="0">
+          <a:bodyPr wrap="square" lIns="0" tIns="0" rIns="0" bIns="0" anchor="ctr">
             <a:spAutoFit/>
           </a:bodyPr>
           <a:lstStyle/>
@@ -8269,7 +8390,7 @@
           <a:noFill/>
         </p:spPr>
         <p:txBody>
-          <a:bodyPr wrap="square" anchor="t" lIns="0" rIns="0" tIns="0" bIns="0">
+          <a:bodyPr wrap="square" lIns="0" tIns="0" rIns="0" bIns="0" anchor="t">
             <a:spAutoFit/>
           </a:bodyPr>
           <a:lstStyle/>
@@ -8332,6 +8453,7 @@
           <a:lstStyle/>
           <a:p>
             <a:pPr algn="ctr"/>
+            <a:endParaRPr/>
           </a:p>
         </p:txBody>
       </p:sp>
@@ -8352,7 +8474,7 @@
           <a:noFill/>
         </p:spPr>
         <p:txBody>
-          <a:bodyPr wrap="square" anchor="ctr" lIns="0" rIns="0" tIns="0" bIns="0">
+          <a:bodyPr wrap="square" lIns="0" tIns="0" rIns="0" bIns="0" anchor="ctr">
             <a:spAutoFit/>
           </a:bodyPr>
           <a:lstStyle/>
@@ -8387,7 +8509,7 @@
           <a:noFill/>
         </p:spPr>
         <p:txBody>
-          <a:bodyPr wrap="square" anchor="t" lIns="0" rIns="0" tIns="0" bIns="0">
+          <a:bodyPr wrap="square" lIns="0" tIns="0" rIns="0" bIns="0" anchor="t">
             <a:spAutoFit/>
           </a:bodyPr>
           <a:lstStyle/>
@@ -8450,6 +8572,7 @@
           <a:lstStyle/>
           <a:p>
             <a:pPr algn="ctr"/>
+            <a:endParaRPr/>
           </a:p>
         </p:txBody>
       </p:sp>
@@ -8470,7 +8593,7 @@
           <a:noFill/>
         </p:spPr>
         <p:txBody>
-          <a:bodyPr wrap="square" anchor="ctr" lIns="0" rIns="0" tIns="0" bIns="0">
+          <a:bodyPr wrap="square" lIns="0" tIns="0" rIns="0" bIns="0" anchor="ctr">
             <a:spAutoFit/>
           </a:bodyPr>
           <a:lstStyle/>
@@ -8505,7 +8628,7 @@
           <a:noFill/>
         </p:spPr>
         <p:txBody>
-          <a:bodyPr wrap="square" anchor="t" lIns="0" rIns="0" tIns="0" bIns="0">
+          <a:bodyPr wrap="square" lIns="0" tIns="0" rIns="0" bIns="0" anchor="t">
             <a:spAutoFit/>
           </a:bodyPr>
           <a:lstStyle/>
@@ -8566,6 +8689,7 @@
           <a:lstStyle/>
           <a:p>
             <a:pPr algn="ctr"/>
+            <a:endParaRPr/>
           </a:p>
         </p:txBody>
       </p:sp>
@@ -8614,6 +8738,7 @@
           <a:lstStyle/>
           <a:p>
             <a:pPr algn="ctr"/>
+            <a:endParaRPr/>
           </a:p>
         </p:txBody>
       </p:sp>
@@ -8634,7 +8759,7 @@
           <a:noFill/>
         </p:spPr>
         <p:txBody>
-          <a:bodyPr wrap="square" anchor="t" lIns="0" rIns="0" tIns="0" bIns="0">
+          <a:bodyPr wrap="square" lIns="0" tIns="0" rIns="0" bIns="0" anchor="t">
             <a:spAutoFit/>
           </a:bodyPr>
           <a:lstStyle/>
@@ -8669,7 +8794,7 @@
           <a:noFill/>
         </p:spPr>
         <p:txBody>
-          <a:bodyPr wrap="square" anchor="t" lIns="0" rIns="0" tIns="0" bIns="0">
+          <a:bodyPr wrap="square" lIns="0" tIns="0" rIns="0" bIns="0" anchor="t">
             <a:spAutoFit/>
           </a:bodyPr>
           <a:lstStyle/>
@@ -8708,7 +8833,7 @@
           <a:noFill/>
         </p:spPr>
         <p:txBody>
-          <a:bodyPr wrap="square" anchor="t" lIns="0" rIns="0" tIns="0" bIns="0">
+          <a:bodyPr wrap="square" lIns="0" tIns="0" rIns="0" bIns="0" anchor="t">
             <a:spAutoFit/>
           </a:bodyPr>
           <a:lstStyle/>
@@ -8743,7 +8868,7 @@
           <a:noFill/>
         </p:spPr>
         <p:txBody>
-          <a:bodyPr wrap="square" anchor="t" lIns="0" rIns="0" tIns="0" bIns="0">
+          <a:bodyPr wrap="square" lIns="0" tIns="0" rIns="0" bIns="0" anchor="t">
             <a:spAutoFit/>
           </a:bodyPr>
           <a:lstStyle/>
@@ -8778,7 +8903,7 @@
           <a:noFill/>
         </p:spPr>
         <p:txBody>
-          <a:bodyPr wrap="square" anchor="t" lIns="0" rIns="0" tIns="0" bIns="0">
+          <a:bodyPr wrap="square" lIns="0" tIns="0" rIns="0" bIns="0" anchor="t">
             <a:spAutoFit/>
           </a:bodyPr>
           <a:lstStyle/>
@@ -8839,6 +8964,7 @@
           <a:lstStyle/>
           <a:p>
             <a:pPr algn="ctr"/>
+            <a:endParaRPr/>
           </a:p>
         </p:txBody>
       </p:sp>
@@ -8859,7 +8985,7 @@
           <a:noFill/>
         </p:spPr>
         <p:txBody>
-          <a:bodyPr wrap="square" anchor="t" lIns="0" rIns="0" tIns="0" bIns="0">
+          <a:bodyPr wrap="square" lIns="0" tIns="0" rIns="0" bIns="0" anchor="t">
             <a:spAutoFit/>
           </a:bodyPr>
           <a:lstStyle/>
@@ -8894,7 +9020,7 @@
           <a:noFill/>
         </p:spPr>
         <p:txBody>
-          <a:bodyPr wrap="square" anchor="t" lIns="0" rIns="0" tIns="0" bIns="0">
+          <a:bodyPr wrap="square" lIns="0" tIns="0" rIns="0" bIns="0" anchor="t">
             <a:spAutoFit/>
           </a:bodyPr>
           <a:lstStyle/>
@@ -8929,7 +9055,7 @@
           <a:noFill/>
         </p:spPr>
         <p:txBody>
-          <a:bodyPr wrap="square" anchor="t" lIns="0" rIns="0" tIns="0" bIns="0">
+          <a:bodyPr wrap="square" lIns="0" tIns="0" rIns="0" bIns="0" anchor="t">
             <a:spAutoFit/>
           </a:bodyPr>
           <a:lstStyle/>
@@ -8956,7 +9082,7 @@
 </file>
 
 <file path=ppt/slides/slide6.xml><?xml version="1.0" encoding="utf-8"?>
-<p:sld xmlns:a="http://schemas.openxmlformats.org/drawingml/2006/main" xmlns:p="http://schemas.openxmlformats.org/presentationml/2006/main" xmlns:r="http://schemas.openxmlformats.org/officeDocument/2006/relationships">
+<p:sld xmlns:a="http://schemas.openxmlformats.org/drawingml/2006/main" xmlns:r="http://schemas.openxmlformats.org/officeDocument/2006/relationships" xmlns:p="http://schemas.openxmlformats.org/presentationml/2006/main">
   <p:cSld>
     <p:spTree>
       <p:nvGrpSpPr>
@@ -8964,7 +9090,14 @@
         <p:cNvGrpSpPr/>
         <p:nvPr/>
       </p:nvGrpSpPr>
-      <p:grpSpPr/>
+      <p:grpSpPr>
+        <a:xfrm>
+          <a:off x="0" y="0"/>
+          <a:ext cx="0" cy="0"/>
+          <a:chOff x="0" y="0"/>
+          <a:chExt cx="0" cy="0"/>
+        </a:xfrm>
+      </p:grpSpPr>
       <p:sp>
         <p:nvSpPr>
           <p:cNvPr id="2" name="Rectangle 1"/>
@@ -9006,6 +9139,7 @@
           <a:lstStyle/>
           <a:p>
             <a:pPr algn="ctr"/>
+            <a:endParaRPr/>
           </a:p>
         </p:txBody>
       </p:sp>
@@ -9026,7 +9160,7 @@
           <a:noFill/>
         </p:spPr>
         <p:txBody>
-          <a:bodyPr wrap="square" anchor="t" lIns="0" rIns="0" tIns="0" bIns="0">
+          <a:bodyPr wrap="square" lIns="0" tIns="0" rIns="0" bIns="0" anchor="t">
             <a:spAutoFit/>
           </a:bodyPr>
           <a:lstStyle/>
@@ -9061,7 +9195,7 @@
           <a:noFill/>
         </p:spPr>
         <p:txBody>
-          <a:bodyPr wrap="square" anchor="t" lIns="0" rIns="0" tIns="0" bIns="0">
+          <a:bodyPr wrap="square" lIns="0" tIns="0" rIns="0" bIns="0" anchor="t">
             <a:spAutoFit/>
           </a:bodyPr>
           <a:lstStyle/>
@@ -9120,6 +9254,7 @@
           <a:lstStyle/>
           <a:p>
             <a:pPr algn="ctr"/>
+            <a:endParaRPr/>
           </a:p>
         </p:txBody>
       </p:sp>
@@ -9166,6 +9301,7 @@
           <a:lstStyle/>
           <a:p>
             <a:pPr algn="ctr"/>
+            <a:endParaRPr/>
           </a:p>
         </p:txBody>
       </p:sp>
@@ -9214,6 +9350,7 @@
           <a:lstStyle/>
           <a:p>
             <a:pPr algn="ctr"/>
+            <a:endParaRPr/>
           </a:p>
         </p:txBody>
       </p:sp>
@@ -9234,7 +9371,7 @@
           <a:noFill/>
         </p:spPr>
         <p:txBody>
-          <a:bodyPr wrap="square" anchor="ctr" lIns="0" rIns="0" tIns="0" bIns="0">
+          <a:bodyPr wrap="square" lIns="0" tIns="0" rIns="0" bIns="0" anchor="ctr">
             <a:spAutoFit/>
           </a:bodyPr>
           <a:lstStyle/>
@@ -9269,7 +9406,7 @@
           <a:noFill/>
         </p:spPr>
         <p:txBody>
-          <a:bodyPr wrap="square" anchor="ctr" lIns="0" rIns="0" tIns="0" bIns="0">
+          <a:bodyPr wrap="square" lIns="0" tIns="0" rIns="0" bIns="0" anchor="ctr">
             <a:spAutoFit/>
           </a:bodyPr>
           <a:lstStyle/>
@@ -9304,7 +9441,7 @@
           <a:noFill/>
         </p:spPr>
         <p:txBody>
-          <a:bodyPr wrap="square" anchor="ctr" lIns="0" rIns="0" tIns="0" bIns="0">
+          <a:bodyPr wrap="square" lIns="0" tIns="0" rIns="0" bIns="0" anchor="ctr">
             <a:spAutoFit/>
           </a:bodyPr>
           <a:lstStyle/>
@@ -9367,6 +9504,7 @@
           <a:lstStyle/>
           <a:p>
             <a:pPr algn="ctr"/>
+            <a:endParaRPr/>
           </a:p>
         </p:txBody>
       </p:sp>
@@ -9387,7 +9525,7 @@
           <a:noFill/>
         </p:spPr>
         <p:txBody>
-          <a:bodyPr wrap="square" anchor="ctr" lIns="0" rIns="0" tIns="0" bIns="0">
+          <a:bodyPr wrap="square" lIns="0" tIns="0" rIns="0" bIns="0" anchor="ctr">
             <a:spAutoFit/>
           </a:bodyPr>
           <a:lstStyle/>
@@ -9422,7 +9560,7 @@
           <a:noFill/>
         </p:spPr>
         <p:txBody>
-          <a:bodyPr wrap="square" anchor="ctr" lIns="0" rIns="0" tIns="0" bIns="0">
+          <a:bodyPr wrap="square" lIns="0" tIns="0" rIns="0" bIns="0" anchor="ctr">
             <a:spAutoFit/>
           </a:bodyPr>
           <a:lstStyle/>
@@ -9457,7 +9595,7 @@
           <a:noFill/>
         </p:spPr>
         <p:txBody>
-          <a:bodyPr wrap="square" anchor="ctr" lIns="0" rIns="0" tIns="0" bIns="0">
+          <a:bodyPr wrap="square" lIns="0" tIns="0" rIns="0" bIns="0" anchor="ctr">
             <a:spAutoFit/>
           </a:bodyPr>
           <a:lstStyle/>
@@ -9520,6 +9658,7 @@
           <a:lstStyle/>
           <a:p>
             <a:pPr algn="ctr"/>
+            <a:endParaRPr/>
           </a:p>
         </p:txBody>
       </p:sp>
@@ -9540,7 +9679,7 @@
           <a:noFill/>
         </p:spPr>
         <p:txBody>
-          <a:bodyPr wrap="square" anchor="ctr" lIns="0" rIns="0" tIns="0" bIns="0">
+          <a:bodyPr wrap="square" lIns="0" tIns="0" rIns="0" bIns="0" anchor="ctr">
             <a:spAutoFit/>
           </a:bodyPr>
           <a:lstStyle/>
@@ -9575,7 +9714,7 @@
           <a:noFill/>
         </p:spPr>
         <p:txBody>
-          <a:bodyPr wrap="square" anchor="ctr" lIns="0" rIns="0" tIns="0" bIns="0">
+          <a:bodyPr wrap="square" lIns="0" tIns="0" rIns="0" bIns="0" anchor="ctr">
             <a:spAutoFit/>
           </a:bodyPr>
           <a:lstStyle/>
@@ -9610,7 +9749,7 @@
           <a:noFill/>
         </p:spPr>
         <p:txBody>
-          <a:bodyPr wrap="square" anchor="ctr" lIns="0" rIns="0" tIns="0" bIns="0">
+          <a:bodyPr wrap="square" lIns="0" tIns="0" rIns="0" bIns="0" anchor="ctr">
             <a:spAutoFit/>
           </a:bodyPr>
           <a:lstStyle/>
@@ -9645,7 +9784,7 @@
           <a:noFill/>
         </p:spPr>
         <p:txBody>
-          <a:bodyPr wrap="square" anchor="t" lIns="0" rIns="0" tIns="0" bIns="0">
+          <a:bodyPr wrap="square" lIns="0" tIns="0" rIns="0" bIns="0" anchor="t">
             <a:spAutoFit/>
           </a:bodyPr>
           <a:lstStyle/>
@@ -9706,6 +9845,7 @@
           <a:lstStyle/>
           <a:p>
             <a:pPr algn="ctr"/>
+            <a:endParaRPr/>
           </a:p>
         </p:txBody>
       </p:sp>
@@ -9726,7 +9866,7 @@
           <a:noFill/>
         </p:spPr>
         <p:txBody>
-          <a:bodyPr wrap="square" anchor="t" lIns="0" rIns="0" tIns="0" bIns="0">
+          <a:bodyPr wrap="square" lIns="0" tIns="0" rIns="0" bIns="0" anchor="t">
             <a:spAutoFit/>
           </a:bodyPr>
           <a:lstStyle/>
@@ -9761,7 +9901,7 @@
           <a:noFill/>
         </p:spPr>
         <p:txBody>
-          <a:bodyPr wrap="square" anchor="t" lIns="0" rIns="0" tIns="0" bIns="0">
+          <a:bodyPr wrap="square" lIns="0" tIns="0" rIns="0" bIns="0" anchor="t">
             <a:spAutoFit/>
           </a:bodyPr>
           <a:lstStyle/>
@@ -9796,7 +9936,7 @@
           <a:noFill/>
         </p:spPr>
         <p:txBody>
-          <a:bodyPr wrap="square" anchor="t" lIns="0" rIns="0" tIns="0" bIns="0">
+          <a:bodyPr wrap="square" lIns="0" tIns="0" rIns="0" bIns="0" anchor="t">
             <a:spAutoFit/>
           </a:bodyPr>
           <a:lstStyle/>
@@ -9823,7 +9963,7 @@
 </file>
 
 <file path=ppt/slides/slide7.xml><?xml version="1.0" encoding="utf-8"?>
-<p:sld xmlns:a="http://schemas.openxmlformats.org/drawingml/2006/main" xmlns:p="http://schemas.openxmlformats.org/presentationml/2006/main" xmlns:r="http://schemas.openxmlformats.org/officeDocument/2006/relationships">
+<p:sld xmlns:a="http://schemas.openxmlformats.org/drawingml/2006/main" xmlns:r="http://schemas.openxmlformats.org/officeDocument/2006/relationships" xmlns:p="http://schemas.openxmlformats.org/presentationml/2006/main">
   <p:cSld>
     <p:spTree>
       <p:nvGrpSpPr>
@@ -9831,7 +9971,14 @@
         <p:cNvGrpSpPr/>
         <p:nvPr/>
       </p:nvGrpSpPr>
-      <p:grpSpPr/>
+      <p:grpSpPr>
+        <a:xfrm>
+          <a:off x="0" y="0"/>
+          <a:ext cx="0" cy="0"/>
+          <a:chOff x="0" y="0"/>
+          <a:chExt cx="0" cy="0"/>
+        </a:xfrm>
+      </p:grpSpPr>
       <p:sp>
         <p:nvSpPr>
           <p:cNvPr id="2" name="Rectangle 1"/>
@@ -9873,6 +10020,7 @@
           <a:lstStyle/>
           <a:p>
             <a:pPr algn="ctr"/>
+            <a:endParaRPr/>
           </a:p>
         </p:txBody>
       </p:sp>
@@ -9893,7 +10041,7 @@
           <a:noFill/>
         </p:spPr>
         <p:txBody>
-          <a:bodyPr wrap="square" anchor="t" lIns="0" rIns="0" tIns="0" bIns="0">
+          <a:bodyPr wrap="square" lIns="0" tIns="0" rIns="0" bIns="0" anchor="t">
             <a:spAutoFit/>
           </a:bodyPr>
           <a:lstStyle/>
@@ -9928,7 +10076,7 @@
           <a:noFill/>
         </p:spPr>
         <p:txBody>
-          <a:bodyPr wrap="square" anchor="t" lIns="0" rIns="0" tIns="0" bIns="0">
+          <a:bodyPr wrap="square" lIns="0" tIns="0" rIns="0" bIns="0" anchor="t">
             <a:spAutoFit/>
           </a:bodyPr>
           <a:lstStyle/>
@@ -9987,6 +10135,7 @@
           <a:lstStyle/>
           <a:p>
             <a:pPr algn="ctr"/>
+            <a:endParaRPr/>
           </a:p>
         </p:txBody>
       </p:sp>
@@ -10000,7 +10149,7 @@
         </p:nvGraphicFramePr>
         <p:xfrm>
           <a:off x="868680" y="1828800"/>
-          <a:ext cx="10469880" cy="2257544512080"/>
+          <a:ext cx="10469880" cy="0"/>
         </p:xfrm>
         <a:graphic>
           <a:graphicData uri="http://schemas.openxmlformats.org/drawingml/2006/table">
@@ -10009,31 +10158,53 @@
                 <a:tableStyleId>{5C22544A-7EE6-4342-B048-85BDC9FD1C3A}</a:tableStyleId>
               </a:tblPr>
               <a:tblGrid>
-                <a:gridCol w="1554480"/>
-                <a:gridCol w="2103120"/>
-                <a:gridCol w="2468880"/>
-                <a:gridCol w="2103120"/>
-                <a:gridCol w="2240280"/>
+                <a:gridCol w="1554480">
+                  <a:extLst>
+                    <a:ext uri="{9D8B030D-6E8A-4147-A177-3AD203B41FA5}">
+                      <a16:colId xmlns:a16="http://schemas.microsoft.com/office/drawing/2014/main" val="20000"/>
+                    </a:ext>
+                  </a:extLst>
+                </a:gridCol>
+                <a:gridCol w="2103120">
+                  <a:extLst>
+                    <a:ext uri="{9D8B030D-6E8A-4147-A177-3AD203B41FA5}">
+                      <a16:colId xmlns:a16="http://schemas.microsoft.com/office/drawing/2014/main" val="20001"/>
+                    </a:ext>
+                  </a:extLst>
+                </a:gridCol>
+                <a:gridCol w="2468880">
+                  <a:extLst>
+                    <a:ext uri="{9D8B030D-6E8A-4147-A177-3AD203B41FA5}">
+                      <a16:colId xmlns:a16="http://schemas.microsoft.com/office/drawing/2014/main" val="20002"/>
+                    </a:ext>
+                  </a:extLst>
+                </a:gridCol>
+                <a:gridCol w="2103120">
+                  <a:extLst>
+                    <a:ext uri="{9D8B030D-6E8A-4147-A177-3AD203B41FA5}">
+                      <a16:colId xmlns:a16="http://schemas.microsoft.com/office/drawing/2014/main" val="20003"/>
+                    </a:ext>
+                  </a:extLst>
+                </a:gridCol>
+                <a:gridCol w="2240280">
+                  <a:extLst>
+                    <a:ext uri="{9D8B030D-6E8A-4147-A177-3AD203B41FA5}">
+                      <a16:colId xmlns:a16="http://schemas.microsoft.com/office/drawing/2014/main" val="20004"/>
+                    </a:ext>
+                  </a:extLst>
+                </a:gridCol>
               </a:tblGrid>
               <a:tr h="640080">
                 <a:tc>
                   <a:txBody>
-                    <a:bodyPr wrap="square"/>
+                    <a:bodyPr/>
                     <a:lstStyle/>
                     <a:p>
                       <a:pPr algn="ctr"/>
-                      <a:r>
-                        <a:rPr sz="1200" b="1" spc="80">
-                          <a:solidFill>
-                            <a:srgbClr val="FFFFFF"/>
-                          </a:solidFill>
-                          <a:latin typeface="Helvetica Neue"/>
-                        </a:rPr>
-                        <a:t/>
-                      </a:r>
+                      <a:endParaRPr/>
                     </a:p>
                   </a:txBody>
-                  <a:tcPr marL="137160" marR="137160" marT="45720" marB="45720" anchor="ctr">
+                  <a:tcPr marL="137160" marR="137160" anchor="ctr">
                     <a:solidFill>
                       <a:srgbClr val="2D3A5A"/>
                     </a:solidFill>
@@ -10041,7 +10212,7 @@
                 </a:tc>
                 <a:tc>
                   <a:txBody>
-                    <a:bodyPr wrap="square"/>
+                    <a:bodyPr/>
                     <a:lstStyle/>
                     <a:p>
                       <a:pPr algn="ctr"/>
@@ -10056,7 +10227,7 @@
                       </a:r>
                     </a:p>
                   </a:txBody>
-                  <a:tcPr marL="137160" marR="137160" marT="45720" marB="45720" anchor="ctr">
+                  <a:tcPr marL="137160" marR="137160" anchor="ctr">
                     <a:solidFill>
                       <a:srgbClr val="2D3A5A"/>
                     </a:solidFill>
@@ -10064,7 +10235,7 @@
                 </a:tc>
                 <a:tc>
                   <a:txBody>
-                    <a:bodyPr wrap="square"/>
+                    <a:bodyPr/>
                     <a:lstStyle/>
                     <a:p>
                       <a:pPr algn="ctr"/>
@@ -10079,7 +10250,7 @@
                       </a:r>
                     </a:p>
                   </a:txBody>
-                  <a:tcPr marL="137160" marR="137160" marT="45720" marB="45720" anchor="ctr">
+                  <a:tcPr marL="137160" marR="137160" anchor="ctr">
                     <a:solidFill>
                       <a:srgbClr val="2D3A5A"/>
                     </a:solidFill>
@@ -10087,7 +10258,7 @@
                 </a:tc>
                 <a:tc>
                   <a:txBody>
-                    <a:bodyPr wrap="square"/>
+                    <a:bodyPr/>
                     <a:lstStyle/>
                     <a:p>
                       <a:pPr algn="ctr"/>
@@ -10102,7 +10273,7 @@
                       </a:r>
                     </a:p>
                   </a:txBody>
-                  <a:tcPr marL="137160" marR="137160" marT="45720" marB="45720" anchor="ctr">
+                  <a:tcPr marL="137160" marR="137160" anchor="ctr">
                     <a:solidFill>
                       <a:srgbClr val="2D3A5A"/>
                     </a:solidFill>
@@ -10110,7 +10281,7 @@
                 </a:tc>
                 <a:tc>
                   <a:txBody>
-                    <a:bodyPr wrap="square"/>
+                    <a:bodyPr/>
                     <a:lstStyle/>
                     <a:p>
                       <a:pPr algn="ctr"/>
@@ -10125,17 +10296,22 @@
                       </a:r>
                     </a:p>
                   </a:txBody>
-                  <a:tcPr marL="137160" marR="137160" marT="45720" marB="45720" anchor="ctr">
+                  <a:tcPr marL="137160" marR="137160" anchor="ctr">
                     <a:solidFill>
                       <a:srgbClr val="EA580C"/>
                     </a:solidFill>
                   </a:tcPr>
                 </a:tc>
+                <a:extLst>
+                  <a:ext uri="{0D108BD9-81ED-4DB2-BD59-A6C34878D82A}">
+                    <a16:rowId xmlns:a16="http://schemas.microsoft.com/office/drawing/2014/main" val="10000"/>
+                  </a:ext>
+                </a:extLst>
               </a:tr>
-              <a:tr h="564385968000">
+              <a:tr h="0">
                 <a:tc>
                   <a:txBody>
-                    <a:bodyPr wrap="square"/>
+                    <a:bodyPr/>
                     <a:lstStyle/>
                     <a:p>
                       <a:pPr algn="ctr"/>
@@ -10150,7 +10326,7 @@
                       </a:r>
                     </a:p>
                   </a:txBody>
-                  <a:tcPr marL="137160" marR="137160" marT="45720" marB="45720" anchor="ctr">
+                  <a:tcPr marL="137160" marR="137160" anchor="ctr">
                     <a:solidFill>
                       <a:srgbClr val="F1EEE6"/>
                     </a:solidFill>
@@ -10158,7 +10334,7 @@
                 </a:tc>
                 <a:tc>
                   <a:txBody>
-                    <a:bodyPr wrap="square"/>
+                    <a:bodyPr/>
                     <a:lstStyle/>
                     <a:p>
                       <a:pPr algn="ctr"/>
@@ -10173,7 +10349,7 @@
                       </a:r>
                     </a:p>
                   </a:txBody>
-                  <a:tcPr marL="137160" marR="137160" marT="45720" marB="45720" anchor="ctr">
+                  <a:tcPr marL="137160" marR="137160" anchor="ctr">
                     <a:solidFill>
                       <a:srgbClr val="FFFFFF"/>
                     </a:solidFill>
@@ -10181,7 +10357,7 @@
                 </a:tc>
                 <a:tc>
                   <a:txBody>
-                    <a:bodyPr wrap="square"/>
+                    <a:bodyPr/>
                     <a:lstStyle/>
                     <a:p>
                       <a:pPr algn="ctr"/>
@@ -10196,7 +10372,7 @@
                       </a:r>
                     </a:p>
                   </a:txBody>
-                  <a:tcPr marL="137160" marR="137160" marT="45720" marB="45720" anchor="ctr">
+                  <a:tcPr marL="137160" marR="137160" anchor="ctr">
                     <a:solidFill>
                       <a:srgbClr val="FFFFFF"/>
                     </a:solidFill>
@@ -10204,7 +10380,7 @@
                 </a:tc>
                 <a:tc>
                   <a:txBody>
-                    <a:bodyPr wrap="square"/>
+                    <a:bodyPr/>
                     <a:lstStyle/>
                     <a:p>
                       <a:pPr algn="ctr"/>
@@ -10219,7 +10395,7 @@
                       </a:r>
                     </a:p>
                   </a:txBody>
-                  <a:tcPr marL="137160" marR="137160" marT="45720" marB="45720" anchor="ctr">
+                  <a:tcPr marL="137160" marR="137160" anchor="ctr">
                     <a:solidFill>
                       <a:srgbClr val="FFFFFF"/>
                     </a:solidFill>
@@ -10227,7 +10403,7 @@
                 </a:tc>
                 <a:tc>
                   <a:txBody>
-                    <a:bodyPr wrap="square"/>
+                    <a:bodyPr/>
                     <a:lstStyle/>
                     <a:p>
                       <a:pPr algn="ctr"/>
@@ -10242,17 +10418,22 @@
                       </a:r>
                     </a:p>
                   </a:txBody>
-                  <a:tcPr marL="137160" marR="137160" marT="45720" marB="45720" anchor="ctr">
+                  <a:tcPr marL="137160" marR="137160" anchor="ctr">
                     <a:solidFill>
                       <a:srgbClr val="FFFDF8"/>
                     </a:solidFill>
                   </a:tcPr>
                 </a:tc>
+                <a:extLst>
+                  <a:ext uri="{0D108BD9-81ED-4DB2-BD59-A6C34878D82A}">
+                    <a16:rowId xmlns:a16="http://schemas.microsoft.com/office/drawing/2014/main" val="10001"/>
+                  </a:ext>
+                </a:extLst>
               </a:tr>
-              <a:tr h="564385968000">
+              <a:tr h="0">
                 <a:tc>
                   <a:txBody>
-                    <a:bodyPr wrap="square"/>
+                    <a:bodyPr/>
                     <a:lstStyle/>
                     <a:p>
                       <a:pPr algn="ctr"/>
@@ -10267,7 +10448,7 @@
                       </a:r>
                     </a:p>
                   </a:txBody>
-                  <a:tcPr marL="137160" marR="137160" marT="45720" marB="45720" anchor="ctr">
+                  <a:tcPr marL="137160" marR="137160" anchor="ctr">
                     <a:solidFill>
                       <a:srgbClr val="F1EEE6"/>
                     </a:solidFill>
@@ -10275,7 +10456,7 @@
                 </a:tc>
                 <a:tc>
                   <a:txBody>
-                    <a:bodyPr wrap="square"/>
+                    <a:bodyPr/>
                     <a:lstStyle/>
                     <a:p>
                       <a:pPr algn="ctr"/>
@@ -10290,7 +10471,7 @@
                       </a:r>
                     </a:p>
                   </a:txBody>
-                  <a:tcPr marL="137160" marR="137160" marT="45720" marB="45720" anchor="ctr">
+                  <a:tcPr marL="137160" marR="137160" anchor="ctr">
                     <a:solidFill>
                       <a:srgbClr val="F1EEE6"/>
                     </a:solidFill>
@@ -10298,7 +10479,7 @@
                 </a:tc>
                 <a:tc>
                   <a:txBody>
-                    <a:bodyPr wrap="square"/>
+                    <a:bodyPr/>
                     <a:lstStyle/>
                     <a:p>
                       <a:pPr algn="ctr"/>
@@ -10313,7 +10494,7 @@
                       </a:r>
                     </a:p>
                   </a:txBody>
-                  <a:tcPr marL="137160" marR="137160" marT="45720" marB="45720" anchor="ctr">
+                  <a:tcPr marL="137160" marR="137160" anchor="ctr">
                     <a:solidFill>
                       <a:srgbClr val="F1EEE6"/>
                     </a:solidFill>
@@ -10321,7 +10502,7 @@
                 </a:tc>
                 <a:tc>
                   <a:txBody>
-                    <a:bodyPr wrap="square"/>
+                    <a:bodyPr/>
                     <a:lstStyle/>
                     <a:p>
                       <a:pPr algn="ctr"/>
@@ -10336,7 +10517,7 @@
                       </a:r>
                     </a:p>
                   </a:txBody>
-                  <a:tcPr marL="137160" marR="137160" marT="45720" marB="45720" anchor="ctr">
+                  <a:tcPr marL="137160" marR="137160" anchor="ctr">
                     <a:solidFill>
                       <a:srgbClr val="F1EEE6"/>
                     </a:solidFill>
@@ -10344,7 +10525,7 @@
                 </a:tc>
                 <a:tc>
                   <a:txBody>
-                    <a:bodyPr wrap="square"/>
+                    <a:bodyPr/>
                     <a:lstStyle/>
                     <a:p>
                       <a:pPr algn="ctr"/>
@@ -10359,17 +10540,22 @@
                       </a:r>
                     </a:p>
                   </a:txBody>
-                  <a:tcPr marL="137160" marR="137160" marT="45720" marB="45720" anchor="ctr">
+                  <a:tcPr marL="137160" marR="137160" anchor="ctr">
                     <a:solidFill>
                       <a:srgbClr val="FFFDF8"/>
                     </a:solidFill>
                   </a:tcPr>
                 </a:tc>
+                <a:extLst>
+                  <a:ext uri="{0D108BD9-81ED-4DB2-BD59-A6C34878D82A}">
+                    <a16:rowId xmlns:a16="http://schemas.microsoft.com/office/drawing/2014/main" val="10002"/>
+                  </a:ext>
+                </a:extLst>
               </a:tr>
-              <a:tr h="564385968000">
+              <a:tr h="0">
                 <a:tc>
                   <a:txBody>
-                    <a:bodyPr wrap="square"/>
+                    <a:bodyPr/>
                     <a:lstStyle/>
                     <a:p>
                       <a:pPr algn="ctr"/>
@@ -10384,7 +10570,7 @@
                       </a:r>
                     </a:p>
                   </a:txBody>
-                  <a:tcPr marL="137160" marR="137160" marT="45720" marB="45720" anchor="ctr">
+                  <a:tcPr marL="137160" marR="137160" anchor="ctr">
                     <a:solidFill>
                       <a:srgbClr val="F1EEE6"/>
                     </a:solidFill>
@@ -10392,7 +10578,7 @@
                 </a:tc>
                 <a:tc>
                   <a:txBody>
-                    <a:bodyPr wrap="square"/>
+                    <a:bodyPr/>
                     <a:lstStyle/>
                     <a:p>
                       <a:pPr algn="ctr"/>
@@ -10407,7 +10593,7 @@
                       </a:r>
                     </a:p>
                   </a:txBody>
-                  <a:tcPr marL="137160" marR="137160" marT="45720" marB="45720" anchor="ctr">
+                  <a:tcPr marL="137160" marR="137160" anchor="ctr">
                     <a:solidFill>
                       <a:srgbClr val="FFFFFF"/>
                     </a:solidFill>
@@ -10415,7 +10601,7 @@
                 </a:tc>
                 <a:tc>
                   <a:txBody>
-                    <a:bodyPr wrap="square"/>
+                    <a:bodyPr/>
                     <a:lstStyle/>
                     <a:p>
                       <a:pPr algn="ctr"/>
@@ -10430,7 +10616,7 @@
                       </a:r>
                     </a:p>
                   </a:txBody>
-                  <a:tcPr marL="137160" marR="137160" marT="45720" marB="45720" anchor="ctr">
+                  <a:tcPr marL="137160" marR="137160" anchor="ctr">
                     <a:solidFill>
                       <a:srgbClr val="FFFFFF"/>
                     </a:solidFill>
@@ -10438,7 +10624,7 @@
                 </a:tc>
                 <a:tc>
                   <a:txBody>
-                    <a:bodyPr wrap="square"/>
+                    <a:bodyPr/>
                     <a:lstStyle/>
                     <a:p>
                       <a:pPr algn="ctr"/>
@@ -10453,7 +10639,7 @@
                       </a:r>
                     </a:p>
                   </a:txBody>
-                  <a:tcPr marL="137160" marR="137160" marT="45720" marB="45720" anchor="ctr">
+                  <a:tcPr marL="137160" marR="137160" anchor="ctr">
                     <a:solidFill>
                       <a:srgbClr val="FFFFFF"/>
                     </a:solidFill>
@@ -10461,7 +10647,7 @@
                 </a:tc>
                 <a:tc>
                   <a:txBody>
-                    <a:bodyPr wrap="square"/>
+                    <a:bodyPr/>
                     <a:lstStyle/>
                     <a:p>
                       <a:pPr algn="ctr"/>
@@ -10476,17 +10662,22 @@
                       </a:r>
                     </a:p>
                   </a:txBody>
-                  <a:tcPr marL="137160" marR="137160" marT="45720" marB="45720" anchor="ctr">
+                  <a:tcPr marL="137160" marR="137160" anchor="ctr">
                     <a:solidFill>
                       <a:srgbClr val="FFFDF8"/>
                     </a:solidFill>
                   </a:tcPr>
                 </a:tc>
+                <a:extLst>
+                  <a:ext uri="{0D108BD9-81ED-4DB2-BD59-A6C34878D82A}">
+                    <a16:rowId xmlns:a16="http://schemas.microsoft.com/office/drawing/2014/main" val="10003"/>
+                  </a:ext>
+                </a:extLst>
               </a:tr>
-              <a:tr h="564385968000">
+              <a:tr h="0">
                 <a:tc>
                   <a:txBody>
-                    <a:bodyPr wrap="square"/>
+                    <a:bodyPr/>
                     <a:lstStyle/>
                     <a:p>
                       <a:pPr algn="ctr"/>
@@ -10501,7 +10692,7 @@
                       </a:r>
                     </a:p>
                   </a:txBody>
-                  <a:tcPr marL="137160" marR="137160" marT="45720" marB="45720" anchor="ctr">
+                  <a:tcPr marL="137160" marR="137160" anchor="ctr">
                     <a:solidFill>
                       <a:srgbClr val="F1EEE6"/>
                     </a:solidFill>
@@ -10509,7 +10700,7 @@
                 </a:tc>
                 <a:tc>
                   <a:txBody>
-                    <a:bodyPr wrap="square"/>
+                    <a:bodyPr/>
                     <a:lstStyle/>
                     <a:p>
                       <a:pPr algn="ctr"/>
@@ -10524,7 +10715,7 @@
                       </a:r>
                     </a:p>
                   </a:txBody>
-                  <a:tcPr marL="137160" marR="137160" marT="45720" marB="45720" anchor="ctr">
+                  <a:tcPr marL="137160" marR="137160" anchor="ctr">
                     <a:solidFill>
                       <a:srgbClr val="F1EEE6"/>
                     </a:solidFill>
@@ -10532,7 +10723,7 @@
                 </a:tc>
                 <a:tc>
                   <a:txBody>
-                    <a:bodyPr wrap="square"/>
+                    <a:bodyPr/>
                     <a:lstStyle/>
                     <a:p>
                       <a:pPr algn="ctr"/>
@@ -10547,7 +10738,7 @@
                       </a:r>
                     </a:p>
                   </a:txBody>
-                  <a:tcPr marL="137160" marR="137160" marT="45720" marB="45720" anchor="ctr">
+                  <a:tcPr marL="137160" marR="137160" anchor="ctr">
                     <a:solidFill>
                       <a:srgbClr val="F1EEE6"/>
                     </a:solidFill>
@@ -10555,7 +10746,7 @@
                 </a:tc>
                 <a:tc>
                   <a:txBody>
-                    <a:bodyPr wrap="square"/>
+                    <a:bodyPr/>
                     <a:lstStyle/>
                     <a:p>
                       <a:pPr algn="ctr"/>
@@ -10570,7 +10761,7 @@
                       </a:r>
                     </a:p>
                   </a:txBody>
-                  <a:tcPr marL="137160" marR="137160" marT="45720" marB="45720" anchor="ctr">
+                  <a:tcPr marL="137160" marR="137160" anchor="ctr">
                     <a:solidFill>
                       <a:srgbClr val="F1EEE6"/>
                     </a:solidFill>
@@ -10578,7 +10769,7 @@
                 </a:tc>
                 <a:tc>
                   <a:txBody>
-                    <a:bodyPr wrap="square"/>
+                    <a:bodyPr/>
                     <a:lstStyle/>
                     <a:p>
                       <a:pPr algn="ctr"/>
@@ -10593,12 +10784,17 @@
                       </a:r>
                     </a:p>
                   </a:txBody>
-                  <a:tcPr marL="137160" marR="137160" marT="45720" marB="45720" anchor="ctr">
+                  <a:tcPr marL="137160" marR="137160" anchor="ctr">
                     <a:solidFill>
                       <a:srgbClr val="FFFDF8"/>
                     </a:solidFill>
                   </a:tcPr>
                 </a:tc>
+                <a:extLst>
+                  <a:ext uri="{0D108BD9-81ED-4DB2-BD59-A6C34878D82A}">
+                    <a16:rowId xmlns:a16="http://schemas.microsoft.com/office/drawing/2014/main" val="10004"/>
+                  </a:ext>
+                </a:extLst>
               </a:tr>
             </a:tbl>
           </a:graphicData>
@@ -10647,6 +10843,7 @@
           <a:lstStyle/>
           <a:p>
             <a:pPr algn="ctr"/>
+            <a:endParaRPr/>
           </a:p>
         </p:txBody>
       </p:sp>
@@ -10695,6 +10892,7 @@
           <a:lstStyle/>
           <a:p>
             <a:pPr algn="ctr"/>
+            <a:endParaRPr/>
           </a:p>
         </p:txBody>
       </p:sp>
@@ -10715,7 +10913,7 @@
           <a:noFill/>
         </p:spPr>
         <p:txBody>
-          <a:bodyPr wrap="square" anchor="t" lIns="0" rIns="0" tIns="0" bIns="0">
+          <a:bodyPr wrap="square" lIns="0" tIns="0" rIns="0" bIns="0" anchor="t">
             <a:spAutoFit/>
           </a:bodyPr>
           <a:lstStyle/>
@@ -10750,7 +10948,7 @@
           <a:noFill/>
         </p:spPr>
         <p:txBody>
-          <a:bodyPr wrap="square" anchor="t" lIns="0" rIns="0" tIns="0" bIns="0">
+          <a:bodyPr wrap="square" lIns="0" tIns="0" rIns="0" bIns="0" anchor="t">
             <a:spAutoFit/>
           </a:bodyPr>
           <a:lstStyle/>
@@ -10811,6 +11009,7 @@
           <a:lstStyle/>
           <a:p>
             <a:pPr algn="ctr"/>
+            <a:endParaRPr/>
           </a:p>
         </p:txBody>
       </p:sp>
@@ -10831,7 +11030,7 @@
           <a:noFill/>
         </p:spPr>
         <p:txBody>
-          <a:bodyPr wrap="square" anchor="t" lIns="0" rIns="0" tIns="0" bIns="0">
+          <a:bodyPr wrap="square" lIns="0" tIns="0" rIns="0" bIns="0" anchor="t">
             <a:spAutoFit/>
           </a:bodyPr>
           <a:lstStyle/>
@@ -10866,7 +11065,7 @@
           <a:noFill/>
         </p:spPr>
         <p:txBody>
-          <a:bodyPr wrap="square" anchor="t" lIns="0" rIns="0" tIns="0" bIns="0">
+          <a:bodyPr wrap="square" lIns="0" tIns="0" rIns="0" bIns="0" anchor="t">
             <a:spAutoFit/>
           </a:bodyPr>
           <a:lstStyle/>
@@ -10901,7 +11100,7 @@
           <a:noFill/>
         </p:spPr>
         <p:txBody>
-          <a:bodyPr wrap="square" anchor="t" lIns="0" rIns="0" tIns="0" bIns="0">
+          <a:bodyPr wrap="square" lIns="0" tIns="0" rIns="0" bIns="0" anchor="t">
             <a:spAutoFit/>
           </a:bodyPr>
           <a:lstStyle/>
@@ -10928,7 +11127,7 @@
 </file>
 
 <file path=ppt/slides/slide8.xml><?xml version="1.0" encoding="utf-8"?>
-<p:sld xmlns:a="http://schemas.openxmlformats.org/drawingml/2006/main" xmlns:p="http://schemas.openxmlformats.org/presentationml/2006/main" xmlns:r="http://schemas.openxmlformats.org/officeDocument/2006/relationships">
+<p:sld xmlns:a="http://schemas.openxmlformats.org/drawingml/2006/main" xmlns:r="http://schemas.openxmlformats.org/officeDocument/2006/relationships" xmlns:p="http://schemas.openxmlformats.org/presentationml/2006/main">
   <p:cSld>
     <p:spTree>
       <p:nvGrpSpPr>
@@ -10936,7 +11135,14 @@
         <p:cNvGrpSpPr/>
         <p:nvPr/>
       </p:nvGrpSpPr>
-      <p:grpSpPr/>
+      <p:grpSpPr>
+        <a:xfrm>
+          <a:off x="0" y="0"/>
+          <a:ext cx="0" cy="0"/>
+          <a:chOff x="0" y="0"/>
+          <a:chExt cx="0" cy="0"/>
+        </a:xfrm>
+      </p:grpSpPr>
       <p:sp>
         <p:nvSpPr>
           <p:cNvPr id="2" name="Rectangle 1"/>
@@ -10978,6 +11184,7 @@
           <a:lstStyle/>
           <a:p>
             <a:pPr algn="ctr"/>
+            <a:endParaRPr/>
           </a:p>
         </p:txBody>
       </p:sp>
@@ -10998,7 +11205,7 @@
           <a:noFill/>
         </p:spPr>
         <p:txBody>
-          <a:bodyPr wrap="square" anchor="t" lIns="0" rIns="0" tIns="0" bIns="0">
+          <a:bodyPr wrap="square" lIns="0" tIns="0" rIns="0" bIns="0" anchor="t">
             <a:spAutoFit/>
           </a:bodyPr>
           <a:lstStyle/>
@@ -11033,7 +11240,7 @@
           <a:noFill/>
         </p:spPr>
         <p:txBody>
-          <a:bodyPr wrap="square" anchor="t" lIns="0" rIns="0" tIns="0" bIns="0">
+          <a:bodyPr wrap="square" lIns="0" tIns="0" rIns="0" bIns="0" anchor="t">
             <a:spAutoFit/>
           </a:bodyPr>
           <a:lstStyle/>
@@ -11092,6 +11299,7 @@
           <a:lstStyle/>
           <a:p>
             <a:pPr algn="ctr"/>
+            <a:endParaRPr/>
           </a:p>
         </p:txBody>
       </p:sp>
@@ -11138,6 +11346,7 @@
           <a:lstStyle/>
           <a:p>
             <a:pPr algn="ctr"/>
+            <a:endParaRPr/>
           </a:p>
         </p:txBody>
       </p:sp>
@@ -11186,6 +11395,7 @@
           <a:lstStyle/>
           <a:p>
             <a:pPr algn="ctr"/>
+            <a:endParaRPr/>
           </a:p>
         </p:txBody>
       </p:sp>
@@ -11206,7 +11416,7 @@
           <a:noFill/>
         </p:spPr>
         <p:txBody>
-          <a:bodyPr wrap="square" anchor="t" lIns="0" rIns="0" tIns="0" bIns="0">
+          <a:bodyPr wrap="square" lIns="0" tIns="0" rIns="0" bIns="0" anchor="t">
             <a:spAutoFit/>
           </a:bodyPr>
           <a:lstStyle/>
@@ -11241,7 +11451,7 @@
           <a:noFill/>
         </p:spPr>
         <p:txBody>
-          <a:bodyPr wrap="square" anchor="ctr" lIns="0" rIns="0" tIns="0" bIns="0">
+          <a:bodyPr wrap="square" lIns="0" tIns="0" rIns="0" bIns="0" anchor="ctr">
             <a:spAutoFit/>
           </a:bodyPr>
           <a:lstStyle/>
@@ -11280,7 +11490,7 @@
           <a:noFill/>
         </p:spPr>
         <p:txBody>
-          <a:bodyPr wrap="square" anchor="t" lIns="0" rIns="0" tIns="0" bIns="0">
+          <a:bodyPr wrap="square" lIns="0" tIns="0" rIns="0" bIns="0" anchor="t">
             <a:spAutoFit/>
           </a:bodyPr>
           <a:lstStyle/>
@@ -11347,6 +11557,7 @@
           <a:lstStyle/>
           <a:p>
             <a:pPr algn="ctr"/>
+            <a:endParaRPr/>
           </a:p>
         </p:txBody>
       </p:sp>
@@ -11367,7 +11578,7 @@
           <a:noFill/>
         </p:spPr>
         <p:txBody>
-          <a:bodyPr wrap="square" anchor="t" lIns="0" rIns="0" tIns="0" bIns="0">
+          <a:bodyPr wrap="square" lIns="0" tIns="0" rIns="0" bIns="0" anchor="t">
             <a:spAutoFit/>
           </a:bodyPr>
           <a:lstStyle/>
@@ -11402,7 +11613,7 @@
           <a:noFill/>
         </p:spPr>
         <p:txBody>
-          <a:bodyPr wrap="square" anchor="ctr" lIns="0" rIns="0" tIns="0" bIns="0">
+          <a:bodyPr wrap="square" lIns="0" tIns="0" rIns="0" bIns="0" anchor="ctr">
             <a:spAutoFit/>
           </a:bodyPr>
           <a:lstStyle/>
@@ -11441,7 +11652,7 @@
           <a:noFill/>
         </p:spPr>
         <p:txBody>
-          <a:bodyPr wrap="square" anchor="t" lIns="0" rIns="0" tIns="0" bIns="0">
+          <a:bodyPr wrap="square" lIns="0" tIns="0" rIns="0" bIns="0" anchor="t">
             <a:spAutoFit/>
           </a:bodyPr>
           <a:lstStyle/>
@@ -11508,6 +11719,7 @@
           <a:lstStyle/>
           <a:p>
             <a:pPr algn="ctr"/>
+            <a:endParaRPr/>
           </a:p>
         </p:txBody>
       </p:sp>
@@ -11528,7 +11740,7 @@
           <a:noFill/>
         </p:spPr>
         <p:txBody>
-          <a:bodyPr wrap="square" anchor="t" lIns="0" rIns="0" tIns="0" bIns="0">
+          <a:bodyPr wrap="square" lIns="0" tIns="0" rIns="0" bIns="0" anchor="t">
             <a:spAutoFit/>
           </a:bodyPr>
           <a:lstStyle/>
@@ -11563,7 +11775,7 @@
           <a:noFill/>
         </p:spPr>
         <p:txBody>
-          <a:bodyPr wrap="square" anchor="ctr" lIns="0" rIns="0" tIns="0" bIns="0">
+          <a:bodyPr wrap="square" lIns="0" tIns="0" rIns="0" bIns="0" anchor="ctr">
             <a:spAutoFit/>
           </a:bodyPr>
           <a:lstStyle/>
@@ -11602,7 +11814,7 @@
           <a:noFill/>
         </p:spPr>
         <p:txBody>
-          <a:bodyPr wrap="square" anchor="t" lIns="0" rIns="0" tIns="0" bIns="0">
+          <a:bodyPr wrap="square" lIns="0" tIns="0" rIns="0" bIns="0" anchor="t">
             <a:spAutoFit/>
           </a:bodyPr>
           <a:lstStyle/>
@@ -11669,6 +11881,7 @@
           <a:lstStyle/>
           <a:p>
             <a:pPr algn="ctr"/>
+            <a:endParaRPr/>
           </a:p>
         </p:txBody>
       </p:sp>
@@ -11689,7 +11902,7 @@
           <a:noFill/>
         </p:spPr>
         <p:txBody>
-          <a:bodyPr wrap="square" anchor="t" lIns="0" rIns="0" tIns="0" bIns="0">
+          <a:bodyPr wrap="square" lIns="0" tIns="0" rIns="0" bIns="0" anchor="t">
             <a:spAutoFit/>
           </a:bodyPr>
           <a:lstStyle/>
@@ -11724,7 +11937,7 @@
           <a:noFill/>
         </p:spPr>
         <p:txBody>
-          <a:bodyPr wrap="square" anchor="ctr" lIns="0" rIns="0" tIns="0" bIns="0">
+          <a:bodyPr wrap="square" lIns="0" tIns="0" rIns="0" bIns="0" anchor="ctr">
             <a:spAutoFit/>
           </a:bodyPr>
           <a:lstStyle/>
@@ -11779,7 +11992,7 @@
           <a:noFill/>
         </p:spPr>
         <p:txBody>
-          <a:bodyPr wrap="square" anchor="t" lIns="0" rIns="0" tIns="0" bIns="0">
+          <a:bodyPr wrap="square" lIns="0" tIns="0" rIns="0" bIns="0" anchor="t">
             <a:spAutoFit/>
           </a:bodyPr>
           <a:lstStyle/>
@@ -11818,7 +12031,7 @@
           <a:noFill/>
         </p:spPr>
         <p:txBody>
-          <a:bodyPr wrap="square" anchor="t" lIns="0" rIns="0" tIns="0" bIns="0">
+          <a:bodyPr wrap="square" lIns="0" tIns="0" rIns="0" bIns="0" anchor="t">
             <a:spAutoFit/>
           </a:bodyPr>
           <a:lstStyle/>
@@ -11879,6 +12092,7 @@
           <a:lstStyle/>
           <a:p>
             <a:pPr algn="ctr"/>
+            <a:endParaRPr/>
           </a:p>
         </p:txBody>
       </p:sp>
@@ -11899,7 +12113,7 @@
           <a:noFill/>
         </p:spPr>
         <p:txBody>
-          <a:bodyPr wrap="square" anchor="t" lIns="0" rIns="0" tIns="0" bIns="0">
+          <a:bodyPr wrap="square" lIns="0" tIns="0" rIns="0" bIns="0" anchor="t">
             <a:spAutoFit/>
           </a:bodyPr>
           <a:lstStyle/>
@@ -11934,7 +12148,7 @@
           <a:noFill/>
         </p:spPr>
         <p:txBody>
-          <a:bodyPr wrap="square" anchor="t" lIns="0" rIns="0" tIns="0" bIns="0">
+          <a:bodyPr wrap="square" lIns="0" tIns="0" rIns="0" bIns="0" anchor="t">
             <a:spAutoFit/>
           </a:bodyPr>
           <a:lstStyle/>
@@ -11969,7 +12183,7 @@
           <a:noFill/>
         </p:spPr>
         <p:txBody>
-          <a:bodyPr wrap="square" anchor="t" lIns="0" rIns="0" tIns="0" bIns="0">
+          <a:bodyPr wrap="square" lIns="0" tIns="0" rIns="0" bIns="0" anchor="t">
             <a:spAutoFit/>
           </a:bodyPr>
           <a:lstStyle/>
@@ -11996,7 +12210,7 @@
 </file>
 
 <file path=ppt/slides/slide9.xml><?xml version="1.0" encoding="utf-8"?>
-<p:sld xmlns:a="http://schemas.openxmlformats.org/drawingml/2006/main" xmlns:p="http://schemas.openxmlformats.org/presentationml/2006/main" xmlns:r="http://schemas.openxmlformats.org/officeDocument/2006/relationships">
+<p:sld xmlns:a="http://schemas.openxmlformats.org/drawingml/2006/main" xmlns:r="http://schemas.openxmlformats.org/officeDocument/2006/relationships" xmlns:p="http://schemas.openxmlformats.org/presentationml/2006/main">
   <p:cSld>
     <p:spTree>
       <p:nvGrpSpPr>
@@ -12004,7 +12218,14 @@
         <p:cNvGrpSpPr/>
         <p:nvPr/>
       </p:nvGrpSpPr>
-      <p:grpSpPr/>
+      <p:grpSpPr>
+        <a:xfrm>
+          <a:off x="0" y="0"/>
+          <a:ext cx="0" cy="0"/>
+          <a:chOff x="0" y="0"/>
+          <a:chExt cx="0" cy="0"/>
+        </a:xfrm>
+      </p:grpSpPr>
       <p:sp>
         <p:nvSpPr>
           <p:cNvPr id="2" name="Rectangle 1"/>
@@ -12046,6 +12267,7 @@
           <a:lstStyle/>
           <a:p>
             <a:pPr algn="ctr"/>
+            <a:endParaRPr/>
           </a:p>
         </p:txBody>
       </p:sp>
@@ -12066,7 +12288,7 @@
           <a:noFill/>
         </p:spPr>
         <p:txBody>
-          <a:bodyPr wrap="square" anchor="t" lIns="0" rIns="0" tIns="0" bIns="0">
+          <a:bodyPr wrap="square" lIns="0" tIns="0" rIns="0" bIns="0" anchor="t">
             <a:spAutoFit/>
           </a:bodyPr>
           <a:lstStyle/>
@@ -12101,7 +12323,7 @@
           <a:noFill/>
         </p:spPr>
         <p:txBody>
-          <a:bodyPr wrap="square" anchor="t" lIns="0" rIns="0" tIns="0" bIns="0">
+          <a:bodyPr wrap="square" lIns="0" tIns="0" rIns="0" bIns="0" anchor="t">
             <a:spAutoFit/>
           </a:bodyPr>
           <a:lstStyle/>
@@ -12160,6 +12382,7 @@
           <a:lstStyle/>
           <a:p>
             <a:pPr algn="ctr"/>
+            <a:endParaRPr/>
           </a:p>
         </p:txBody>
       </p:sp>
@@ -12208,6 +12431,7 @@
           <a:lstStyle/>
           <a:p>
             <a:pPr algn="ctr"/>
+            <a:endParaRPr/>
           </a:p>
         </p:txBody>
       </p:sp>
@@ -12254,6 +12478,7 @@
           <a:lstStyle/>
           <a:p>
             <a:pPr algn="ctr"/>
+            <a:endParaRPr/>
           </a:p>
         </p:txBody>
       </p:sp>
@@ -12274,7 +12499,7 @@
           <a:noFill/>
         </p:spPr>
         <p:txBody>
-          <a:bodyPr wrap="square" anchor="ctr" lIns="0" rIns="0" tIns="0" bIns="0">
+          <a:bodyPr wrap="square" lIns="0" tIns="0" rIns="0" bIns="0" anchor="ctr">
             <a:spAutoFit/>
           </a:bodyPr>
           <a:lstStyle/>
@@ -12309,7 +12534,7 @@
           <a:noFill/>
         </p:spPr>
         <p:txBody>
-          <a:bodyPr wrap="square" anchor="t" lIns="0" rIns="0" tIns="0" bIns="0">
+          <a:bodyPr wrap="square" lIns="0" tIns="0" rIns="0" bIns="0" anchor="t">
             <a:spAutoFit/>
           </a:bodyPr>
           <a:lstStyle/>
@@ -12344,7 +12569,7 @@
           <a:noFill/>
         </p:spPr>
         <p:txBody>
-          <a:bodyPr wrap="square" anchor="t" lIns="0" rIns="0" tIns="0" bIns="0">
+          <a:bodyPr wrap="square" lIns="0" tIns="0" rIns="0" bIns="0" anchor="t">
             <a:spAutoFit/>
           </a:bodyPr>
           <a:lstStyle/>
@@ -12403,6 +12628,7 @@
           <a:lstStyle/>
           <a:p>
             <a:pPr algn="ctr"/>
+            <a:endParaRPr/>
           </a:p>
         </p:txBody>
       </p:sp>
@@ -12423,7 +12649,7 @@
           <a:noFill/>
         </p:spPr>
         <p:txBody>
-          <a:bodyPr wrap="square" anchor="t" lIns="0" rIns="0" tIns="0" bIns="0">
+          <a:bodyPr wrap="square" lIns="0" tIns="0" rIns="0" bIns="0" anchor="t">
             <a:spAutoFit/>
           </a:bodyPr>
           <a:lstStyle/>
@@ -12522,6 +12748,7 @@
           <a:lstStyle/>
           <a:p>
             <a:pPr algn="ctr"/>
+            <a:endParaRPr/>
           </a:p>
         </p:txBody>
       </p:sp>
@@ -12568,6 +12795,7 @@
           <a:lstStyle/>
           <a:p>
             <a:pPr algn="ctr"/>
+            <a:endParaRPr/>
           </a:p>
         </p:txBody>
       </p:sp>
@@ -12588,7 +12816,7 @@
           <a:noFill/>
         </p:spPr>
         <p:txBody>
-          <a:bodyPr wrap="square" anchor="ctr" lIns="0" rIns="0" tIns="0" bIns="0">
+          <a:bodyPr wrap="square" lIns="0" tIns="0" rIns="0" bIns="0" anchor="ctr">
             <a:spAutoFit/>
           </a:bodyPr>
           <a:lstStyle/>
@@ -12623,7 +12851,7 @@
           <a:noFill/>
         </p:spPr>
         <p:txBody>
-          <a:bodyPr wrap="square" anchor="t" lIns="0" rIns="0" tIns="0" bIns="0">
+          <a:bodyPr wrap="square" lIns="0" tIns="0" rIns="0" bIns="0" anchor="t">
             <a:spAutoFit/>
           </a:bodyPr>
           <a:lstStyle/>
@@ -12658,7 +12886,7 @@
           <a:noFill/>
         </p:spPr>
         <p:txBody>
-          <a:bodyPr wrap="square" anchor="t" lIns="0" rIns="0" tIns="0" bIns="0">
+          <a:bodyPr wrap="square" lIns="0" tIns="0" rIns="0" bIns="0" anchor="t">
             <a:spAutoFit/>
           </a:bodyPr>
           <a:lstStyle/>
@@ -12717,6 +12945,7 @@
           <a:lstStyle/>
           <a:p>
             <a:pPr algn="ctr"/>
+            <a:endParaRPr/>
           </a:p>
         </p:txBody>
       </p:sp>
@@ -12737,7 +12966,7 @@
           <a:noFill/>
         </p:spPr>
         <p:txBody>
-          <a:bodyPr wrap="square" anchor="t" lIns="0" rIns="0" tIns="0" bIns="0">
+          <a:bodyPr wrap="square" lIns="0" tIns="0" rIns="0" bIns="0" anchor="t">
             <a:spAutoFit/>
           </a:bodyPr>
           <a:lstStyle/>
@@ -12818,6 +13047,7 @@
           <a:lstStyle/>
           <a:p>
             <a:pPr algn="ctr"/>
+            <a:endParaRPr/>
           </a:p>
         </p:txBody>
       </p:sp>
@@ -12838,7 +13068,7 @@
           <a:noFill/>
         </p:spPr>
         <p:txBody>
-          <a:bodyPr wrap="square" anchor="t" lIns="0" rIns="0" tIns="0" bIns="0">
+          <a:bodyPr wrap="square" lIns="0" tIns="0" rIns="0" bIns="0" anchor="t">
             <a:spAutoFit/>
           </a:bodyPr>
           <a:lstStyle/>
@@ -12873,7 +13103,7 @@
           <a:noFill/>
         </p:spPr>
         <p:txBody>
-          <a:bodyPr wrap="square" anchor="t" lIns="0" rIns="0" tIns="0" bIns="0">
+          <a:bodyPr wrap="square" lIns="0" tIns="0" rIns="0" bIns="0" anchor="t">
             <a:spAutoFit/>
           </a:bodyPr>
           <a:lstStyle/>
@@ -12908,7 +13138,7 @@
           <a:noFill/>
         </p:spPr>
         <p:txBody>
-          <a:bodyPr wrap="square" anchor="t" lIns="0" rIns="0" tIns="0" bIns="0">
+          <a:bodyPr wrap="square" lIns="0" tIns="0" rIns="0" bIns="0" anchor="t">
             <a:spAutoFit/>
           </a:bodyPr>
           <a:lstStyle/>

</xml_diff>